<commit_message>
fix(G6-03): align defense status and sources with latest C review
</commit_message>
<xml_diff>
--- a/docs/deliverables/G6/G6-03-验收答辩候选.pptx
+++ b/docs/deliverables/G6/G6-03-验收答辩候选.pptx
@@ -203,9 +203,9 @@
             </a:lvl1pPr>
           </a:lstStyle>
           <a:p>
-            <a:fld id="{2CBBBCA4-16D4-4191-BDA9-6F24168B41B5}" type="datetimeFigureOut">
+            <a:fld id="{58B2BA98-EB1A-4DA6-9B55-2AAE6ADBFAB5}" type="datetimeFigureOut">
               <a:rPr lang="zh-CN" altLang="en-US" smtClean="0"/>
-              <a:t>2026/10/11</a:t>
+              <a:t>2026/10/12</a:t>
             </a:fld>
             <a:endParaRPr lang="zh-CN" altLang="en-US"/>
           </a:p>
@@ -361,7 +361,7 @@
             </a:lvl1pPr>
           </a:lstStyle>
           <a:p>
-            <a:fld id="{4D1E7FFA-7EBE-4257-AFCA-48BD069FC2F6}" type="slidenum">
+            <a:fld id="{9E96E106-DC41-4082-98AA-5BCDE38605D0}" type="slidenum">
               <a:rPr lang="zh-CN" altLang="en-US" smtClean="0"/>
               <a:t>‹#›</a:t>
             </a:fld>
@@ -372,7 +372,7 @@
     </p:spTree>
     <p:extLst>
       <p:ext uri="{BB962C8B-B14F-4D97-AF65-F5344CB8AC3E}">
-        <p14:creationId xmlns:p14="http://schemas.microsoft.com/office/powerpoint/2010/main" val="3768743649"/>
+        <p14:creationId xmlns:p14="http://schemas.microsoft.com/office/powerpoint/2010/main" val="404798117"/>
       </p:ext>
     </p:extLst>
   </p:cSld>
@@ -558,7 +558,31 @@
             </a:r>
             <a:r>
               <a:rPr lang="zh-CN" altLang="en-US"/>
-              <a:t>整体复核待完成，真实项目验收继续延期。</a:t>
+              <a:t>复核</a:t>
+            </a:r>
+            <a:r>
+              <a:rPr lang="en-US" altLang="zh-CN"/>
+              <a:t>CHANGES_REQUIRED</a:t>
+            </a:r>
+            <a:r>
+              <a:rPr lang="zh-CN" altLang="en-US"/>
+              <a:t>；状态</a:t>
+            </a:r>
+            <a:r>
+              <a:rPr lang="en-US" altLang="zh-CN"/>
+              <a:t>/</a:t>
+            </a:r>
+            <a:r>
+              <a:rPr lang="zh-CN" altLang="en-US"/>
+              <a:t>来源已整改，待</a:t>
+            </a:r>
+            <a:r>
+              <a:rPr lang="en-US" altLang="zh-CN"/>
+              <a:t>C</a:t>
+            </a:r>
+            <a:r>
+              <a:rPr lang="zh-CN" altLang="en-US"/>
+              <a:t>定向复验；真实项目验收继续延期。</a:t>
             </a:r>
           </a:p>
           <a:p>
@@ -590,6 +614,30 @@
           </a:p>
           <a:p>
             <a:r>
+              <a:rPr lang="en-US" altLang="zh-CN"/>
+              <a:t>docs/work/G6/G6-01_A_rereview.md</a:t>
+            </a:r>
+          </a:p>
+          <a:p>
+            <a:r>
+              <a:rPr lang="en-US" altLang="zh-CN"/>
+              <a:t>docs/work/G6/G6-02_A_rereview.md</a:t>
+            </a:r>
+          </a:p>
+          <a:p>
+            <a:r>
+              <a:rPr lang="en-US" altLang="zh-CN"/>
+              <a:t>logs/reviews/2026-10-12_G6-03-C-review.md</a:t>
+            </a:r>
+          </a:p>
+          <a:p>
+            <a:r>
+              <a:rPr lang="en-US" altLang="zh-CN"/>
+              <a:t>evidence/g6/G6-03/C-review/review-result.json</a:t>
+            </a:r>
+          </a:p>
+          <a:p>
+            <a:r>
               <a:rPr lang="zh-CN" altLang="en-US"/>
               <a:t>截图版本：</a:t>
             </a:r>
@@ -605,7 +653,7 @@
             </a:r>
             <a:r>
               <a:rPr lang="en-US" altLang="zh-CN"/>
-              <a:t>COURSE_SIMULATED_REHEARSAL / REAL_WORLD_DEFERRED / C_PENDING_REVIEW</a:t>
+              <a:t>COURSE_SIMULATED_REHEARSAL / REAL_WORLD_DEFERRED / C_CHANGES_REQUIRED_PENDING_TARGETED_REREVIEW</a:t>
             </a:r>
             <a:endParaRPr lang="zh-CN" altLang="en-US"/>
           </a:p>
@@ -626,7 +674,7 @@
           <a:bodyPr/>
           <a:lstStyle/>
           <a:p>
-            <a:fld id="{4D1E7FFA-7EBE-4257-AFCA-48BD069FC2F6}" type="slidenum">
+            <a:fld id="{9E96E106-DC41-4082-98AA-5BCDE38605D0}" type="slidenum">
               <a:rPr lang="zh-CN" altLang="en-US" smtClean="0"/>
               <a:t>1</a:t>
             </a:fld>
@@ -637,7 +685,7 @@
     </p:spTree>
     <p:extLst>
       <p:ext uri="{BB962C8B-B14F-4D97-AF65-F5344CB8AC3E}">
-        <p14:creationId xmlns:p14="http://schemas.microsoft.com/office/powerpoint/2010/main" val="2446726529"/>
+        <p14:creationId xmlns:p14="http://schemas.microsoft.com/office/powerpoint/2010/main" val="2280061474"/>
       </p:ext>
     </p:extLst>
   </p:cSld>
@@ -749,6 +797,30 @@
           </a:p>
           <a:p>
             <a:r>
+              <a:rPr lang="en-US" altLang="zh-CN"/>
+              <a:t>docs/work/G6/G6-01_A_rereview.md</a:t>
+            </a:r>
+          </a:p>
+          <a:p>
+            <a:r>
+              <a:rPr lang="en-US" altLang="zh-CN"/>
+              <a:t>docs/work/G6/G6-02_A_rereview.md</a:t>
+            </a:r>
+          </a:p>
+          <a:p>
+            <a:r>
+              <a:rPr lang="en-US" altLang="zh-CN"/>
+              <a:t>logs/reviews/2026-10-12_G6-03-C-review.md</a:t>
+            </a:r>
+          </a:p>
+          <a:p>
+            <a:r>
+              <a:rPr lang="en-US" altLang="zh-CN"/>
+              <a:t>evidence/g6/G6-03/C-review/review-result.json</a:t>
+            </a:r>
+          </a:p>
+          <a:p>
+            <a:r>
               <a:rPr lang="zh-CN" altLang="en-US"/>
               <a:t>截图版本：</a:t>
             </a:r>
@@ -764,7 +836,7 @@
             </a:r>
             <a:r>
               <a:rPr lang="en-US" altLang="zh-CN"/>
-              <a:t>COURSE_SIMULATED_REHEARSAL / REAL_WORLD_DEFERRED / C_PENDING_REVIEW</a:t>
+              <a:t>COURSE_SIMULATED_REHEARSAL / REAL_WORLD_DEFERRED / C_CHANGES_REQUIRED_PENDING_TARGETED_REREVIEW</a:t>
             </a:r>
             <a:endParaRPr lang="zh-CN" altLang="en-US"/>
           </a:p>
@@ -785,7 +857,7 @@
           <a:bodyPr/>
           <a:lstStyle/>
           <a:p>
-            <a:fld id="{4D1E7FFA-7EBE-4257-AFCA-48BD069FC2F6}" type="slidenum">
+            <a:fld id="{9E96E106-DC41-4082-98AA-5BCDE38605D0}" type="slidenum">
               <a:rPr lang="zh-CN" altLang="en-US" smtClean="0"/>
               <a:t>10</a:t>
             </a:fld>
@@ -796,7 +868,7 @@
     </p:spTree>
     <p:extLst>
       <p:ext uri="{BB962C8B-B14F-4D97-AF65-F5344CB8AC3E}">
-        <p14:creationId xmlns:p14="http://schemas.microsoft.com/office/powerpoint/2010/main" val="2354422930"/>
+        <p14:creationId xmlns:p14="http://schemas.microsoft.com/office/powerpoint/2010/main" val="3197211678"/>
       </p:ext>
     </p:extLst>
   </p:cSld>
@@ -954,6 +1026,30 @@
           </a:p>
           <a:p>
             <a:r>
+              <a:rPr lang="en-US" altLang="zh-CN"/>
+              <a:t>docs/work/G6/G6-01_A_rereview.md</a:t>
+            </a:r>
+          </a:p>
+          <a:p>
+            <a:r>
+              <a:rPr lang="en-US" altLang="zh-CN"/>
+              <a:t>docs/work/G6/G6-02_A_rereview.md</a:t>
+            </a:r>
+          </a:p>
+          <a:p>
+            <a:r>
+              <a:rPr lang="en-US" altLang="zh-CN"/>
+              <a:t>logs/reviews/2026-10-12_G6-03-C-review.md</a:t>
+            </a:r>
+          </a:p>
+          <a:p>
+            <a:r>
+              <a:rPr lang="en-US" altLang="zh-CN"/>
+              <a:t>evidence/g6/G6-03/C-review/review-result.json</a:t>
+            </a:r>
+          </a:p>
+          <a:p>
+            <a:r>
               <a:rPr lang="zh-CN" altLang="en-US"/>
               <a:t>截图版本：</a:t>
             </a:r>
@@ -969,7 +1065,7 @@
             </a:r>
             <a:r>
               <a:rPr lang="en-US" altLang="zh-CN"/>
-              <a:t>COURSE_SIMULATED_REHEARSAL / REAL_WORLD_DEFERRED / C_PENDING_REVIEW</a:t>
+              <a:t>COURSE_SIMULATED_REHEARSAL / REAL_WORLD_DEFERRED / C_CHANGES_REQUIRED_PENDING_TARGETED_REREVIEW</a:t>
             </a:r>
             <a:endParaRPr lang="zh-CN" altLang="en-US"/>
           </a:p>
@@ -990,7 +1086,7 @@
           <a:bodyPr/>
           <a:lstStyle/>
           <a:p>
-            <a:fld id="{4D1E7FFA-7EBE-4257-AFCA-48BD069FC2F6}" type="slidenum">
+            <a:fld id="{9E96E106-DC41-4082-98AA-5BCDE38605D0}" type="slidenum">
               <a:rPr lang="zh-CN" altLang="en-US" smtClean="0"/>
               <a:t>11</a:t>
             </a:fld>
@@ -1001,7 +1097,7 @@
     </p:spTree>
     <p:extLst>
       <p:ext uri="{BB962C8B-B14F-4D97-AF65-F5344CB8AC3E}">
-        <p14:creationId xmlns:p14="http://schemas.microsoft.com/office/powerpoint/2010/main" val="4108294156"/>
+        <p14:creationId xmlns:p14="http://schemas.microsoft.com/office/powerpoint/2010/main" val="39291552"/>
       </p:ext>
     </p:extLst>
   </p:cSld>
@@ -1161,6 +1257,30 @@
           </a:p>
           <a:p>
             <a:r>
+              <a:rPr lang="en-US" altLang="zh-CN"/>
+              <a:t>docs/work/G6/G6-01_A_rereview.md</a:t>
+            </a:r>
+          </a:p>
+          <a:p>
+            <a:r>
+              <a:rPr lang="en-US" altLang="zh-CN"/>
+              <a:t>docs/work/G6/G6-02_A_rereview.md</a:t>
+            </a:r>
+          </a:p>
+          <a:p>
+            <a:r>
+              <a:rPr lang="en-US" altLang="zh-CN"/>
+              <a:t>logs/reviews/2026-10-12_G6-03-C-review.md</a:t>
+            </a:r>
+          </a:p>
+          <a:p>
+            <a:r>
+              <a:rPr lang="en-US" altLang="zh-CN"/>
+              <a:t>evidence/g6/G6-03/C-review/review-result.json</a:t>
+            </a:r>
+          </a:p>
+          <a:p>
+            <a:r>
               <a:rPr lang="zh-CN" altLang="en-US"/>
               <a:t>截图版本：</a:t>
             </a:r>
@@ -1176,7 +1296,7 @@
             </a:r>
             <a:r>
               <a:rPr lang="en-US" altLang="zh-CN"/>
-              <a:t>COURSE_SIMULATED_REHEARSAL / REAL_WORLD_DEFERRED / C_PENDING_REVIEW</a:t>
+              <a:t>COURSE_SIMULATED_REHEARSAL / REAL_WORLD_DEFERRED / C_CHANGES_REQUIRED_PENDING_TARGETED_REREVIEW</a:t>
             </a:r>
             <a:endParaRPr lang="zh-CN" altLang="en-US"/>
           </a:p>
@@ -1197,7 +1317,7 @@
           <a:bodyPr/>
           <a:lstStyle/>
           <a:p>
-            <a:fld id="{4D1E7FFA-7EBE-4257-AFCA-48BD069FC2F6}" type="slidenum">
+            <a:fld id="{9E96E106-DC41-4082-98AA-5BCDE38605D0}" type="slidenum">
               <a:rPr lang="zh-CN" altLang="en-US" smtClean="0"/>
               <a:t>12</a:t>
             </a:fld>
@@ -1208,7 +1328,7 @@
     </p:spTree>
     <p:extLst>
       <p:ext uri="{BB962C8B-B14F-4D97-AF65-F5344CB8AC3E}">
-        <p14:creationId xmlns:p14="http://schemas.microsoft.com/office/powerpoint/2010/main" val="2443288830"/>
+        <p14:creationId xmlns:p14="http://schemas.microsoft.com/office/powerpoint/2010/main" val="2112579885"/>
       </p:ext>
     </p:extLst>
   </p:cSld>
@@ -1386,6 +1506,30 @@
           </a:p>
           <a:p>
             <a:r>
+              <a:rPr lang="en-US" altLang="zh-CN"/>
+              <a:t>docs/work/G6/G6-01_A_rereview.md</a:t>
+            </a:r>
+          </a:p>
+          <a:p>
+            <a:r>
+              <a:rPr lang="en-US" altLang="zh-CN"/>
+              <a:t>docs/work/G6/G6-02_A_rereview.md</a:t>
+            </a:r>
+          </a:p>
+          <a:p>
+            <a:r>
+              <a:rPr lang="en-US" altLang="zh-CN"/>
+              <a:t>logs/reviews/2026-10-12_G6-03-C-review.md</a:t>
+            </a:r>
+          </a:p>
+          <a:p>
+            <a:r>
+              <a:rPr lang="en-US" altLang="zh-CN"/>
+              <a:t>evidence/g6/G6-03/C-review/review-result.json</a:t>
+            </a:r>
+          </a:p>
+          <a:p>
+            <a:r>
               <a:rPr lang="zh-CN" altLang="en-US"/>
               <a:t>截图版本：</a:t>
             </a:r>
@@ -1401,7 +1545,7 @@
             </a:r>
             <a:r>
               <a:rPr lang="en-US" altLang="zh-CN"/>
-              <a:t>COURSE_SIMULATED_REHEARSAL / REAL_WORLD_DEFERRED / C_PENDING_REVIEW</a:t>
+              <a:t>COURSE_SIMULATED_REHEARSAL / REAL_WORLD_DEFERRED / C_CHANGES_REQUIRED_PENDING_TARGETED_REREVIEW</a:t>
             </a:r>
             <a:endParaRPr lang="zh-CN" altLang="en-US"/>
           </a:p>
@@ -1422,7 +1566,7 @@
           <a:bodyPr/>
           <a:lstStyle/>
           <a:p>
-            <a:fld id="{4D1E7FFA-7EBE-4257-AFCA-48BD069FC2F6}" type="slidenum">
+            <a:fld id="{9E96E106-DC41-4082-98AA-5BCDE38605D0}" type="slidenum">
               <a:rPr lang="zh-CN" altLang="en-US" smtClean="0"/>
               <a:t>13</a:t>
             </a:fld>
@@ -1433,7 +1577,7 @@
     </p:spTree>
     <p:extLst>
       <p:ext uri="{BB962C8B-B14F-4D97-AF65-F5344CB8AC3E}">
-        <p14:creationId xmlns:p14="http://schemas.microsoft.com/office/powerpoint/2010/main" val="1600674978"/>
+        <p14:creationId xmlns:p14="http://schemas.microsoft.com/office/powerpoint/2010/main" val="3536111548"/>
       </p:ext>
     </p:extLst>
   </p:cSld>
@@ -1509,6 +1653,22 @@
             </a:r>
             <a:r>
               <a:rPr lang="en-US" altLang="zh-CN"/>
+              <a:t>G6-01 A</a:t>
+            </a:r>
+            <a:r>
+              <a:rPr lang="zh-CN" altLang="en-US"/>
+              <a:t>接受及</a:t>
+            </a:r>
+            <a:r>
+              <a:rPr lang="en-US" altLang="zh-CN"/>
+              <a:t>G6-02 B/A</a:t>
+            </a:r>
+            <a:r>
+              <a:rPr lang="zh-CN" altLang="en-US"/>
+              <a:t>最终审计已闭环；</a:t>
+            </a:r>
+            <a:r>
+              <a:rPr lang="en-US" altLang="zh-CN"/>
               <a:t>C</a:t>
             </a:r>
             <a:r>
@@ -1521,23 +1681,39 @@
             </a:r>
             <a:r>
               <a:rPr lang="zh-CN" altLang="en-US"/>
-              <a:t>、</a:t>
-            </a:r>
-            <a:r>
-              <a:rPr lang="en-US" altLang="zh-CN"/>
-              <a:t>G6-01 A</a:t>
-            </a:r>
-            <a:r>
-              <a:rPr lang="zh-CN" altLang="en-US"/>
-              <a:t>复核和</a:t>
-            </a:r>
-            <a:r>
-              <a:rPr lang="en-US" altLang="zh-CN"/>
-              <a:t>G6-02</a:t>
-            </a:r>
-            <a:r>
-              <a:rPr lang="zh-CN" altLang="en-US"/>
-              <a:t>最终增量审计仍待闭环。真实现场的质询、计时和意见仅在实际发生后追加记录。</a:t>
+              <a:t>为</a:t>
+            </a:r>
+            <a:r>
+              <a:rPr lang="en-US" altLang="zh-CN"/>
+              <a:t>CHANGES_REQUIRED</a:t>
+            </a:r>
+            <a:r>
+              <a:rPr lang="zh-CN" altLang="en-US"/>
+              <a:t>。此次</a:t>
+            </a:r>
+            <a:r>
+              <a:rPr lang="en-US" altLang="zh-CN"/>
+              <a:t>002</a:t>
+            </a:r>
+            <a:r>
+              <a:rPr lang="zh-CN" altLang="en-US"/>
+              <a:t>整改待</a:t>
+            </a:r>
+            <a:r>
+              <a:rPr lang="en-US" altLang="zh-CN"/>
+              <a:t>C</a:t>
+            </a:r>
+            <a:r>
+              <a:rPr lang="zh-CN" altLang="en-US"/>
+              <a:t>定向复验，不能提前置</a:t>
+            </a:r>
+            <a:r>
+              <a:rPr lang="en-US" altLang="zh-CN"/>
+              <a:t>DONE</a:t>
+            </a:r>
+            <a:r>
+              <a:rPr lang="zh-CN" altLang="en-US"/>
+              <a:t>。真实现场的质询、计时和意见仅在实际发生后追加记录。</a:t>
             </a:r>
           </a:p>
           <a:p>
@@ -1591,6 +1767,30 @@
           </a:p>
           <a:p>
             <a:r>
+              <a:rPr lang="en-US" altLang="zh-CN"/>
+              <a:t>docs/work/G6/G6-01_A_rereview.md</a:t>
+            </a:r>
+          </a:p>
+          <a:p>
+            <a:r>
+              <a:rPr lang="en-US" altLang="zh-CN"/>
+              <a:t>docs/work/G6/G6-02_A_rereview.md</a:t>
+            </a:r>
+          </a:p>
+          <a:p>
+            <a:r>
+              <a:rPr lang="en-US" altLang="zh-CN"/>
+              <a:t>logs/reviews/2026-10-12_G6-03-C-review.md</a:t>
+            </a:r>
+          </a:p>
+          <a:p>
+            <a:r>
+              <a:rPr lang="en-US" altLang="zh-CN"/>
+              <a:t>evidence/g6/G6-03/C-review/review-result.json</a:t>
+            </a:r>
+          </a:p>
+          <a:p>
+            <a:r>
               <a:rPr lang="zh-CN" altLang="en-US"/>
               <a:t>截图版本：</a:t>
             </a:r>
@@ -1606,7 +1806,7 @@
             </a:r>
             <a:r>
               <a:rPr lang="en-US" altLang="zh-CN"/>
-              <a:t>COURSE_SIMULATED_REHEARSAL / REAL_WORLD_DEFERRED / C_PENDING_REVIEW</a:t>
+              <a:t>COURSE_SIMULATED_REHEARSAL / REAL_WORLD_DEFERRED / C_CHANGES_REQUIRED_PENDING_TARGETED_REREVIEW</a:t>
             </a:r>
             <a:endParaRPr lang="zh-CN" altLang="en-US"/>
           </a:p>
@@ -1627,7 +1827,7 @@
           <a:bodyPr/>
           <a:lstStyle/>
           <a:p>
-            <a:fld id="{4D1E7FFA-7EBE-4257-AFCA-48BD069FC2F6}" type="slidenum">
+            <a:fld id="{9E96E106-DC41-4082-98AA-5BCDE38605D0}" type="slidenum">
               <a:rPr lang="zh-CN" altLang="en-US" smtClean="0"/>
               <a:t>14</a:t>
             </a:fld>
@@ -1638,7 +1838,7 @@
     </p:spTree>
     <p:extLst>
       <p:ext uri="{BB962C8B-B14F-4D97-AF65-F5344CB8AC3E}">
-        <p14:creationId xmlns:p14="http://schemas.microsoft.com/office/powerpoint/2010/main" val="2972684125"/>
+        <p14:creationId xmlns:p14="http://schemas.microsoft.com/office/powerpoint/2010/main" val="2742446975"/>
       </p:ext>
     </p:extLst>
   </p:cSld>
@@ -1750,15 +1950,23 @@
             </a:r>
             <a:r>
               <a:rPr lang="zh-CN" altLang="en-US"/>
-              <a:t>手册当前为</a:t>
-            </a:r>
-            <a:r>
-              <a:rPr lang="en-US" altLang="zh-CN"/>
-              <a:t>REVIEW</a:t>
-            </a:r>
-            <a:r>
-              <a:rPr lang="zh-CN" altLang="en-US"/>
-              <a:t>，</a:t>
+              <a:t>已由</a:t>
+            </a:r>
+            <a:r>
+              <a:rPr lang="en-US" altLang="zh-CN"/>
+              <a:t>A</a:t>
+            </a:r>
+            <a:r>
+              <a:rPr lang="zh-CN" altLang="en-US"/>
+              <a:t>接受并</a:t>
+            </a:r>
+            <a:r>
+              <a:rPr lang="en-US" altLang="zh-CN"/>
+              <a:t>DONE</a:t>
+            </a:r>
+            <a:r>
+              <a:rPr lang="zh-CN" altLang="en-US"/>
+              <a:t>；</a:t>
             </a:r>
             <a:r>
               <a:rPr lang="en-US" altLang="zh-CN"/>
@@ -1766,7 +1974,7 @@
             </a:r>
             <a:r>
               <a:rPr lang="zh-CN" altLang="en-US"/>
-              <a:t>由</a:t>
+              <a:t>已获</a:t>
             </a:r>
             <a:r>
               <a:rPr lang="en-US" altLang="zh-CN"/>
@@ -1774,15 +1982,31 @@
             </a:r>
             <a:r>
               <a:rPr lang="zh-CN" altLang="en-US"/>
-              <a:t>接受首版但最终仍</a:t>
-            </a:r>
-            <a:r>
-              <a:rPr lang="en-US" altLang="zh-CN"/>
-              <a:t>REVIEW</a:t>
-            </a:r>
-            <a:r>
-              <a:rPr lang="zh-CN" altLang="en-US"/>
-              <a:t>，本轮</a:t>
+              <a:t>最终接受及</a:t>
+            </a:r>
+            <a:r>
+              <a:rPr lang="en-US" altLang="zh-CN"/>
+              <a:t>A</a:t>
+            </a:r>
+            <a:r>
+              <a:rPr lang="zh-CN" altLang="en-US"/>
+              <a:t>一致性接受并</a:t>
+            </a:r>
+            <a:r>
+              <a:rPr lang="en-US" altLang="zh-CN"/>
+              <a:t>DONE</a:t>
+            </a:r>
+            <a:r>
+              <a:rPr lang="zh-CN" altLang="en-US"/>
+              <a:t>。</a:t>
+            </a:r>
+            <a:r>
+              <a:rPr lang="en-US" altLang="zh-CN"/>
+              <a:t>C</a:t>
+            </a:r>
+            <a:r>
+              <a:rPr lang="zh-CN" altLang="en-US"/>
+              <a:t>已整体复核</a:t>
             </a:r>
             <a:r>
               <a:rPr lang="en-US" altLang="zh-CN"/>
@@ -1790,15 +2014,23 @@
             </a:r>
             <a:r>
               <a:rPr lang="zh-CN" altLang="en-US"/>
-              <a:t>候选也需要</a:t>
-            </a:r>
-            <a:r>
-              <a:rPr lang="en-US" altLang="zh-CN"/>
-              <a:t>C</a:t>
-            </a:r>
-            <a:r>
-              <a:rPr lang="zh-CN" altLang="en-US"/>
-              <a:t>整体复核。不能把课程任务</a:t>
+              <a:t>，结论</a:t>
+            </a:r>
+            <a:r>
+              <a:rPr lang="en-US" altLang="zh-CN"/>
+              <a:t>CHANGES_REQUIRED</a:t>
+            </a:r>
+            <a:r>
+              <a:rPr lang="zh-CN" altLang="en-US"/>
+              <a:t>，仅状态</a:t>
+            </a:r>
+            <a:r>
+              <a:rPr lang="en-US" altLang="zh-CN"/>
+              <a:t>/</a:t>
+            </a:r>
+            <a:r>
+              <a:rPr lang="zh-CN" altLang="en-US"/>
+              <a:t>来源整改待定向复验。不能把课程任务</a:t>
             </a:r>
             <a:r>
               <a:rPr lang="en-US" altLang="zh-CN"/>
@@ -1852,6 +2084,30 @@
           </a:p>
           <a:p>
             <a:r>
+              <a:rPr lang="en-US" altLang="zh-CN"/>
+              <a:t>docs/work/G6/G6-01_A_rereview.md</a:t>
+            </a:r>
+          </a:p>
+          <a:p>
+            <a:r>
+              <a:rPr lang="en-US" altLang="zh-CN"/>
+              <a:t>docs/work/G6/G6-02_A_rereview.md</a:t>
+            </a:r>
+          </a:p>
+          <a:p>
+            <a:r>
+              <a:rPr lang="en-US" altLang="zh-CN"/>
+              <a:t>logs/reviews/2026-10-12_G6-03-C-review.md</a:t>
+            </a:r>
+          </a:p>
+          <a:p>
+            <a:r>
+              <a:rPr lang="en-US" altLang="zh-CN"/>
+              <a:t>evidence/g6/G6-03/C-review/review-result.json</a:t>
+            </a:r>
+          </a:p>
+          <a:p>
+            <a:r>
               <a:rPr lang="zh-CN" altLang="en-US"/>
               <a:t>截图版本：</a:t>
             </a:r>
@@ -1867,7 +2123,7 @@
             </a:r>
             <a:r>
               <a:rPr lang="en-US" altLang="zh-CN"/>
-              <a:t>COURSE_SIMULATED_REHEARSAL / REAL_WORLD_DEFERRED / C_PENDING_REVIEW</a:t>
+              <a:t>COURSE_SIMULATED_REHEARSAL / REAL_WORLD_DEFERRED / C_CHANGES_REQUIRED_PENDING_TARGETED_REREVIEW</a:t>
             </a:r>
             <a:endParaRPr lang="zh-CN" altLang="en-US"/>
           </a:p>
@@ -1888,7 +2144,7 @@
           <a:bodyPr/>
           <a:lstStyle/>
           <a:p>
-            <a:fld id="{4D1E7FFA-7EBE-4257-AFCA-48BD069FC2F6}" type="slidenum">
+            <a:fld id="{9E96E106-DC41-4082-98AA-5BCDE38605D0}" type="slidenum">
               <a:rPr lang="zh-CN" altLang="en-US" smtClean="0"/>
               <a:t>2</a:t>
             </a:fld>
@@ -1899,7 +2155,7 @@
     </p:spTree>
     <p:extLst>
       <p:ext uri="{BB962C8B-B14F-4D97-AF65-F5344CB8AC3E}">
-        <p14:creationId xmlns:p14="http://schemas.microsoft.com/office/powerpoint/2010/main" val="2520493048"/>
+        <p14:creationId xmlns:p14="http://schemas.microsoft.com/office/powerpoint/2010/main" val="1368157619"/>
       </p:ext>
     </p:extLst>
   </p:cSld>
@@ -2075,6 +2331,30 @@
           </a:p>
           <a:p>
             <a:r>
+              <a:rPr lang="en-US" altLang="zh-CN"/>
+              <a:t>docs/work/G6/G6-01_A_rereview.md</a:t>
+            </a:r>
+          </a:p>
+          <a:p>
+            <a:r>
+              <a:rPr lang="en-US" altLang="zh-CN"/>
+              <a:t>docs/work/G6/G6-02_A_rereview.md</a:t>
+            </a:r>
+          </a:p>
+          <a:p>
+            <a:r>
+              <a:rPr lang="en-US" altLang="zh-CN"/>
+              <a:t>logs/reviews/2026-10-12_G6-03-C-review.md</a:t>
+            </a:r>
+          </a:p>
+          <a:p>
+            <a:r>
+              <a:rPr lang="en-US" altLang="zh-CN"/>
+              <a:t>evidence/g6/G6-03/C-review/review-result.json</a:t>
+            </a:r>
+          </a:p>
+          <a:p>
+            <a:r>
               <a:rPr lang="zh-CN" altLang="en-US"/>
               <a:t>截图版本：</a:t>
             </a:r>
@@ -2090,7 +2370,7 @@
             </a:r>
             <a:r>
               <a:rPr lang="en-US" altLang="zh-CN"/>
-              <a:t>COURSE_SIMULATED_REHEARSAL / REAL_WORLD_DEFERRED / C_PENDING_REVIEW</a:t>
+              <a:t>COURSE_SIMULATED_REHEARSAL / REAL_WORLD_DEFERRED / C_CHANGES_REQUIRED_PENDING_TARGETED_REREVIEW</a:t>
             </a:r>
             <a:endParaRPr lang="zh-CN" altLang="en-US"/>
           </a:p>
@@ -2111,7 +2391,7 @@
           <a:bodyPr/>
           <a:lstStyle/>
           <a:p>
-            <a:fld id="{4D1E7FFA-7EBE-4257-AFCA-48BD069FC2F6}" type="slidenum">
+            <a:fld id="{9E96E106-DC41-4082-98AA-5BCDE38605D0}" type="slidenum">
               <a:rPr lang="zh-CN" altLang="en-US" smtClean="0"/>
               <a:t>3</a:t>
             </a:fld>
@@ -2122,7 +2402,7 @@
     </p:spTree>
     <p:extLst>
       <p:ext uri="{BB962C8B-B14F-4D97-AF65-F5344CB8AC3E}">
-        <p14:creationId xmlns:p14="http://schemas.microsoft.com/office/powerpoint/2010/main" val="940387098"/>
+        <p14:creationId xmlns:p14="http://schemas.microsoft.com/office/powerpoint/2010/main" val="47886286"/>
       </p:ext>
     </p:extLst>
   </p:cSld>
@@ -2362,6 +2642,30 @@
           </a:p>
           <a:p>
             <a:r>
+              <a:rPr lang="en-US" altLang="zh-CN"/>
+              <a:t>docs/work/G6/G6-01_A_rereview.md</a:t>
+            </a:r>
+          </a:p>
+          <a:p>
+            <a:r>
+              <a:rPr lang="en-US" altLang="zh-CN"/>
+              <a:t>docs/work/G6/G6-02_A_rereview.md</a:t>
+            </a:r>
+          </a:p>
+          <a:p>
+            <a:r>
+              <a:rPr lang="en-US" altLang="zh-CN"/>
+              <a:t>logs/reviews/2026-10-12_G6-03-C-review.md</a:t>
+            </a:r>
+          </a:p>
+          <a:p>
+            <a:r>
+              <a:rPr lang="en-US" altLang="zh-CN"/>
+              <a:t>evidence/g6/G6-03/C-review/review-result.json</a:t>
+            </a:r>
+          </a:p>
+          <a:p>
+            <a:r>
               <a:rPr lang="zh-CN" altLang="en-US"/>
               <a:t>截图版本：</a:t>
             </a:r>
@@ -2377,7 +2681,7 @@
             </a:r>
             <a:r>
               <a:rPr lang="en-US" altLang="zh-CN"/>
-              <a:t>COURSE_SIMULATED_REHEARSAL / REAL_WORLD_DEFERRED / C_PENDING_REVIEW</a:t>
+              <a:t>COURSE_SIMULATED_REHEARSAL / REAL_WORLD_DEFERRED / C_CHANGES_REQUIRED_PENDING_TARGETED_REREVIEW</a:t>
             </a:r>
             <a:endParaRPr lang="zh-CN" altLang="en-US"/>
           </a:p>
@@ -2398,7 +2702,7 @@
           <a:bodyPr/>
           <a:lstStyle/>
           <a:p>
-            <a:fld id="{4D1E7FFA-7EBE-4257-AFCA-48BD069FC2F6}" type="slidenum">
+            <a:fld id="{9E96E106-DC41-4082-98AA-5BCDE38605D0}" type="slidenum">
               <a:rPr lang="zh-CN" altLang="en-US" smtClean="0"/>
               <a:t>4</a:t>
             </a:fld>
@@ -2409,7 +2713,7 @@
     </p:spTree>
     <p:extLst>
       <p:ext uri="{BB962C8B-B14F-4D97-AF65-F5344CB8AC3E}">
-        <p14:creationId xmlns:p14="http://schemas.microsoft.com/office/powerpoint/2010/main" val="4269835749"/>
+        <p14:creationId xmlns:p14="http://schemas.microsoft.com/office/powerpoint/2010/main" val="359868230"/>
       </p:ext>
     </p:extLst>
   </p:cSld>
@@ -2645,6 +2949,30 @@
           </a:p>
           <a:p>
             <a:r>
+              <a:rPr lang="en-US" altLang="zh-CN"/>
+              <a:t>docs/work/G6/G6-01_A_rereview.md</a:t>
+            </a:r>
+          </a:p>
+          <a:p>
+            <a:r>
+              <a:rPr lang="en-US" altLang="zh-CN"/>
+              <a:t>docs/work/G6/G6-02_A_rereview.md</a:t>
+            </a:r>
+          </a:p>
+          <a:p>
+            <a:r>
+              <a:rPr lang="en-US" altLang="zh-CN"/>
+              <a:t>logs/reviews/2026-10-12_G6-03-C-review.md</a:t>
+            </a:r>
+          </a:p>
+          <a:p>
+            <a:r>
+              <a:rPr lang="en-US" altLang="zh-CN"/>
+              <a:t>evidence/g6/G6-03/C-review/review-result.json</a:t>
+            </a:r>
+          </a:p>
+          <a:p>
+            <a:r>
               <a:rPr lang="zh-CN" altLang="en-US"/>
               <a:t>截图版本：</a:t>
             </a:r>
@@ -2660,7 +2988,7 @@
             </a:r>
             <a:r>
               <a:rPr lang="en-US" altLang="zh-CN"/>
-              <a:t>COURSE_SIMULATED_REHEARSAL / REAL_WORLD_DEFERRED / C_PENDING_REVIEW</a:t>
+              <a:t>COURSE_SIMULATED_REHEARSAL / REAL_WORLD_DEFERRED / C_CHANGES_REQUIRED_PENDING_TARGETED_REREVIEW</a:t>
             </a:r>
             <a:endParaRPr lang="zh-CN" altLang="en-US"/>
           </a:p>
@@ -2681,7 +3009,7 @@
           <a:bodyPr/>
           <a:lstStyle/>
           <a:p>
-            <a:fld id="{4D1E7FFA-7EBE-4257-AFCA-48BD069FC2F6}" type="slidenum">
+            <a:fld id="{9E96E106-DC41-4082-98AA-5BCDE38605D0}" type="slidenum">
               <a:rPr lang="zh-CN" altLang="en-US" smtClean="0"/>
               <a:t>5</a:t>
             </a:fld>
@@ -2692,7 +3020,7 @@
     </p:spTree>
     <p:extLst>
       <p:ext uri="{BB962C8B-B14F-4D97-AF65-F5344CB8AC3E}">
-        <p14:creationId xmlns:p14="http://schemas.microsoft.com/office/powerpoint/2010/main" val="638680580"/>
+        <p14:creationId xmlns:p14="http://schemas.microsoft.com/office/powerpoint/2010/main" val="1721250716"/>
       </p:ext>
     </p:extLst>
   </p:cSld>
@@ -2800,11 +3128,35 @@
             </a:r>
             <a:r>
               <a:rPr lang="en-US" altLang="zh-CN"/>
-              <a:t>G6-01</a:t>
-            </a:r>
-            <a:r>
-              <a:rPr lang="zh-CN" altLang="en-US"/>
-              <a:t>文档和</a:t>
+              <a:t>G6-01 V0.2</a:t>
+            </a:r>
+            <a:r>
+              <a:rPr lang="zh-CN" altLang="en-US"/>
+              <a:t>及</a:t>
+            </a:r>
+            <a:r>
+              <a:rPr lang="en-US" altLang="zh-CN"/>
+              <a:t>26</a:t>
+            </a:r>
+            <a:r>
+              <a:rPr lang="zh-CN" altLang="en-US"/>
+              <a:t>步命令证据已由</a:t>
+            </a:r>
+            <a:r>
+              <a:rPr lang="en-US" altLang="zh-CN"/>
+              <a:t>A</a:t>
+            </a:r>
+            <a:r>
+              <a:rPr lang="zh-CN" altLang="en-US"/>
+              <a:t>接受；</a:t>
+            </a:r>
+            <a:r>
+              <a:rPr lang="en-US" altLang="zh-CN"/>
+              <a:t>G6-02</a:t>
+            </a:r>
+            <a:r>
+              <a:rPr lang="zh-CN" altLang="en-US"/>
+              <a:t>最终审计经</a:t>
             </a:r>
             <a:r>
               <a:rPr lang="en-US" altLang="zh-CN"/>
@@ -2812,7 +3164,7 @@
             </a:r>
             <a:r>
               <a:rPr lang="zh-CN" altLang="en-US"/>
-              <a:t>本地命令记录可以用于操作依据，但尚无</a:t>
+              <a:t>再复验与</a:t>
             </a:r>
             <a:r>
               <a:rPr lang="en-US" altLang="zh-CN"/>
@@ -2820,23 +3172,31 @@
             </a:r>
             <a:r>
               <a:rPr lang="zh-CN" altLang="en-US"/>
-              <a:t>整体接受记录，不能擅自宣称前置已</a:t>
-            </a:r>
-            <a:r>
-              <a:rPr lang="en-US" altLang="zh-CN"/>
-              <a:t>DONE</a:t>
-            </a:r>
-            <a:r>
-              <a:rPr lang="zh-CN" altLang="en-US"/>
-              <a:t>。</a:t>
-            </a:r>
-            <a:r>
-              <a:rPr lang="en-US" altLang="zh-CN"/>
-              <a:t>G6-02 B</a:t>
-            </a:r>
-            <a:r>
-              <a:rPr lang="zh-CN" altLang="en-US"/>
-              <a:t>结论明确只接受首版。本轮的运行、截图、问题和讲稿将作为其最终审计输入。</a:t>
+              <a:t>一致性复验接受。首版</a:t>
+            </a:r>
+            <a:r>
+              <a:rPr lang="en-US" altLang="zh-CN"/>
+              <a:t>29</a:t>
+            </a:r>
+            <a:r>
+              <a:rPr lang="zh-CN" altLang="en-US"/>
+              <a:t>项快照保留，增量</a:t>
+            </a:r>
+            <a:r>
+              <a:rPr lang="en-US" altLang="zh-CN"/>
+              <a:t>GI</a:t>
+            </a:r>
+            <a:r>
+              <a:rPr lang="zh-CN" altLang="en-US"/>
+              <a:t>三段</a:t>
+            </a:r>
+            <a:r>
+              <a:rPr lang="en-US" altLang="zh-CN"/>
+              <a:t>21/18/11</a:t>
+            </a:r>
+            <a:r>
+              <a:rPr lang="zh-CN" altLang="en-US"/>
+              <a:t>分列。此次修订作为后续增量交接，不倒改已锁历史指纹。</a:t>
             </a:r>
           </a:p>
           <a:p>
@@ -2874,6 +3234,30 @@
           </a:p>
           <a:p>
             <a:r>
+              <a:rPr lang="en-US" altLang="zh-CN"/>
+              <a:t>docs/work/G6/G6-01_A_rereview.md</a:t>
+            </a:r>
+          </a:p>
+          <a:p>
+            <a:r>
+              <a:rPr lang="en-US" altLang="zh-CN"/>
+              <a:t>docs/work/G6/G6-02_A_rereview.md</a:t>
+            </a:r>
+          </a:p>
+          <a:p>
+            <a:r>
+              <a:rPr lang="en-US" altLang="zh-CN"/>
+              <a:t>logs/reviews/2026-10-12_G6-03-C-review.md</a:t>
+            </a:r>
+          </a:p>
+          <a:p>
+            <a:r>
+              <a:rPr lang="en-US" altLang="zh-CN"/>
+              <a:t>evidence/g6/G6-03/C-review/review-result.json</a:t>
+            </a:r>
+          </a:p>
+          <a:p>
+            <a:r>
               <a:rPr lang="zh-CN" altLang="en-US"/>
               <a:t>截图版本：</a:t>
             </a:r>
@@ -2889,7 +3273,7 @@
             </a:r>
             <a:r>
               <a:rPr lang="en-US" altLang="zh-CN"/>
-              <a:t>COURSE_SIMULATED_REHEARSAL / REAL_WORLD_DEFERRED / C_PENDING_REVIEW</a:t>
+              <a:t>COURSE_SIMULATED_REHEARSAL / REAL_WORLD_DEFERRED / C_CHANGES_REQUIRED_PENDING_TARGETED_REREVIEW</a:t>
             </a:r>
             <a:endParaRPr lang="zh-CN" altLang="en-US"/>
           </a:p>
@@ -2910,7 +3294,7 @@
           <a:bodyPr/>
           <a:lstStyle/>
           <a:p>
-            <a:fld id="{4D1E7FFA-7EBE-4257-AFCA-48BD069FC2F6}" type="slidenum">
+            <a:fld id="{9E96E106-DC41-4082-98AA-5BCDE38605D0}" type="slidenum">
               <a:rPr lang="zh-CN" altLang="en-US" smtClean="0"/>
               <a:t>6</a:t>
             </a:fld>
@@ -2921,7 +3305,7 @@
     </p:spTree>
     <p:extLst>
       <p:ext uri="{BB962C8B-B14F-4D97-AF65-F5344CB8AC3E}">
-        <p14:creationId xmlns:p14="http://schemas.microsoft.com/office/powerpoint/2010/main" val="2935754957"/>
+        <p14:creationId xmlns:p14="http://schemas.microsoft.com/office/powerpoint/2010/main" val="1502422355"/>
       </p:ext>
     </p:extLst>
   </p:cSld>
@@ -3049,6 +3433,30 @@
           </a:p>
           <a:p>
             <a:r>
+              <a:rPr lang="en-US" altLang="zh-CN"/>
+              <a:t>docs/work/G6/G6-01_A_rereview.md</a:t>
+            </a:r>
+          </a:p>
+          <a:p>
+            <a:r>
+              <a:rPr lang="en-US" altLang="zh-CN"/>
+              <a:t>docs/work/G6/G6-02_A_rereview.md</a:t>
+            </a:r>
+          </a:p>
+          <a:p>
+            <a:r>
+              <a:rPr lang="en-US" altLang="zh-CN"/>
+              <a:t>logs/reviews/2026-10-12_G6-03-C-review.md</a:t>
+            </a:r>
+          </a:p>
+          <a:p>
+            <a:r>
+              <a:rPr lang="en-US" altLang="zh-CN"/>
+              <a:t>evidence/g6/G6-03/C-review/review-result.json</a:t>
+            </a:r>
+          </a:p>
+          <a:p>
+            <a:r>
               <a:rPr lang="zh-CN" altLang="en-US"/>
               <a:t>截图版本：</a:t>
             </a:r>
@@ -3064,7 +3472,7 @@
             </a:r>
             <a:r>
               <a:rPr lang="en-US" altLang="zh-CN"/>
-              <a:t>COURSE_SIMULATED_REHEARSAL / REAL_WORLD_DEFERRED / C_PENDING_REVIEW</a:t>
+              <a:t>COURSE_SIMULATED_REHEARSAL / REAL_WORLD_DEFERRED / C_CHANGES_REQUIRED_PENDING_TARGETED_REREVIEW</a:t>
             </a:r>
             <a:endParaRPr lang="zh-CN" altLang="en-US"/>
           </a:p>
@@ -3085,7 +3493,7 @@
           <a:bodyPr/>
           <a:lstStyle/>
           <a:p>
-            <a:fld id="{4D1E7FFA-7EBE-4257-AFCA-48BD069FC2F6}" type="slidenum">
+            <a:fld id="{9E96E106-DC41-4082-98AA-5BCDE38605D0}" type="slidenum">
               <a:rPr lang="zh-CN" altLang="en-US" smtClean="0"/>
               <a:t>7</a:t>
             </a:fld>
@@ -3096,7 +3504,7 @@
     </p:spTree>
     <p:extLst>
       <p:ext uri="{BB962C8B-B14F-4D97-AF65-F5344CB8AC3E}">
-        <p14:creationId xmlns:p14="http://schemas.microsoft.com/office/powerpoint/2010/main" val="607367286"/>
+        <p14:creationId xmlns:p14="http://schemas.microsoft.com/office/powerpoint/2010/main" val="2880348426"/>
       </p:ext>
     </p:extLst>
   </p:cSld>
@@ -3224,6 +3632,30 @@
           </a:p>
           <a:p>
             <a:r>
+              <a:rPr lang="en-US" altLang="zh-CN"/>
+              <a:t>docs/work/G6/G6-01_A_rereview.md</a:t>
+            </a:r>
+          </a:p>
+          <a:p>
+            <a:r>
+              <a:rPr lang="en-US" altLang="zh-CN"/>
+              <a:t>docs/work/G6/G6-02_A_rereview.md</a:t>
+            </a:r>
+          </a:p>
+          <a:p>
+            <a:r>
+              <a:rPr lang="en-US" altLang="zh-CN"/>
+              <a:t>logs/reviews/2026-10-12_G6-03-C-review.md</a:t>
+            </a:r>
+          </a:p>
+          <a:p>
+            <a:r>
+              <a:rPr lang="en-US" altLang="zh-CN"/>
+              <a:t>evidence/g6/G6-03/C-review/review-result.json</a:t>
+            </a:r>
+          </a:p>
+          <a:p>
+            <a:r>
               <a:rPr lang="zh-CN" altLang="en-US"/>
               <a:t>截图版本：</a:t>
             </a:r>
@@ -3239,7 +3671,7 @@
             </a:r>
             <a:r>
               <a:rPr lang="en-US" altLang="zh-CN"/>
-              <a:t>COURSE_SIMULATED_REHEARSAL / REAL_WORLD_DEFERRED / C_PENDING_REVIEW</a:t>
+              <a:t>COURSE_SIMULATED_REHEARSAL / REAL_WORLD_DEFERRED / C_CHANGES_REQUIRED_PENDING_TARGETED_REREVIEW</a:t>
             </a:r>
             <a:endParaRPr lang="zh-CN" altLang="en-US"/>
           </a:p>
@@ -3260,7 +3692,7 @@
           <a:bodyPr/>
           <a:lstStyle/>
           <a:p>
-            <a:fld id="{4D1E7FFA-7EBE-4257-AFCA-48BD069FC2F6}" type="slidenum">
+            <a:fld id="{9E96E106-DC41-4082-98AA-5BCDE38605D0}" type="slidenum">
               <a:rPr lang="zh-CN" altLang="en-US" smtClean="0"/>
               <a:t>8</a:t>
             </a:fld>
@@ -3271,7 +3703,7 @@
     </p:spTree>
     <p:extLst>
       <p:ext uri="{BB962C8B-B14F-4D97-AF65-F5344CB8AC3E}">
-        <p14:creationId xmlns:p14="http://schemas.microsoft.com/office/powerpoint/2010/main" val="1606082284"/>
+        <p14:creationId xmlns:p14="http://schemas.microsoft.com/office/powerpoint/2010/main" val="1249950379"/>
       </p:ext>
     </p:extLst>
   </p:cSld>
@@ -3395,7 +3827,7 @@
             </a:r>
             <a:r>
               <a:rPr lang="zh-CN" altLang="en-US"/>
-              <a:t>与带问题试演保留，问题状态为整改复验完成、待</a:t>
+              <a:t>与带问题试演保留，</a:t>
             </a:r>
             <a:r>
               <a:rPr lang="en-US" altLang="zh-CN"/>
@@ -3411,7 +3843,39 @@
             </a:r>
             <a:r>
               <a:rPr lang="zh-CN" altLang="en-US"/>
-              <a:t>整体复核，不能由整改者代签关闭。</a:t>
+              <a:t>独立复演均有实际记录；问题已</a:t>
+            </a:r>
+            <a:r>
+              <a:rPr lang="en-US" altLang="zh-CN"/>
+              <a:t>CLOSED / VERIFIED_BY_B_AND_C</a:t>
+            </a:r>
+            <a:r>
+              <a:rPr lang="zh-CN" altLang="en-US"/>
+              <a:t>。当前</a:t>
+            </a:r>
+            <a:r>
+              <a:rPr lang="en-US" altLang="zh-CN"/>
+              <a:t>002</a:t>
+            </a:r>
+            <a:r>
+              <a:rPr lang="zh-CN" altLang="en-US"/>
+              <a:t>状态</a:t>
+            </a:r>
+            <a:r>
+              <a:rPr lang="en-US" altLang="zh-CN"/>
+              <a:t>/</a:t>
+            </a:r>
+            <a:r>
+              <a:rPr lang="zh-CN" altLang="en-US"/>
+              <a:t>来源修订仍待</a:t>
+            </a:r>
+            <a:r>
+              <a:rPr lang="en-US" altLang="zh-CN"/>
+              <a:t>C</a:t>
+            </a:r>
+            <a:r>
+              <a:rPr lang="zh-CN" altLang="en-US"/>
+              <a:t>定向复验。</a:t>
             </a:r>
           </a:p>
           <a:p>
@@ -3455,6 +3919,30 @@
           </a:p>
           <a:p>
             <a:r>
+              <a:rPr lang="en-US" altLang="zh-CN"/>
+              <a:t>docs/work/G6/G6-01_A_rereview.md</a:t>
+            </a:r>
+          </a:p>
+          <a:p>
+            <a:r>
+              <a:rPr lang="en-US" altLang="zh-CN"/>
+              <a:t>docs/work/G6/G6-02_A_rereview.md</a:t>
+            </a:r>
+          </a:p>
+          <a:p>
+            <a:r>
+              <a:rPr lang="en-US" altLang="zh-CN"/>
+              <a:t>logs/reviews/2026-10-12_G6-03-C-review.md</a:t>
+            </a:r>
+          </a:p>
+          <a:p>
+            <a:r>
+              <a:rPr lang="en-US" altLang="zh-CN"/>
+              <a:t>evidence/g6/G6-03/C-review/review-result.json</a:t>
+            </a:r>
+          </a:p>
+          <a:p>
+            <a:r>
               <a:rPr lang="zh-CN" altLang="en-US"/>
               <a:t>截图版本：</a:t>
             </a:r>
@@ -3470,7 +3958,7 @@
             </a:r>
             <a:r>
               <a:rPr lang="en-US" altLang="zh-CN"/>
-              <a:t>COURSE_SIMULATED_REHEARSAL / REAL_WORLD_DEFERRED / C_PENDING_REVIEW</a:t>
+              <a:t>COURSE_SIMULATED_REHEARSAL / REAL_WORLD_DEFERRED / C_CHANGES_REQUIRED_PENDING_TARGETED_REREVIEW</a:t>
             </a:r>
             <a:endParaRPr lang="zh-CN" altLang="en-US"/>
           </a:p>
@@ -3491,7 +3979,7 @@
           <a:bodyPr/>
           <a:lstStyle/>
           <a:p>
-            <a:fld id="{4D1E7FFA-7EBE-4257-AFCA-48BD069FC2F6}" type="slidenum">
+            <a:fld id="{9E96E106-DC41-4082-98AA-5BCDE38605D0}" type="slidenum">
               <a:rPr lang="zh-CN" altLang="en-US" smtClean="0"/>
               <a:t>9</a:t>
             </a:fld>
@@ -3502,7 +3990,7 @@
     </p:spTree>
     <p:extLst>
       <p:ext uri="{BB962C8B-B14F-4D97-AF65-F5344CB8AC3E}">
-        <p14:creationId xmlns:p14="http://schemas.microsoft.com/office/powerpoint/2010/main" val="2872110713"/>
+        <p14:creationId xmlns:p14="http://schemas.microsoft.com/office/powerpoint/2010/main" val="3278052037"/>
       </p:ext>
     </p:extLst>
   </p:cSld>
@@ -3534,7 +4022,7 @@
           <p:cNvPr id="2" name="标题 1">
             <a:extLst>
               <a:ext uri="{FF2B5EF4-FFF2-40B4-BE49-F238E27FC236}">
-                <a16:creationId xmlns:a16="http://schemas.microsoft.com/office/drawing/2014/main" id="{1C3AF129-F72A-4251-B562-D370943CFEFF}"/>
+                <a16:creationId xmlns:a16="http://schemas.microsoft.com/office/drawing/2014/main" id="{F19C028C-06B8-4FC7-9D5C-86985E081761}"/>
               </a:ext>
             </a:extLst>
           </p:cNvPr>
@@ -3571,7 +4059,7 @@
           <p:cNvPr id="3" name="副标题 2">
             <a:extLst>
               <a:ext uri="{FF2B5EF4-FFF2-40B4-BE49-F238E27FC236}">
-                <a16:creationId xmlns:a16="http://schemas.microsoft.com/office/drawing/2014/main" id="{64F0FBF9-B563-4552-B318-56953793CAEC}"/>
+                <a16:creationId xmlns:a16="http://schemas.microsoft.com/office/drawing/2014/main" id="{FB457385-EC99-485D-B90E-3CB513EDBAC7}"/>
               </a:ext>
             </a:extLst>
           </p:cNvPr>
@@ -3641,7 +4129,7 @@
           <p:cNvPr id="4" name="日期占位符 3">
             <a:extLst>
               <a:ext uri="{FF2B5EF4-FFF2-40B4-BE49-F238E27FC236}">
-                <a16:creationId xmlns:a16="http://schemas.microsoft.com/office/drawing/2014/main" id="{49ED8F0E-F38D-4851-B242-785A476D451C}"/>
+                <a16:creationId xmlns:a16="http://schemas.microsoft.com/office/drawing/2014/main" id="{36FD0DD0-ABA4-4F0E-B303-D093A512B222}"/>
               </a:ext>
             </a:extLst>
           </p:cNvPr>
@@ -3657,9 +4145,9 @@
           <a:bodyPr/>
           <a:lstStyle/>
           <a:p>
-            <a:fld id="{52CFA33C-6648-48C0-937A-91135B7D527E}" type="datetimeFigureOut">
+            <a:fld id="{3EAC4583-685E-409A-8A6A-9320C2082B0E}" type="datetimeFigureOut">
               <a:rPr lang="zh-CN" altLang="en-US" smtClean="0"/>
-              <a:t>2026/10/11</a:t>
+              <a:t>2026/10/12</a:t>
             </a:fld>
             <a:endParaRPr lang="zh-CN" altLang="en-US"/>
           </a:p>
@@ -3670,7 +4158,7 @@
           <p:cNvPr id="5" name="页脚占位符 4">
             <a:extLst>
               <a:ext uri="{FF2B5EF4-FFF2-40B4-BE49-F238E27FC236}">
-                <a16:creationId xmlns:a16="http://schemas.microsoft.com/office/drawing/2014/main" id="{EA8719FE-B416-4258-9BA5-B3D308749C09}"/>
+                <a16:creationId xmlns:a16="http://schemas.microsoft.com/office/drawing/2014/main" id="{D6D4997F-C03D-466A-BEC1-56458C13AE19}"/>
               </a:ext>
             </a:extLst>
           </p:cNvPr>
@@ -3695,7 +4183,7 @@
           <p:cNvPr id="6" name="灯片编号占位符 5">
             <a:extLst>
               <a:ext uri="{FF2B5EF4-FFF2-40B4-BE49-F238E27FC236}">
-                <a16:creationId xmlns:a16="http://schemas.microsoft.com/office/drawing/2014/main" id="{7363A291-1446-4F04-9C1C-93CFF8407C8A}"/>
+                <a16:creationId xmlns:a16="http://schemas.microsoft.com/office/drawing/2014/main" id="{A7D4E368-09AB-41B7-A053-5E5EA871DD83}"/>
               </a:ext>
             </a:extLst>
           </p:cNvPr>
@@ -3711,7 +4199,7 @@
           <a:bodyPr/>
           <a:lstStyle/>
           <a:p>
-            <a:fld id="{D1F306FC-4156-411C-BCB8-364FFCBFC11F}" type="slidenum">
+            <a:fld id="{BDA8BDE4-976D-47A8-ACF1-2157C40663B1}" type="slidenum">
               <a:rPr lang="zh-CN" altLang="en-US" smtClean="0"/>
               <a:t>‹#›</a:t>
             </a:fld>
@@ -3722,7 +4210,7 @@
     </p:spTree>
     <p:extLst>
       <p:ext uri="{BB962C8B-B14F-4D97-AF65-F5344CB8AC3E}">
-        <p14:creationId xmlns:p14="http://schemas.microsoft.com/office/powerpoint/2010/main" val="3134080529"/>
+        <p14:creationId xmlns:p14="http://schemas.microsoft.com/office/powerpoint/2010/main" val="3377157713"/>
       </p:ext>
     </p:extLst>
   </p:cSld>
@@ -3754,7 +4242,7 @@
           <p:cNvPr id="2" name="标题 1">
             <a:extLst>
               <a:ext uri="{FF2B5EF4-FFF2-40B4-BE49-F238E27FC236}">
-                <a16:creationId xmlns:a16="http://schemas.microsoft.com/office/drawing/2014/main" id="{7231130D-612F-4901-B6BC-340A236EB120}"/>
+                <a16:creationId xmlns:a16="http://schemas.microsoft.com/office/drawing/2014/main" id="{EC58E942-223A-4B8A-8A72-4C80FD67B451}"/>
               </a:ext>
             </a:extLst>
           </p:cNvPr>
@@ -3782,7 +4270,7 @@
           <p:cNvPr id="3" name="竖排文字占位符 2">
             <a:extLst>
               <a:ext uri="{FF2B5EF4-FFF2-40B4-BE49-F238E27FC236}">
-                <a16:creationId xmlns:a16="http://schemas.microsoft.com/office/drawing/2014/main" id="{ADB60FC5-A347-44E9-B087-916CF1C383D9}"/>
+                <a16:creationId xmlns:a16="http://schemas.microsoft.com/office/drawing/2014/main" id="{D374FAD8-D5E4-4B6C-AA48-D10D2289F824}"/>
               </a:ext>
             </a:extLst>
           </p:cNvPr>
@@ -3839,7 +4327,7 @@
           <p:cNvPr id="4" name="日期占位符 3">
             <a:extLst>
               <a:ext uri="{FF2B5EF4-FFF2-40B4-BE49-F238E27FC236}">
-                <a16:creationId xmlns:a16="http://schemas.microsoft.com/office/drawing/2014/main" id="{55E92854-793E-4305-9D14-B7301091CD59}"/>
+                <a16:creationId xmlns:a16="http://schemas.microsoft.com/office/drawing/2014/main" id="{09036286-263F-4438-9758-545C02055413}"/>
               </a:ext>
             </a:extLst>
           </p:cNvPr>
@@ -3855,9 +4343,9 @@
           <a:bodyPr/>
           <a:lstStyle/>
           <a:p>
-            <a:fld id="{52CFA33C-6648-48C0-937A-91135B7D527E}" type="datetimeFigureOut">
+            <a:fld id="{3EAC4583-685E-409A-8A6A-9320C2082B0E}" type="datetimeFigureOut">
               <a:rPr lang="zh-CN" altLang="en-US" smtClean="0"/>
-              <a:t>2026/10/11</a:t>
+              <a:t>2026/10/12</a:t>
             </a:fld>
             <a:endParaRPr lang="zh-CN" altLang="en-US"/>
           </a:p>
@@ -3868,7 +4356,7 @@
           <p:cNvPr id="5" name="页脚占位符 4">
             <a:extLst>
               <a:ext uri="{FF2B5EF4-FFF2-40B4-BE49-F238E27FC236}">
-                <a16:creationId xmlns:a16="http://schemas.microsoft.com/office/drawing/2014/main" id="{9CFE57A9-F092-428D-85A5-8E83A2090079}"/>
+                <a16:creationId xmlns:a16="http://schemas.microsoft.com/office/drawing/2014/main" id="{74DA061B-D386-49A2-BED6-BADC0D10731C}"/>
               </a:ext>
             </a:extLst>
           </p:cNvPr>
@@ -3893,7 +4381,7 @@
           <p:cNvPr id="6" name="灯片编号占位符 5">
             <a:extLst>
               <a:ext uri="{FF2B5EF4-FFF2-40B4-BE49-F238E27FC236}">
-                <a16:creationId xmlns:a16="http://schemas.microsoft.com/office/drawing/2014/main" id="{145D1F83-EA6D-474A-94FA-13043458D93D}"/>
+                <a16:creationId xmlns:a16="http://schemas.microsoft.com/office/drawing/2014/main" id="{2030DAD2-7441-47AD-BE35-05200ECC1D88}"/>
               </a:ext>
             </a:extLst>
           </p:cNvPr>
@@ -3909,7 +4397,7 @@
           <a:bodyPr/>
           <a:lstStyle/>
           <a:p>
-            <a:fld id="{D1F306FC-4156-411C-BCB8-364FFCBFC11F}" type="slidenum">
+            <a:fld id="{BDA8BDE4-976D-47A8-ACF1-2157C40663B1}" type="slidenum">
               <a:rPr lang="zh-CN" altLang="en-US" smtClean="0"/>
               <a:t>‹#›</a:t>
             </a:fld>
@@ -3920,7 +4408,7 @@
     </p:spTree>
     <p:extLst>
       <p:ext uri="{BB962C8B-B14F-4D97-AF65-F5344CB8AC3E}">
-        <p14:creationId xmlns:p14="http://schemas.microsoft.com/office/powerpoint/2010/main" val="286530567"/>
+        <p14:creationId xmlns:p14="http://schemas.microsoft.com/office/powerpoint/2010/main" val="1068149921"/>
       </p:ext>
     </p:extLst>
   </p:cSld>
@@ -3952,7 +4440,7 @@
           <p:cNvPr id="2" name="竖排标题 1">
             <a:extLst>
               <a:ext uri="{FF2B5EF4-FFF2-40B4-BE49-F238E27FC236}">
-                <a16:creationId xmlns:a16="http://schemas.microsoft.com/office/drawing/2014/main" id="{6516BF68-F928-4DAA-8BF2-7FFBCF60143B}"/>
+                <a16:creationId xmlns:a16="http://schemas.microsoft.com/office/drawing/2014/main" id="{C33ACB96-02E1-40BF-BFB1-1DFEE1D006CB}"/>
               </a:ext>
             </a:extLst>
           </p:cNvPr>
@@ -3985,7 +4473,7 @@
           <p:cNvPr id="3" name="竖排文字占位符 2">
             <a:extLst>
               <a:ext uri="{FF2B5EF4-FFF2-40B4-BE49-F238E27FC236}">
-                <a16:creationId xmlns:a16="http://schemas.microsoft.com/office/drawing/2014/main" id="{6C78A8F3-08CB-4266-BA81-50D566C45D4D}"/>
+                <a16:creationId xmlns:a16="http://schemas.microsoft.com/office/drawing/2014/main" id="{28C02134-500D-4B97-8A11-704A1BAEF65F}"/>
               </a:ext>
             </a:extLst>
           </p:cNvPr>
@@ -4047,7 +4535,7 @@
           <p:cNvPr id="4" name="日期占位符 3">
             <a:extLst>
               <a:ext uri="{FF2B5EF4-FFF2-40B4-BE49-F238E27FC236}">
-                <a16:creationId xmlns:a16="http://schemas.microsoft.com/office/drawing/2014/main" id="{D9958A5A-6902-4360-9CAD-CB0D11A3572C}"/>
+                <a16:creationId xmlns:a16="http://schemas.microsoft.com/office/drawing/2014/main" id="{8BD8A24D-2A65-40B3-9350-14D36BE77E1B}"/>
               </a:ext>
             </a:extLst>
           </p:cNvPr>
@@ -4063,9 +4551,9 @@
           <a:bodyPr/>
           <a:lstStyle/>
           <a:p>
-            <a:fld id="{52CFA33C-6648-48C0-937A-91135B7D527E}" type="datetimeFigureOut">
+            <a:fld id="{3EAC4583-685E-409A-8A6A-9320C2082B0E}" type="datetimeFigureOut">
               <a:rPr lang="zh-CN" altLang="en-US" smtClean="0"/>
-              <a:t>2026/10/11</a:t>
+              <a:t>2026/10/12</a:t>
             </a:fld>
             <a:endParaRPr lang="zh-CN" altLang="en-US"/>
           </a:p>
@@ -4076,7 +4564,7 @@
           <p:cNvPr id="5" name="页脚占位符 4">
             <a:extLst>
               <a:ext uri="{FF2B5EF4-FFF2-40B4-BE49-F238E27FC236}">
-                <a16:creationId xmlns:a16="http://schemas.microsoft.com/office/drawing/2014/main" id="{5120F767-5440-40E0-A2E8-930930BD07D8}"/>
+                <a16:creationId xmlns:a16="http://schemas.microsoft.com/office/drawing/2014/main" id="{C0D869DA-101C-4C88-8242-DA39A636D966}"/>
               </a:ext>
             </a:extLst>
           </p:cNvPr>
@@ -4101,7 +4589,7 @@
           <p:cNvPr id="6" name="灯片编号占位符 5">
             <a:extLst>
               <a:ext uri="{FF2B5EF4-FFF2-40B4-BE49-F238E27FC236}">
-                <a16:creationId xmlns:a16="http://schemas.microsoft.com/office/drawing/2014/main" id="{6D3B1EAA-B9E0-4AA2-84BD-E234A94CC3F4}"/>
+                <a16:creationId xmlns:a16="http://schemas.microsoft.com/office/drawing/2014/main" id="{0C78CDAE-3514-4751-8D8F-B328EF2B3C79}"/>
               </a:ext>
             </a:extLst>
           </p:cNvPr>
@@ -4117,7 +4605,7 @@
           <a:bodyPr/>
           <a:lstStyle/>
           <a:p>
-            <a:fld id="{D1F306FC-4156-411C-BCB8-364FFCBFC11F}" type="slidenum">
+            <a:fld id="{BDA8BDE4-976D-47A8-ACF1-2157C40663B1}" type="slidenum">
               <a:rPr lang="zh-CN" altLang="en-US" smtClean="0"/>
               <a:t>‹#›</a:t>
             </a:fld>
@@ -4128,7 +4616,7 @@
     </p:spTree>
     <p:extLst>
       <p:ext uri="{BB962C8B-B14F-4D97-AF65-F5344CB8AC3E}">
-        <p14:creationId xmlns:p14="http://schemas.microsoft.com/office/powerpoint/2010/main" val="2021237010"/>
+        <p14:creationId xmlns:p14="http://schemas.microsoft.com/office/powerpoint/2010/main" val="4130963176"/>
       </p:ext>
     </p:extLst>
   </p:cSld>
@@ -4160,7 +4648,7 @@
           <p:cNvPr id="2" name="标题 1">
             <a:extLst>
               <a:ext uri="{FF2B5EF4-FFF2-40B4-BE49-F238E27FC236}">
-                <a16:creationId xmlns:a16="http://schemas.microsoft.com/office/drawing/2014/main" id="{56D60165-9E25-4A15-8AB8-F450FC3DEA39}"/>
+                <a16:creationId xmlns:a16="http://schemas.microsoft.com/office/drawing/2014/main" id="{47955791-EBB9-46AD-BAD4-C55348BB24E8}"/>
               </a:ext>
             </a:extLst>
           </p:cNvPr>
@@ -4188,7 +4676,7 @@
           <p:cNvPr id="3" name="内容占位符 2">
             <a:extLst>
               <a:ext uri="{FF2B5EF4-FFF2-40B4-BE49-F238E27FC236}">
-                <a16:creationId xmlns:a16="http://schemas.microsoft.com/office/drawing/2014/main" id="{5A1C7A6C-8C1F-4B6E-AD53-918B8BFAC450}"/>
+                <a16:creationId xmlns:a16="http://schemas.microsoft.com/office/drawing/2014/main" id="{3ADEBAE3-B188-4C57-A0F4-2AB0E5E109D7}"/>
               </a:ext>
             </a:extLst>
           </p:cNvPr>
@@ -4245,7 +4733,7 @@
           <p:cNvPr id="4" name="日期占位符 3">
             <a:extLst>
               <a:ext uri="{FF2B5EF4-FFF2-40B4-BE49-F238E27FC236}">
-                <a16:creationId xmlns:a16="http://schemas.microsoft.com/office/drawing/2014/main" id="{FFA5626A-B1DA-42F9-8F05-38FAD34F7C58}"/>
+                <a16:creationId xmlns:a16="http://schemas.microsoft.com/office/drawing/2014/main" id="{4FA73F0A-5208-4F62-994B-FB5715FD742E}"/>
               </a:ext>
             </a:extLst>
           </p:cNvPr>
@@ -4261,9 +4749,9 @@
           <a:bodyPr/>
           <a:lstStyle/>
           <a:p>
-            <a:fld id="{52CFA33C-6648-48C0-937A-91135B7D527E}" type="datetimeFigureOut">
+            <a:fld id="{3EAC4583-685E-409A-8A6A-9320C2082B0E}" type="datetimeFigureOut">
               <a:rPr lang="zh-CN" altLang="en-US" smtClean="0"/>
-              <a:t>2026/10/11</a:t>
+              <a:t>2026/10/12</a:t>
             </a:fld>
             <a:endParaRPr lang="zh-CN" altLang="en-US"/>
           </a:p>
@@ -4274,7 +4762,7 @@
           <p:cNvPr id="5" name="页脚占位符 4">
             <a:extLst>
               <a:ext uri="{FF2B5EF4-FFF2-40B4-BE49-F238E27FC236}">
-                <a16:creationId xmlns:a16="http://schemas.microsoft.com/office/drawing/2014/main" id="{9F9F626E-9F3B-489C-8329-55C0A5A5BDE7}"/>
+                <a16:creationId xmlns:a16="http://schemas.microsoft.com/office/drawing/2014/main" id="{E84821A7-3DAC-4F69-AD74-94E1E0B9B537}"/>
               </a:ext>
             </a:extLst>
           </p:cNvPr>
@@ -4299,7 +4787,7 @@
           <p:cNvPr id="6" name="灯片编号占位符 5">
             <a:extLst>
               <a:ext uri="{FF2B5EF4-FFF2-40B4-BE49-F238E27FC236}">
-                <a16:creationId xmlns:a16="http://schemas.microsoft.com/office/drawing/2014/main" id="{F55055B9-271D-4025-946F-AD7619AD3D29}"/>
+                <a16:creationId xmlns:a16="http://schemas.microsoft.com/office/drawing/2014/main" id="{5576D22A-31C4-47F2-88AD-FE04141EF5F4}"/>
               </a:ext>
             </a:extLst>
           </p:cNvPr>
@@ -4315,7 +4803,7 @@
           <a:bodyPr/>
           <a:lstStyle/>
           <a:p>
-            <a:fld id="{D1F306FC-4156-411C-BCB8-364FFCBFC11F}" type="slidenum">
+            <a:fld id="{BDA8BDE4-976D-47A8-ACF1-2157C40663B1}" type="slidenum">
               <a:rPr lang="zh-CN" altLang="en-US" smtClean="0"/>
               <a:t>‹#›</a:t>
             </a:fld>
@@ -4326,7 +4814,7 @@
     </p:spTree>
     <p:extLst>
       <p:ext uri="{BB962C8B-B14F-4D97-AF65-F5344CB8AC3E}">
-        <p14:creationId xmlns:p14="http://schemas.microsoft.com/office/powerpoint/2010/main" val="744946909"/>
+        <p14:creationId xmlns:p14="http://schemas.microsoft.com/office/powerpoint/2010/main" val="653770852"/>
       </p:ext>
     </p:extLst>
   </p:cSld>
@@ -4358,7 +4846,7 @@
           <p:cNvPr id="2" name="标题 1">
             <a:extLst>
               <a:ext uri="{FF2B5EF4-FFF2-40B4-BE49-F238E27FC236}">
-                <a16:creationId xmlns:a16="http://schemas.microsoft.com/office/drawing/2014/main" id="{78A18617-862E-4DEF-B8E1-32DFE3FAAAFE}"/>
+                <a16:creationId xmlns:a16="http://schemas.microsoft.com/office/drawing/2014/main" id="{BE43B69F-2B21-4121-A9FA-3B1793789D8F}"/>
               </a:ext>
             </a:extLst>
           </p:cNvPr>
@@ -4395,7 +4883,7 @@
           <p:cNvPr id="3" name="文本占位符 2">
             <a:extLst>
               <a:ext uri="{FF2B5EF4-FFF2-40B4-BE49-F238E27FC236}">
-                <a16:creationId xmlns:a16="http://schemas.microsoft.com/office/drawing/2014/main" id="{9665AEDE-62F0-42D9-BBBB-6AEC0213A43A}"/>
+                <a16:creationId xmlns:a16="http://schemas.microsoft.com/office/drawing/2014/main" id="{FA0B18F8-85B8-4784-8775-755AACD78F85}"/>
               </a:ext>
             </a:extLst>
           </p:cNvPr>
@@ -4520,7 +5008,7 @@
           <p:cNvPr id="4" name="日期占位符 3">
             <a:extLst>
               <a:ext uri="{FF2B5EF4-FFF2-40B4-BE49-F238E27FC236}">
-                <a16:creationId xmlns:a16="http://schemas.microsoft.com/office/drawing/2014/main" id="{74E95B26-B47D-4E14-970E-CBD75DF50AB1}"/>
+                <a16:creationId xmlns:a16="http://schemas.microsoft.com/office/drawing/2014/main" id="{65A7F652-E781-44C0-B331-484ED2DA0273}"/>
               </a:ext>
             </a:extLst>
           </p:cNvPr>
@@ -4536,9 +5024,9 @@
           <a:bodyPr/>
           <a:lstStyle/>
           <a:p>
-            <a:fld id="{52CFA33C-6648-48C0-937A-91135B7D527E}" type="datetimeFigureOut">
+            <a:fld id="{3EAC4583-685E-409A-8A6A-9320C2082B0E}" type="datetimeFigureOut">
               <a:rPr lang="zh-CN" altLang="en-US" smtClean="0"/>
-              <a:t>2026/10/11</a:t>
+              <a:t>2026/10/12</a:t>
             </a:fld>
             <a:endParaRPr lang="zh-CN" altLang="en-US"/>
           </a:p>
@@ -4549,7 +5037,7 @@
           <p:cNvPr id="5" name="页脚占位符 4">
             <a:extLst>
               <a:ext uri="{FF2B5EF4-FFF2-40B4-BE49-F238E27FC236}">
-                <a16:creationId xmlns:a16="http://schemas.microsoft.com/office/drawing/2014/main" id="{A63A0976-2A0C-4EA5-9BE6-63DBAE0756C0}"/>
+                <a16:creationId xmlns:a16="http://schemas.microsoft.com/office/drawing/2014/main" id="{B589E8A1-C939-4BCC-970E-96294EF0567A}"/>
               </a:ext>
             </a:extLst>
           </p:cNvPr>
@@ -4574,7 +5062,7 @@
           <p:cNvPr id="6" name="灯片编号占位符 5">
             <a:extLst>
               <a:ext uri="{FF2B5EF4-FFF2-40B4-BE49-F238E27FC236}">
-                <a16:creationId xmlns:a16="http://schemas.microsoft.com/office/drawing/2014/main" id="{1F28ED94-4D97-4923-B2A0-DFF6654AE233}"/>
+                <a16:creationId xmlns:a16="http://schemas.microsoft.com/office/drawing/2014/main" id="{608B99DF-F7B7-46E7-89D7-F25C34AC2037}"/>
               </a:ext>
             </a:extLst>
           </p:cNvPr>
@@ -4590,7 +5078,7 @@
           <a:bodyPr/>
           <a:lstStyle/>
           <a:p>
-            <a:fld id="{D1F306FC-4156-411C-BCB8-364FFCBFC11F}" type="slidenum">
+            <a:fld id="{BDA8BDE4-976D-47A8-ACF1-2157C40663B1}" type="slidenum">
               <a:rPr lang="zh-CN" altLang="en-US" smtClean="0"/>
               <a:t>‹#›</a:t>
             </a:fld>
@@ -4601,7 +5089,7 @@
     </p:spTree>
     <p:extLst>
       <p:ext uri="{BB962C8B-B14F-4D97-AF65-F5344CB8AC3E}">
-        <p14:creationId xmlns:p14="http://schemas.microsoft.com/office/powerpoint/2010/main" val="2367839656"/>
+        <p14:creationId xmlns:p14="http://schemas.microsoft.com/office/powerpoint/2010/main" val="2218229564"/>
       </p:ext>
     </p:extLst>
   </p:cSld>
@@ -4633,7 +5121,7 @@
           <p:cNvPr id="2" name="标题 1">
             <a:extLst>
               <a:ext uri="{FF2B5EF4-FFF2-40B4-BE49-F238E27FC236}">
-                <a16:creationId xmlns:a16="http://schemas.microsoft.com/office/drawing/2014/main" id="{119E2733-29D9-4142-86C4-BAA315BA4839}"/>
+                <a16:creationId xmlns:a16="http://schemas.microsoft.com/office/drawing/2014/main" id="{82554EFF-C970-4F6A-A306-AF84C000F611}"/>
               </a:ext>
             </a:extLst>
           </p:cNvPr>
@@ -4661,7 +5149,7 @@
           <p:cNvPr id="3" name="内容占位符 2">
             <a:extLst>
               <a:ext uri="{FF2B5EF4-FFF2-40B4-BE49-F238E27FC236}">
-                <a16:creationId xmlns:a16="http://schemas.microsoft.com/office/drawing/2014/main" id="{F7173AAB-D932-4D1A-B19E-23D2981108B1}"/>
+                <a16:creationId xmlns:a16="http://schemas.microsoft.com/office/drawing/2014/main" id="{9ABC39E7-B0E0-4C52-B890-ADB6BD5600D6}"/>
               </a:ext>
             </a:extLst>
           </p:cNvPr>
@@ -4723,7 +5211,7 @@
           <p:cNvPr id="4" name="内容占位符 3">
             <a:extLst>
               <a:ext uri="{FF2B5EF4-FFF2-40B4-BE49-F238E27FC236}">
-                <a16:creationId xmlns:a16="http://schemas.microsoft.com/office/drawing/2014/main" id="{7C9CD3E0-15EA-46DD-BF38-C85346E624EB}"/>
+                <a16:creationId xmlns:a16="http://schemas.microsoft.com/office/drawing/2014/main" id="{6120EC9C-084B-4560-A74A-C5F0EA25F687}"/>
               </a:ext>
             </a:extLst>
           </p:cNvPr>
@@ -4785,7 +5273,7 @@
           <p:cNvPr id="5" name="日期占位符 4">
             <a:extLst>
               <a:ext uri="{FF2B5EF4-FFF2-40B4-BE49-F238E27FC236}">
-                <a16:creationId xmlns:a16="http://schemas.microsoft.com/office/drawing/2014/main" id="{E2D1E017-18BE-4635-847D-7B923F69C87E}"/>
+                <a16:creationId xmlns:a16="http://schemas.microsoft.com/office/drawing/2014/main" id="{2B1EBACA-3B34-4D55-92E3-5B19CEBAB266}"/>
               </a:ext>
             </a:extLst>
           </p:cNvPr>
@@ -4801,9 +5289,9 @@
           <a:bodyPr/>
           <a:lstStyle/>
           <a:p>
-            <a:fld id="{52CFA33C-6648-48C0-937A-91135B7D527E}" type="datetimeFigureOut">
+            <a:fld id="{3EAC4583-685E-409A-8A6A-9320C2082B0E}" type="datetimeFigureOut">
               <a:rPr lang="zh-CN" altLang="en-US" smtClean="0"/>
-              <a:t>2026/10/11</a:t>
+              <a:t>2026/10/12</a:t>
             </a:fld>
             <a:endParaRPr lang="zh-CN" altLang="en-US"/>
           </a:p>
@@ -4814,7 +5302,7 @@
           <p:cNvPr id="6" name="页脚占位符 5">
             <a:extLst>
               <a:ext uri="{FF2B5EF4-FFF2-40B4-BE49-F238E27FC236}">
-                <a16:creationId xmlns:a16="http://schemas.microsoft.com/office/drawing/2014/main" id="{13F43B32-89AD-41AB-8ADE-B7A147EA4994}"/>
+                <a16:creationId xmlns:a16="http://schemas.microsoft.com/office/drawing/2014/main" id="{82B88A25-71D0-437F-BB6C-6E1F155FF3A0}"/>
               </a:ext>
             </a:extLst>
           </p:cNvPr>
@@ -4839,7 +5327,7 @@
           <p:cNvPr id="7" name="灯片编号占位符 6">
             <a:extLst>
               <a:ext uri="{FF2B5EF4-FFF2-40B4-BE49-F238E27FC236}">
-                <a16:creationId xmlns:a16="http://schemas.microsoft.com/office/drawing/2014/main" id="{C2354B59-9B0D-4DF5-87BE-2FF9F8126B5C}"/>
+                <a16:creationId xmlns:a16="http://schemas.microsoft.com/office/drawing/2014/main" id="{B1BD0F00-6B9B-4089-A443-ED48129C96E6}"/>
               </a:ext>
             </a:extLst>
           </p:cNvPr>
@@ -4855,7 +5343,7 @@
           <a:bodyPr/>
           <a:lstStyle/>
           <a:p>
-            <a:fld id="{D1F306FC-4156-411C-BCB8-364FFCBFC11F}" type="slidenum">
+            <a:fld id="{BDA8BDE4-976D-47A8-ACF1-2157C40663B1}" type="slidenum">
               <a:rPr lang="zh-CN" altLang="en-US" smtClean="0"/>
               <a:t>‹#›</a:t>
             </a:fld>
@@ -4866,7 +5354,7 @@
     </p:spTree>
     <p:extLst>
       <p:ext uri="{BB962C8B-B14F-4D97-AF65-F5344CB8AC3E}">
-        <p14:creationId xmlns:p14="http://schemas.microsoft.com/office/powerpoint/2010/main" val="3019388864"/>
+        <p14:creationId xmlns:p14="http://schemas.microsoft.com/office/powerpoint/2010/main" val="543455176"/>
       </p:ext>
     </p:extLst>
   </p:cSld>
@@ -4898,7 +5386,7 @@
           <p:cNvPr id="2" name="标题 1">
             <a:extLst>
               <a:ext uri="{FF2B5EF4-FFF2-40B4-BE49-F238E27FC236}">
-                <a16:creationId xmlns:a16="http://schemas.microsoft.com/office/drawing/2014/main" id="{83057644-2FF5-478B-9279-ABD2FC0B40DC}"/>
+                <a16:creationId xmlns:a16="http://schemas.microsoft.com/office/drawing/2014/main" id="{05ECE455-159E-476C-9FE4-E6AC1EED80CC}"/>
               </a:ext>
             </a:extLst>
           </p:cNvPr>
@@ -4931,7 +5419,7 @@
           <p:cNvPr id="3" name="文本占位符 2">
             <a:extLst>
               <a:ext uri="{FF2B5EF4-FFF2-40B4-BE49-F238E27FC236}">
-                <a16:creationId xmlns:a16="http://schemas.microsoft.com/office/drawing/2014/main" id="{B8FB8521-E21F-435D-A74A-E8EA9572E78B}"/>
+                <a16:creationId xmlns:a16="http://schemas.microsoft.com/office/drawing/2014/main" id="{DFBA311D-0147-4E7A-BB6B-593DE2DCF1B3}"/>
               </a:ext>
             </a:extLst>
           </p:cNvPr>
@@ -5002,7 +5490,7 @@
           <p:cNvPr id="4" name="内容占位符 3">
             <a:extLst>
               <a:ext uri="{FF2B5EF4-FFF2-40B4-BE49-F238E27FC236}">
-                <a16:creationId xmlns:a16="http://schemas.microsoft.com/office/drawing/2014/main" id="{FBF582B1-167F-460D-A44B-886471131436}"/>
+                <a16:creationId xmlns:a16="http://schemas.microsoft.com/office/drawing/2014/main" id="{FA2B89A9-0394-4B52-A3BE-DFE5B113E278}"/>
               </a:ext>
             </a:extLst>
           </p:cNvPr>
@@ -5064,7 +5552,7 @@
           <p:cNvPr id="5" name="文本占位符 4">
             <a:extLst>
               <a:ext uri="{FF2B5EF4-FFF2-40B4-BE49-F238E27FC236}">
-                <a16:creationId xmlns:a16="http://schemas.microsoft.com/office/drawing/2014/main" id="{B03DA8C4-B998-495D-9D19-5ECA4641A531}"/>
+                <a16:creationId xmlns:a16="http://schemas.microsoft.com/office/drawing/2014/main" id="{64C3AD7E-C727-4C67-8B61-2087159AA55B}"/>
               </a:ext>
             </a:extLst>
           </p:cNvPr>
@@ -5135,7 +5623,7 @@
           <p:cNvPr id="6" name="内容占位符 5">
             <a:extLst>
               <a:ext uri="{FF2B5EF4-FFF2-40B4-BE49-F238E27FC236}">
-                <a16:creationId xmlns:a16="http://schemas.microsoft.com/office/drawing/2014/main" id="{D5891988-1617-4C93-AF45-EEFBD753FA21}"/>
+                <a16:creationId xmlns:a16="http://schemas.microsoft.com/office/drawing/2014/main" id="{3DC9FB57-77E2-4B8F-9B6B-3BB07546CF80}"/>
               </a:ext>
             </a:extLst>
           </p:cNvPr>
@@ -5197,7 +5685,7 @@
           <p:cNvPr id="7" name="日期占位符 6">
             <a:extLst>
               <a:ext uri="{FF2B5EF4-FFF2-40B4-BE49-F238E27FC236}">
-                <a16:creationId xmlns:a16="http://schemas.microsoft.com/office/drawing/2014/main" id="{12DC45B4-51C1-44FB-98EE-FD7CFBFD29DA}"/>
+                <a16:creationId xmlns:a16="http://schemas.microsoft.com/office/drawing/2014/main" id="{360AB226-5F2C-4606-9254-DF411FEA0AC1}"/>
               </a:ext>
             </a:extLst>
           </p:cNvPr>
@@ -5213,9 +5701,9 @@
           <a:bodyPr/>
           <a:lstStyle/>
           <a:p>
-            <a:fld id="{52CFA33C-6648-48C0-937A-91135B7D527E}" type="datetimeFigureOut">
+            <a:fld id="{3EAC4583-685E-409A-8A6A-9320C2082B0E}" type="datetimeFigureOut">
               <a:rPr lang="zh-CN" altLang="en-US" smtClean="0"/>
-              <a:t>2026/10/11</a:t>
+              <a:t>2026/10/12</a:t>
             </a:fld>
             <a:endParaRPr lang="zh-CN" altLang="en-US"/>
           </a:p>
@@ -5226,7 +5714,7 @@
           <p:cNvPr id="8" name="页脚占位符 7">
             <a:extLst>
               <a:ext uri="{FF2B5EF4-FFF2-40B4-BE49-F238E27FC236}">
-                <a16:creationId xmlns:a16="http://schemas.microsoft.com/office/drawing/2014/main" id="{0F91FE52-6494-489D-9554-BAA80F867CD6}"/>
+                <a16:creationId xmlns:a16="http://schemas.microsoft.com/office/drawing/2014/main" id="{10B00AD2-E7F9-4493-AE20-8BFD020C9F43}"/>
               </a:ext>
             </a:extLst>
           </p:cNvPr>
@@ -5251,7 +5739,7 @@
           <p:cNvPr id="9" name="灯片编号占位符 8">
             <a:extLst>
               <a:ext uri="{FF2B5EF4-FFF2-40B4-BE49-F238E27FC236}">
-                <a16:creationId xmlns:a16="http://schemas.microsoft.com/office/drawing/2014/main" id="{8DE5FA83-0CC1-497E-B8B8-A9B26D13009C}"/>
+                <a16:creationId xmlns:a16="http://schemas.microsoft.com/office/drawing/2014/main" id="{E3A3384C-485B-45A9-A356-1FC6BF0A2B7C}"/>
               </a:ext>
             </a:extLst>
           </p:cNvPr>
@@ -5267,7 +5755,7 @@
           <a:bodyPr/>
           <a:lstStyle/>
           <a:p>
-            <a:fld id="{D1F306FC-4156-411C-BCB8-364FFCBFC11F}" type="slidenum">
+            <a:fld id="{BDA8BDE4-976D-47A8-ACF1-2157C40663B1}" type="slidenum">
               <a:rPr lang="zh-CN" altLang="en-US" smtClean="0"/>
               <a:t>‹#›</a:t>
             </a:fld>
@@ -5278,7 +5766,7 @@
     </p:spTree>
     <p:extLst>
       <p:ext uri="{BB962C8B-B14F-4D97-AF65-F5344CB8AC3E}">
-        <p14:creationId xmlns:p14="http://schemas.microsoft.com/office/powerpoint/2010/main" val="3576812497"/>
+        <p14:creationId xmlns:p14="http://schemas.microsoft.com/office/powerpoint/2010/main" val="1329219884"/>
       </p:ext>
     </p:extLst>
   </p:cSld>
@@ -5310,7 +5798,7 @@
           <p:cNvPr id="2" name="标题 1">
             <a:extLst>
               <a:ext uri="{FF2B5EF4-FFF2-40B4-BE49-F238E27FC236}">
-                <a16:creationId xmlns:a16="http://schemas.microsoft.com/office/drawing/2014/main" id="{D7250280-C586-4B4F-94EB-C6722B2101CE}"/>
+                <a16:creationId xmlns:a16="http://schemas.microsoft.com/office/drawing/2014/main" id="{CF352540-6D7C-407D-ABBF-B3E6AFE26F8E}"/>
               </a:ext>
             </a:extLst>
           </p:cNvPr>
@@ -5338,7 +5826,7 @@
           <p:cNvPr id="3" name="日期占位符 2">
             <a:extLst>
               <a:ext uri="{FF2B5EF4-FFF2-40B4-BE49-F238E27FC236}">
-                <a16:creationId xmlns:a16="http://schemas.microsoft.com/office/drawing/2014/main" id="{CF67ACC4-EF2C-4CBA-A75F-D77C6999FD50}"/>
+                <a16:creationId xmlns:a16="http://schemas.microsoft.com/office/drawing/2014/main" id="{638A76C6-4FA4-4298-965C-28CB87737FAB}"/>
               </a:ext>
             </a:extLst>
           </p:cNvPr>
@@ -5354,9 +5842,9 @@
           <a:bodyPr/>
           <a:lstStyle/>
           <a:p>
-            <a:fld id="{52CFA33C-6648-48C0-937A-91135B7D527E}" type="datetimeFigureOut">
+            <a:fld id="{3EAC4583-685E-409A-8A6A-9320C2082B0E}" type="datetimeFigureOut">
               <a:rPr lang="zh-CN" altLang="en-US" smtClean="0"/>
-              <a:t>2026/10/11</a:t>
+              <a:t>2026/10/12</a:t>
             </a:fld>
             <a:endParaRPr lang="zh-CN" altLang="en-US"/>
           </a:p>
@@ -5367,7 +5855,7 @@
           <p:cNvPr id="4" name="页脚占位符 3">
             <a:extLst>
               <a:ext uri="{FF2B5EF4-FFF2-40B4-BE49-F238E27FC236}">
-                <a16:creationId xmlns:a16="http://schemas.microsoft.com/office/drawing/2014/main" id="{12E0B2DC-8443-41DE-929A-63D757C2567E}"/>
+                <a16:creationId xmlns:a16="http://schemas.microsoft.com/office/drawing/2014/main" id="{59E50648-AF16-4D90-9D13-9C2DB8E4C991}"/>
               </a:ext>
             </a:extLst>
           </p:cNvPr>
@@ -5392,7 +5880,7 @@
           <p:cNvPr id="5" name="灯片编号占位符 4">
             <a:extLst>
               <a:ext uri="{FF2B5EF4-FFF2-40B4-BE49-F238E27FC236}">
-                <a16:creationId xmlns:a16="http://schemas.microsoft.com/office/drawing/2014/main" id="{08C18F45-74FB-44BC-BDBD-22D932876B89}"/>
+                <a16:creationId xmlns:a16="http://schemas.microsoft.com/office/drawing/2014/main" id="{94CA9301-7BEE-483A-A84D-C1B6B892700E}"/>
               </a:ext>
             </a:extLst>
           </p:cNvPr>
@@ -5408,7 +5896,7 @@
           <a:bodyPr/>
           <a:lstStyle/>
           <a:p>
-            <a:fld id="{D1F306FC-4156-411C-BCB8-364FFCBFC11F}" type="slidenum">
+            <a:fld id="{BDA8BDE4-976D-47A8-ACF1-2157C40663B1}" type="slidenum">
               <a:rPr lang="zh-CN" altLang="en-US" smtClean="0"/>
               <a:t>‹#›</a:t>
             </a:fld>
@@ -5419,7 +5907,7 @@
     </p:spTree>
     <p:extLst>
       <p:ext uri="{BB962C8B-B14F-4D97-AF65-F5344CB8AC3E}">
-        <p14:creationId xmlns:p14="http://schemas.microsoft.com/office/powerpoint/2010/main" val="3249965564"/>
+        <p14:creationId xmlns:p14="http://schemas.microsoft.com/office/powerpoint/2010/main" val="1824036142"/>
       </p:ext>
     </p:extLst>
   </p:cSld>
@@ -5451,7 +5939,7 @@
           <p:cNvPr id="2" name="日期占位符 1">
             <a:extLst>
               <a:ext uri="{FF2B5EF4-FFF2-40B4-BE49-F238E27FC236}">
-                <a16:creationId xmlns:a16="http://schemas.microsoft.com/office/drawing/2014/main" id="{973884CE-2B8E-4F03-92BD-2810E4DE3EFA}"/>
+                <a16:creationId xmlns:a16="http://schemas.microsoft.com/office/drawing/2014/main" id="{92C2030E-6C15-44D1-AE3C-D5EC1A962F49}"/>
               </a:ext>
             </a:extLst>
           </p:cNvPr>
@@ -5467,9 +5955,9 @@
           <a:bodyPr/>
           <a:lstStyle/>
           <a:p>
-            <a:fld id="{52CFA33C-6648-48C0-937A-91135B7D527E}" type="datetimeFigureOut">
+            <a:fld id="{3EAC4583-685E-409A-8A6A-9320C2082B0E}" type="datetimeFigureOut">
               <a:rPr lang="zh-CN" altLang="en-US" smtClean="0"/>
-              <a:t>2026/10/11</a:t>
+              <a:t>2026/10/12</a:t>
             </a:fld>
             <a:endParaRPr lang="zh-CN" altLang="en-US"/>
           </a:p>
@@ -5480,7 +5968,7 @@
           <p:cNvPr id="3" name="页脚占位符 2">
             <a:extLst>
               <a:ext uri="{FF2B5EF4-FFF2-40B4-BE49-F238E27FC236}">
-                <a16:creationId xmlns:a16="http://schemas.microsoft.com/office/drawing/2014/main" id="{46EEA6BF-CC35-4B64-88F6-F1B67A92F43F}"/>
+                <a16:creationId xmlns:a16="http://schemas.microsoft.com/office/drawing/2014/main" id="{341E78B0-A177-43D1-BCD3-4005157E77A3}"/>
               </a:ext>
             </a:extLst>
           </p:cNvPr>
@@ -5505,7 +5993,7 @@
           <p:cNvPr id="4" name="灯片编号占位符 3">
             <a:extLst>
               <a:ext uri="{FF2B5EF4-FFF2-40B4-BE49-F238E27FC236}">
-                <a16:creationId xmlns:a16="http://schemas.microsoft.com/office/drawing/2014/main" id="{BE406F56-3C5E-460D-B0A2-50E0DB640EDA}"/>
+                <a16:creationId xmlns:a16="http://schemas.microsoft.com/office/drawing/2014/main" id="{BB1E1376-D2DD-4187-820F-C436D958D550}"/>
               </a:ext>
             </a:extLst>
           </p:cNvPr>
@@ -5521,7 +6009,7 @@
           <a:bodyPr/>
           <a:lstStyle/>
           <a:p>
-            <a:fld id="{D1F306FC-4156-411C-BCB8-364FFCBFC11F}" type="slidenum">
+            <a:fld id="{BDA8BDE4-976D-47A8-ACF1-2157C40663B1}" type="slidenum">
               <a:rPr lang="zh-CN" altLang="en-US" smtClean="0"/>
               <a:t>‹#›</a:t>
             </a:fld>
@@ -5532,7 +6020,7 @@
     </p:spTree>
     <p:extLst>
       <p:ext uri="{BB962C8B-B14F-4D97-AF65-F5344CB8AC3E}">
-        <p14:creationId xmlns:p14="http://schemas.microsoft.com/office/powerpoint/2010/main" val="2748634173"/>
+        <p14:creationId xmlns:p14="http://schemas.microsoft.com/office/powerpoint/2010/main" val="2096375568"/>
       </p:ext>
     </p:extLst>
   </p:cSld>
@@ -5564,7 +6052,7 @@
           <p:cNvPr id="2" name="标题 1">
             <a:extLst>
               <a:ext uri="{FF2B5EF4-FFF2-40B4-BE49-F238E27FC236}">
-                <a16:creationId xmlns:a16="http://schemas.microsoft.com/office/drawing/2014/main" id="{74D0B437-0045-49A6-8EDF-61AC5586A735}"/>
+                <a16:creationId xmlns:a16="http://schemas.microsoft.com/office/drawing/2014/main" id="{50FEF6A6-AFA8-49BE-9E2B-F2F8D4002C4A}"/>
               </a:ext>
             </a:extLst>
           </p:cNvPr>
@@ -5601,7 +6089,7 @@
           <p:cNvPr id="3" name="内容占位符 2">
             <a:extLst>
               <a:ext uri="{FF2B5EF4-FFF2-40B4-BE49-F238E27FC236}">
-                <a16:creationId xmlns:a16="http://schemas.microsoft.com/office/drawing/2014/main" id="{D0B5D684-C601-49A5-97FC-95DDE22018A6}"/>
+                <a16:creationId xmlns:a16="http://schemas.microsoft.com/office/drawing/2014/main" id="{A6C91FB2-B999-4E3B-9FA5-9856A365FF01}"/>
               </a:ext>
             </a:extLst>
           </p:cNvPr>
@@ -5691,7 +6179,7 @@
           <p:cNvPr id="4" name="文本占位符 3">
             <a:extLst>
               <a:ext uri="{FF2B5EF4-FFF2-40B4-BE49-F238E27FC236}">
-                <a16:creationId xmlns:a16="http://schemas.microsoft.com/office/drawing/2014/main" id="{B8461638-7DF2-432C-81DC-09E03E326763}"/>
+                <a16:creationId xmlns:a16="http://schemas.microsoft.com/office/drawing/2014/main" id="{0805AA33-B2DF-40C8-ACD0-909D7C28BF85}"/>
               </a:ext>
             </a:extLst>
           </p:cNvPr>
@@ -5762,7 +6250,7 @@
           <p:cNvPr id="5" name="日期占位符 4">
             <a:extLst>
               <a:ext uri="{FF2B5EF4-FFF2-40B4-BE49-F238E27FC236}">
-                <a16:creationId xmlns:a16="http://schemas.microsoft.com/office/drawing/2014/main" id="{D2D1E138-441C-441C-ABF8-38696783C488}"/>
+                <a16:creationId xmlns:a16="http://schemas.microsoft.com/office/drawing/2014/main" id="{94810B5C-E919-47CC-9CA5-81D1419CEA87}"/>
               </a:ext>
             </a:extLst>
           </p:cNvPr>
@@ -5778,9 +6266,9 @@
           <a:bodyPr/>
           <a:lstStyle/>
           <a:p>
-            <a:fld id="{52CFA33C-6648-48C0-937A-91135B7D527E}" type="datetimeFigureOut">
+            <a:fld id="{3EAC4583-685E-409A-8A6A-9320C2082B0E}" type="datetimeFigureOut">
               <a:rPr lang="zh-CN" altLang="en-US" smtClean="0"/>
-              <a:t>2026/10/11</a:t>
+              <a:t>2026/10/12</a:t>
             </a:fld>
             <a:endParaRPr lang="zh-CN" altLang="en-US"/>
           </a:p>
@@ -5791,7 +6279,7 @@
           <p:cNvPr id="6" name="页脚占位符 5">
             <a:extLst>
               <a:ext uri="{FF2B5EF4-FFF2-40B4-BE49-F238E27FC236}">
-                <a16:creationId xmlns:a16="http://schemas.microsoft.com/office/drawing/2014/main" id="{8F8C9BAC-F542-42A2-B342-FEB51CA6CE6A}"/>
+                <a16:creationId xmlns:a16="http://schemas.microsoft.com/office/drawing/2014/main" id="{A66A7EFA-D33E-4AB3-BBA0-88EA3B7FB420}"/>
               </a:ext>
             </a:extLst>
           </p:cNvPr>
@@ -5816,7 +6304,7 @@
           <p:cNvPr id="7" name="灯片编号占位符 6">
             <a:extLst>
               <a:ext uri="{FF2B5EF4-FFF2-40B4-BE49-F238E27FC236}">
-                <a16:creationId xmlns:a16="http://schemas.microsoft.com/office/drawing/2014/main" id="{93E2BFB7-1836-44F7-AA16-EE445B8C9A92}"/>
+                <a16:creationId xmlns:a16="http://schemas.microsoft.com/office/drawing/2014/main" id="{A394E6B8-B1C2-4FDF-8756-F56B2879776E}"/>
               </a:ext>
             </a:extLst>
           </p:cNvPr>
@@ -5832,7 +6320,7 @@
           <a:bodyPr/>
           <a:lstStyle/>
           <a:p>
-            <a:fld id="{D1F306FC-4156-411C-BCB8-364FFCBFC11F}" type="slidenum">
+            <a:fld id="{BDA8BDE4-976D-47A8-ACF1-2157C40663B1}" type="slidenum">
               <a:rPr lang="zh-CN" altLang="en-US" smtClean="0"/>
               <a:t>‹#›</a:t>
             </a:fld>
@@ -5843,7 +6331,7 @@
     </p:spTree>
     <p:extLst>
       <p:ext uri="{BB962C8B-B14F-4D97-AF65-F5344CB8AC3E}">
-        <p14:creationId xmlns:p14="http://schemas.microsoft.com/office/powerpoint/2010/main" val="3746733225"/>
+        <p14:creationId xmlns:p14="http://schemas.microsoft.com/office/powerpoint/2010/main" val="832055746"/>
       </p:ext>
     </p:extLst>
   </p:cSld>
@@ -5875,7 +6363,7 @@
           <p:cNvPr id="2" name="标题 1">
             <a:extLst>
               <a:ext uri="{FF2B5EF4-FFF2-40B4-BE49-F238E27FC236}">
-                <a16:creationId xmlns:a16="http://schemas.microsoft.com/office/drawing/2014/main" id="{9A69B80B-1E9D-453B-9D1D-B3B1DD91A20E}"/>
+                <a16:creationId xmlns:a16="http://schemas.microsoft.com/office/drawing/2014/main" id="{98B1C6F3-4FD4-4B3C-B74C-028D4EE04991}"/>
               </a:ext>
             </a:extLst>
           </p:cNvPr>
@@ -5912,7 +6400,7 @@
           <p:cNvPr id="3" name="图片占位符 2">
             <a:extLst>
               <a:ext uri="{FF2B5EF4-FFF2-40B4-BE49-F238E27FC236}">
-                <a16:creationId xmlns:a16="http://schemas.microsoft.com/office/drawing/2014/main" id="{81D5B428-AC3F-4205-8084-542CF5DF02A1}"/>
+                <a16:creationId xmlns:a16="http://schemas.microsoft.com/office/drawing/2014/main" id="{AFE004CE-963A-4B20-9AF0-2EB28B415E70}"/>
               </a:ext>
             </a:extLst>
           </p:cNvPr>
@@ -5979,7 +6467,7 @@
           <p:cNvPr id="4" name="文本占位符 3">
             <a:extLst>
               <a:ext uri="{FF2B5EF4-FFF2-40B4-BE49-F238E27FC236}">
-                <a16:creationId xmlns:a16="http://schemas.microsoft.com/office/drawing/2014/main" id="{81EE8BAA-FE8D-426F-BA92-906FD0A78D18}"/>
+                <a16:creationId xmlns:a16="http://schemas.microsoft.com/office/drawing/2014/main" id="{A196998F-19E2-4DDB-8517-255667FC1343}"/>
               </a:ext>
             </a:extLst>
           </p:cNvPr>
@@ -6050,7 +6538,7 @@
           <p:cNvPr id="5" name="日期占位符 4">
             <a:extLst>
               <a:ext uri="{FF2B5EF4-FFF2-40B4-BE49-F238E27FC236}">
-                <a16:creationId xmlns:a16="http://schemas.microsoft.com/office/drawing/2014/main" id="{09FA09B0-DF83-4035-8DCD-CB01F14BC38C}"/>
+                <a16:creationId xmlns:a16="http://schemas.microsoft.com/office/drawing/2014/main" id="{41DBE8A7-1E45-42E8-AB7B-34D5C2D4C64B}"/>
               </a:ext>
             </a:extLst>
           </p:cNvPr>
@@ -6066,9 +6554,9 @@
           <a:bodyPr/>
           <a:lstStyle/>
           <a:p>
-            <a:fld id="{52CFA33C-6648-48C0-937A-91135B7D527E}" type="datetimeFigureOut">
+            <a:fld id="{3EAC4583-685E-409A-8A6A-9320C2082B0E}" type="datetimeFigureOut">
               <a:rPr lang="zh-CN" altLang="en-US" smtClean="0"/>
-              <a:t>2026/10/11</a:t>
+              <a:t>2026/10/12</a:t>
             </a:fld>
             <a:endParaRPr lang="zh-CN" altLang="en-US"/>
           </a:p>
@@ -6079,7 +6567,7 @@
           <p:cNvPr id="6" name="页脚占位符 5">
             <a:extLst>
               <a:ext uri="{FF2B5EF4-FFF2-40B4-BE49-F238E27FC236}">
-                <a16:creationId xmlns:a16="http://schemas.microsoft.com/office/drawing/2014/main" id="{44C7F8A2-47F5-43D3-A4E7-95F0D52AF425}"/>
+                <a16:creationId xmlns:a16="http://schemas.microsoft.com/office/drawing/2014/main" id="{45524FBE-F916-4A9C-AF56-AB93BB61A887}"/>
               </a:ext>
             </a:extLst>
           </p:cNvPr>
@@ -6104,7 +6592,7 @@
           <p:cNvPr id="7" name="灯片编号占位符 6">
             <a:extLst>
               <a:ext uri="{FF2B5EF4-FFF2-40B4-BE49-F238E27FC236}">
-                <a16:creationId xmlns:a16="http://schemas.microsoft.com/office/drawing/2014/main" id="{481EE27E-B841-4AB0-B8AC-BB84B2CA390B}"/>
+                <a16:creationId xmlns:a16="http://schemas.microsoft.com/office/drawing/2014/main" id="{B6E018F9-EA8F-4036-9092-573440A1481F}"/>
               </a:ext>
             </a:extLst>
           </p:cNvPr>
@@ -6120,7 +6608,7 @@
           <a:bodyPr/>
           <a:lstStyle/>
           <a:p>
-            <a:fld id="{D1F306FC-4156-411C-BCB8-364FFCBFC11F}" type="slidenum">
+            <a:fld id="{BDA8BDE4-976D-47A8-ACF1-2157C40663B1}" type="slidenum">
               <a:rPr lang="zh-CN" altLang="en-US" smtClean="0"/>
               <a:t>‹#›</a:t>
             </a:fld>
@@ -6131,7 +6619,7 @@
     </p:spTree>
     <p:extLst>
       <p:ext uri="{BB962C8B-B14F-4D97-AF65-F5344CB8AC3E}">
-        <p14:creationId xmlns:p14="http://schemas.microsoft.com/office/powerpoint/2010/main" val="2729110777"/>
+        <p14:creationId xmlns:p14="http://schemas.microsoft.com/office/powerpoint/2010/main" val="2191481648"/>
       </p:ext>
     </p:extLst>
   </p:cSld>
@@ -6168,7 +6656,7 @@
           <p:cNvPr id="2" name="标题占位符 1">
             <a:extLst>
               <a:ext uri="{FF2B5EF4-FFF2-40B4-BE49-F238E27FC236}">
-                <a16:creationId xmlns:a16="http://schemas.microsoft.com/office/drawing/2014/main" id="{5F69D891-B825-443B-B3E4-850A90AA29AC}"/>
+                <a16:creationId xmlns:a16="http://schemas.microsoft.com/office/drawing/2014/main" id="{F5DAA66A-2448-4313-BC77-0D4D219E3D93}"/>
               </a:ext>
             </a:extLst>
           </p:cNvPr>
@@ -6206,7 +6694,7 @@
           <p:cNvPr id="3" name="文本占位符 2">
             <a:extLst>
               <a:ext uri="{FF2B5EF4-FFF2-40B4-BE49-F238E27FC236}">
-                <a16:creationId xmlns:a16="http://schemas.microsoft.com/office/drawing/2014/main" id="{53A32270-DFA3-4A64-B4C1-24EF86A6595D}"/>
+                <a16:creationId xmlns:a16="http://schemas.microsoft.com/office/drawing/2014/main" id="{256AD041-280C-437B-A3F2-52F64982FBB4}"/>
               </a:ext>
             </a:extLst>
           </p:cNvPr>
@@ -6273,7 +6761,7 @@
           <p:cNvPr id="4" name="日期占位符 3">
             <a:extLst>
               <a:ext uri="{FF2B5EF4-FFF2-40B4-BE49-F238E27FC236}">
-                <a16:creationId xmlns:a16="http://schemas.microsoft.com/office/drawing/2014/main" id="{7260A397-D42E-4331-BBCD-13A1754452FE}"/>
+                <a16:creationId xmlns:a16="http://schemas.microsoft.com/office/drawing/2014/main" id="{2F68AB8D-6921-4D20-8CFA-72779A4A28C7}"/>
               </a:ext>
             </a:extLst>
           </p:cNvPr>
@@ -6307,9 +6795,9 @@
             </a:lvl1pPr>
           </a:lstStyle>
           <a:p>
-            <a:fld id="{52CFA33C-6648-48C0-937A-91135B7D527E}" type="datetimeFigureOut">
+            <a:fld id="{3EAC4583-685E-409A-8A6A-9320C2082B0E}" type="datetimeFigureOut">
               <a:rPr lang="zh-CN" altLang="en-US" smtClean="0"/>
-              <a:t>2026/10/11</a:t>
+              <a:t>2026/10/12</a:t>
             </a:fld>
             <a:endParaRPr lang="zh-CN" altLang="en-US"/>
           </a:p>
@@ -6320,7 +6808,7 @@
           <p:cNvPr id="5" name="页脚占位符 4">
             <a:extLst>
               <a:ext uri="{FF2B5EF4-FFF2-40B4-BE49-F238E27FC236}">
-                <a16:creationId xmlns:a16="http://schemas.microsoft.com/office/drawing/2014/main" id="{192D53E1-42F5-45CD-9DD7-B5C3DA2BAC7E}"/>
+                <a16:creationId xmlns:a16="http://schemas.microsoft.com/office/drawing/2014/main" id="{3704A685-A52F-49B3-9138-A492986BFAB6}"/>
               </a:ext>
             </a:extLst>
           </p:cNvPr>
@@ -6363,7 +6851,7 @@
           <p:cNvPr id="6" name="灯片编号占位符 5">
             <a:extLst>
               <a:ext uri="{FF2B5EF4-FFF2-40B4-BE49-F238E27FC236}">
-                <a16:creationId xmlns:a16="http://schemas.microsoft.com/office/drawing/2014/main" id="{8CAD6381-79B5-49E9-92AF-9828D6982B01}"/>
+                <a16:creationId xmlns:a16="http://schemas.microsoft.com/office/drawing/2014/main" id="{B18D90CA-6E45-457B-BAC3-3C64B09CF534}"/>
               </a:ext>
             </a:extLst>
           </p:cNvPr>
@@ -6397,7 +6885,7 @@
             </a:lvl1pPr>
           </a:lstStyle>
           <a:p>
-            <a:fld id="{D1F306FC-4156-411C-BCB8-364FFCBFC11F}" type="slidenum">
+            <a:fld id="{BDA8BDE4-976D-47A8-ACF1-2157C40663B1}" type="slidenum">
               <a:rPr lang="zh-CN" altLang="en-US" smtClean="0"/>
               <a:t>‹#›</a:t>
             </a:fld>
@@ -6408,7 +6896,7 @@
     </p:spTree>
     <p:extLst>
       <p:ext uri="{BB962C8B-B14F-4D97-AF65-F5344CB8AC3E}">
-        <p14:creationId xmlns:p14="http://schemas.microsoft.com/office/powerpoint/2010/main" val="2870752762"/>
+        <p14:creationId xmlns:p14="http://schemas.microsoft.com/office/powerpoint/2010/main" val="3086211358"/>
       </p:ext>
     </p:extLst>
   </p:cSld>
@@ -6739,7 +7227,7 @@
           <p:cNvPr id="2" name="title">
             <a:extLst>
               <a:ext uri="{FF2B5EF4-FFF2-40B4-BE49-F238E27FC236}">
-                <a16:creationId xmlns:a16="http://schemas.microsoft.com/office/drawing/2014/main" id="{BCEF794D-AF02-4D21-8114-40B5F5532DF1}"/>
+                <a16:creationId xmlns:a16="http://schemas.microsoft.com/office/drawing/2014/main" id="{D313271C-EFD4-40AF-A87F-315D4D7ACEB5}"/>
               </a:ext>
             </a:extLst>
           </p:cNvPr>
@@ -6785,7 +7273,7 @@
           <p:cNvPr id="3" name="subtitle">
             <a:extLst>
               <a:ext uri="{FF2B5EF4-FFF2-40B4-BE49-F238E27FC236}">
-                <a16:creationId xmlns:a16="http://schemas.microsoft.com/office/drawing/2014/main" id="{B1A10CA8-22D1-4C62-946A-2224F68886F3}"/>
+                <a16:creationId xmlns:a16="http://schemas.microsoft.com/office/drawing/2014/main" id="{297380DE-4707-4A3E-AB6C-11C7133A4465}"/>
               </a:ext>
             </a:extLst>
           </p:cNvPr>
@@ -6831,7 +7319,7 @@
                 <a:latin typeface="微软雅黑" panose="020B0503020204020204" pitchFamily="34" charset="-122"/>
                 <a:ea typeface="微软雅黑" panose="020B0503020204020204" pitchFamily="34" charset="-122"/>
               </a:rPr>
-              <a:t>V0.1</a:t>
+              <a:t>V0.2</a:t>
             </a:r>
             <a:endParaRPr lang="zh-CN" altLang="en-US" sz="2900" b="1">
               <a:solidFill>
@@ -6848,7 +7336,7 @@
           <p:cNvPr id="4" name="cover-body">
             <a:extLst>
               <a:ext uri="{FF2B5EF4-FFF2-40B4-BE49-F238E27FC236}">
-                <a16:creationId xmlns:a16="http://schemas.microsoft.com/office/drawing/2014/main" id="{8AA2266F-2AD0-40E6-B9C8-CEE0BCC6A094}"/>
+                <a16:creationId xmlns:a16="http://schemas.microsoft.com/office/drawing/2014/main" id="{08498DBA-6F9C-405F-B2EF-87C770FC5CDA}"/>
               </a:ext>
             </a:extLst>
           </p:cNvPr>
@@ -6901,7 +7389,7 @@
                 <a:latin typeface="微软雅黑" panose="020B0503020204020204" pitchFamily="34" charset="-122"/>
                 <a:ea typeface="微软雅黑" panose="020B0503020204020204" pitchFamily="34" charset="-122"/>
               </a:rPr>
-              <a:t>G6-03  /  A </a:t>
+              <a:t>G6-03 / A</a:t>
             </a:r>
             <a:r>
               <a:rPr lang="zh-CN" altLang="en-US" sz="2300">
@@ -6911,7 +7399,7 @@
                 <a:latin typeface="微软雅黑" panose="020B0503020204020204" pitchFamily="34" charset="-122"/>
                 <a:ea typeface="微软雅黑" panose="020B0503020204020204" pitchFamily="34" charset="-122"/>
               </a:rPr>
-              <a:t>主责，</a:t>
+              <a:t>主责；</a:t>
             </a:r>
             <a:r>
               <a:rPr lang="en-US" altLang="zh-CN" sz="2300">
@@ -6921,7 +7409,7 @@
                 <a:latin typeface="微软雅黑" panose="020B0503020204020204" pitchFamily="34" charset="-122"/>
                 <a:ea typeface="微软雅黑" panose="020B0503020204020204" pitchFamily="34" charset="-122"/>
               </a:rPr>
-              <a:t>C </a:t>
+              <a:t>C</a:t>
             </a:r>
             <a:r>
               <a:rPr lang="zh-CN" altLang="en-US" sz="2300">
@@ -6931,7 +7419,7 @@
                 <a:latin typeface="微软雅黑" panose="020B0503020204020204" pitchFamily="34" charset="-122"/>
                 <a:ea typeface="微软雅黑" panose="020B0503020204020204" pitchFamily="34" charset="-122"/>
               </a:rPr>
-              <a:t>整体复核待执行</a:t>
+              <a:t>复核退回，待定向复验</a:t>
             </a:r>
           </a:p>
           <a:p>
@@ -6958,7 +7446,7 @@
           <p:cNvPr id="5" name="boundary">
             <a:extLst>
               <a:ext uri="{FF2B5EF4-FFF2-40B4-BE49-F238E27FC236}">
-                <a16:creationId xmlns:a16="http://schemas.microsoft.com/office/drawing/2014/main" id="{2D0A42D0-D51F-49E2-9769-FD92DA10A8AC}"/>
+                <a16:creationId xmlns:a16="http://schemas.microsoft.com/office/drawing/2014/main" id="{22ADE9CE-3D61-4D75-86D3-4111B28881D8}"/>
               </a:ext>
             </a:extLst>
           </p:cNvPr>
@@ -6994,7 +7482,7 @@
                 <a:latin typeface="微软雅黑" panose="020B0503020204020204" pitchFamily="34" charset="-122"/>
                 <a:ea typeface="微软雅黑" panose="020B0503020204020204" pitchFamily="34" charset="-122"/>
               </a:rPr>
-              <a:t>课程模拟试演候选；真实项目验收延期；</a:t>
+              <a:t>模拟试演候选；</a:t>
             </a:r>
             <a:r>
               <a:rPr lang="en-US" altLang="zh-CN" sz="1100">
@@ -7014,7 +7502,27 @@
                 <a:latin typeface="微软雅黑" panose="020B0503020204020204" pitchFamily="34" charset="-122"/>
                 <a:ea typeface="微软雅黑" panose="020B0503020204020204" pitchFamily="34" charset="-122"/>
               </a:rPr>
-              <a:t>整体复核待完成</a:t>
+              <a:t>复核退回状态</a:t>
+            </a:r>
+            <a:r>
+              <a:rPr lang="en-US" altLang="zh-CN" sz="1100">
+                <a:solidFill>
+                  <a:srgbClr val="8C351E"/>
+                </a:solidFill>
+                <a:latin typeface="微软雅黑" panose="020B0503020204020204" pitchFamily="34" charset="-122"/>
+                <a:ea typeface="微软雅黑" panose="020B0503020204020204" pitchFamily="34" charset="-122"/>
+              </a:rPr>
+              <a:t>/</a:t>
+            </a:r>
+            <a:r>
+              <a:rPr lang="zh-CN" altLang="en-US" sz="1100">
+                <a:solidFill>
+                  <a:srgbClr val="8C351E"/>
+                </a:solidFill>
+                <a:latin typeface="微软雅黑" panose="020B0503020204020204" pitchFamily="34" charset="-122"/>
+                <a:ea typeface="微软雅黑" panose="020B0503020204020204" pitchFamily="34" charset="-122"/>
+              </a:rPr>
+              <a:t>来源，待定向复验；真实验收延期</a:t>
             </a:r>
           </a:p>
         </p:txBody>
@@ -7024,7 +7532,7 @@
           <p:cNvPr id="6" name="page-number">
             <a:extLst>
               <a:ext uri="{FF2B5EF4-FFF2-40B4-BE49-F238E27FC236}">
-                <a16:creationId xmlns:a16="http://schemas.microsoft.com/office/drawing/2014/main" id="{AAD3F809-F082-43A8-BC0A-E59CF3DFD446}"/>
+                <a16:creationId xmlns:a16="http://schemas.microsoft.com/office/drawing/2014/main" id="{A50E1B7B-A7FC-4ECE-A207-4D4CF86BDB3E}"/>
               </a:ext>
             </a:extLst>
           </p:cNvPr>
@@ -7075,7 +7583,7 @@
     </p:spTree>
     <p:extLst>
       <p:ext uri="{BB962C8B-B14F-4D97-AF65-F5344CB8AC3E}">
-        <p14:creationId xmlns:p14="http://schemas.microsoft.com/office/powerpoint/2010/main" val="3371575951"/>
+        <p14:creationId xmlns:p14="http://schemas.microsoft.com/office/powerpoint/2010/main" val="2942939823"/>
       </p:ext>
     </p:extLst>
   </p:cSld>
@@ -7115,7 +7623,7 @@
           <p:cNvPr id="2" name="title">
             <a:extLst>
               <a:ext uri="{FF2B5EF4-FFF2-40B4-BE49-F238E27FC236}">
-                <a16:creationId xmlns:a16="http://schemas.microsoft.com/office/drawing/2014/main" id="{6C07D042-79CA-490F-B50C-04599F65A28D}"/>
+                <a16:creationId xmlns:a16="http://schemas.microsoft.com/office/drawing/2014/main" id="{08C05E29-34E8-407D-B003-7F93BBE1B043}"/>
               </a:ext>
             </a:extLst>
           </p:cNvPr>
@@ -7161,7 +7669,7 @@
           <p:cNvPr id="3" name="subtitle">
             <a:extLst>
               <a:ext uri="{FF2B5EF4-FFF2-40B4-BE49-F238E27FC236}">
-                <a16:creationId xmlns:a16="http://schemas.microsoft.com/office/drawing/2014/main" id="{E3D89DBE-FC0A-48DF-8987-68C6A16D5F42}"/>
+                <a16:creationId xmlns:a16="http://schemas.microsoft.com/office/drawing/2014/main" id="{2D80AE74-6D19-41E5-99AF-51CF7AB52CB1}"/>
               </a:ext>
             </a:extLst>
           </p:cNvPr>
@@ -7224,7 +7732,7 @@
           <p:cNvPr id="5" name="actual-run-screenshot">
             <a:extLst>
               <a:ext uri="{FF2B5EF4-FFF2-40B4-BE49-F238E27FC236}">
-                <a16:creationId xmlns:a16="http://schemas.microsoft.com/office/drawing/2014/main" id="{527A4062-32F4-420A-AFA7-9B460AEF6AD4}"/>
+                <a16:creationId xmlns:a16="http://schemas.microsoft.com/office/drawing/2014/main" id="{770D5EB3-0F1C-4CCB-9887-B2E201050579}"/>
               </a:ext>
             </a:extLst>
           </p:cNvPr>
@@ -7260,7 +7768,7 @@
           <p:cNvPr id="6" name="image-source">
             <a:extLst>
               <a:ext uri="{FF2B5EF4-FFF2-40B4-BE49-F238E27FC236}">
-                <a16:creationId xmlns:a16="http://schemas.microsoft.com/office/drawing/2014/main" id="{BA7FD3E3-2C61-4EA3-8EA0-5E39DA145AF1}"/>
+                <a16:creationId xmlns:a16="http://schemas.microsoft.com/office/drawing/2014/main" id="{F7183FAC-46A7-469C-B8D6-319CE11A8D97}"/>
               </a:ext>
             </a:extLst>
           </p:cNvPr>
@@ -7323,7 +7831,7 @@
           <p:cNvPr id="7" name="evidence-observations">
             <a:extLst>
               <a:ext uri="{FF2B5EF4-FFF2-40B4-BE49-F238E27FC236}">
-                <a16:creationId xmlns:a16="http://schemas.microsoft.com/office/drawing/2014/main" id="{91BBD059-201A-4A48-9E9E-BFF4FDBA268C}"/>
+                <a16:creationId xmlns:a16="http://schemas.microsoft.com/office/drawing/2014/main" id="{0189240A-055D-40DA-A00F-8ABF04AE9377}"/>
               </a:ext>
             </a:extLst>
           </p:cNvPr>
@@ -7472,7 +7980,7 @@
           <p:cNvPr id="8" name="boundary">
             <a:extLst>
               <a:ext uri="{FF2B5EF4-FFF2-40B4-BE49-F238E27FC236}">
-                <a16:creationId xmlns:a16="http://schemas.microsoft.com/office/drawing/2014/main" id="{B287E8B8-BC69-469F-9DC1-9BA22889983C}"/>
+                <a16:creationId xmlns:a16="http://schemas.microsoft.com/office/drawing/2014/main" id="{887AF563-A33F-4D74-9949-84D6A7691BC6}"/>
               </a:ext>
             </a:extLst>
           </p:cNvPr>
@@ -7508,7 +8016,7 @@
                 <a:latin typeface="微软雅黑" panose="020B0503020204020204" pitchFamily="34" charset="-122"/>
                 <a:ea typeface="微软雅黑" panose="020B0503020204020204" pitchFamily="34" charset="-122"/>
               </a:rPr>
-              <a:t>课程模拟试演候选；真实项目验收延期；</a:t>
+              <a:t>模拟试演候选；</a:t>
             </a:r>
             <a:r>
               <a:rPr lang="en-US" altLang="zh-CN" sz="1100">
@@ -7528,7 +8036,27 @@
                 <a:latin typeface="微软雅黑" panose="020B0503020204020204" pitchFamily="34" charset="-122"/>
                 <a:ea typeface="微软雅黑" panose="020B0503020204020204" pitchFamily="34" charset="-122"/>
               </a:rPr>
-              <a:t>整体复核待完成</a:t>
+              <a:t>复核退回状态</a:t>
+            </a:r>
+            <a:r>
+              <a:rPr lang="en-US" altLang="zh-CN" sz="1100">
+                <a:solidFill>
+                  <a:srgbClr val="8C351E"/>
+                </a:solidFill>
+                <a:latin typeface="微软雅黑" panose="020B0503020204020204" pitchFamily="34" charset="-122"/>
+                <a:ea typeface="微软雅黑" panose="020B0503020204020204" pitchFamily="34" charset="-122"/>
+              </a:rPr>
+              <a:t>/</a:t>
+            </a:r>
+            <a:r>
+              <a:rPr lang="zh-CN" altLang="en-US" sz="1100">
+                <a:solidFill>
+                  <a:srgbClr val="8C351E"/>
+                </a:solidFill>
+                <a:latin typeface="微软雅黑" panose="020B0503020204020204" pitchFamily="34" charset="-122"/>
+                <a:ea typeface="微软雅黑" panose="020B0503020204020204" pitchFamily="34" charset="-122"/>
+              </a:rPr>
+              <a:t>来源，待定向复验；真实验收延期</a:t>
             </a:r>
           </a:p>
         </p:txBody>
@@ -7538,7 +8066,7 @@
           <p:cNvPr id="9" name="page-number">
             <a:extLst>
               <a:ext uri="{FF2B5EF4-FFF2-40B4-BE49-F238E27FC236}">
-                <a16:creationId xmlns:a16="http://schemas.microsoft.com/office/drawing/2014/main" id="{484B788F-7B3F-4DA2-BBF3-C6727A2AB54E}"/>
+                <a16:creationId xmlns:a16="http://schemas.microsoft.com/office/drawing/2014/main" id="{C054B702-6168-422C-9B96-DA41154EA559}"/>
               </a:ext>
             </a:extLst>
           </p:cNvPr>
@@ -7589,7 +8117,7 @@
     </p:spTree>
     <p:extLst>
       <p:ext uri="{BB962C8B-B14F-4D97-AF65-F5344CB8AC3E}">
-        <p14:creationId xmlns:p14="http://schemas.microsoft.com/office/powerpoint/2010/main" val="898332194"/>
+        <p14:creationId xmlns:p14="http://schemas.microsoft.com/office/powerpoint/2010/main" val="3816512177"/>
       </p:ext>
     </p:extLst>
   </p:cSld>
@@ -7629,7 +8157,7 @@
           <p:cNvPr id="2" name="title">
             <a:extLst>
               <a:ext uri="{FF2B5EF4-FFF2-40B4-BE49-F238E27FC236}">
-                <a16:creationId xmlns:a16="http://schemas.microsoft.com/office/drawing/2014/main" id="{DAF06FC6-BD24-47DC-801E-DB9D4D1B0CDC}"/>
+                <a16:creationId xmlns:a16="http://schemas.microsoft.com/office/drawing/2014/main" id="{6F5932E6-8D1C-4C7D-AB9F-E53773C2DC08}"/>
               </a:ext>
             </a:extLst>
           </p:cNvPr>
@@ -7675,7 +8203,7 @@
           <p:cNvPr id="3" name="subtitle">
             <a:extLst>
               <a:ext uri="{FF2B5EF4-FFF2-40B4-BE49-F238E27FC236}">
-                <a16:creationId xmlns:a16="http://schemas.microsoft.com/office/drawing/2014/main" id="{80CF5666-D8F7-48FF-99F8-D3B68BE57829}"/>
+                <a16:creationId xmlns:a16="http://schemas.microsoft.com/office/drawing/2014/main" id="{CABF2B36-D2A7-4B19-810B-50221B97BBE4}"/>
               </a:ext>
             </a:extLst>
           </p:cNvPr>
@@ -7741,7 +8269,7 @@
           <p:cNvPr id="5" name="actual-run-screenshot">
             <a:extLst>
               <a:ext uri="{FF2B5EF4-FFF2-40B4-BE49-F238E27FC236}">
-                <a16:creationId xmlns:a16="http://schemas.microsoft.com/office/drawing/2014/main" id="{28D01524-67B4-4653-A98F-FD794D48AA78}"/>
+                <a16:creationId xmlns:a16="http://schemas.microsoft.com/office/drawing/2014/main" id="{376E9522-F15E-47E8-99DC-7274C66D5BD7}"/>
               </a:ext>
             </a:extLst>
           </p:cNvPr>
@@ -7777,7 +8305,7 @@
           <p:cNvPr id="6" name="image-source">
             <a:extLst>
               <a:ext uri="{FF2B5EF4-FFF2-40B4-BE49-F238E27FC236}">
-                <a16:creationId xmlns:a16="http://schemas.microsoft.com/office/drawing/2014/main" id="{24F0C2C0-19A4-49B1-A1B1-5CE3EB3A6457}"/>
+                <a16:creationId xmlns:a16="http://schemas.microsoft.com/office/drawing/2014/main" id="{4397DE09-271C-4CDB-AA5B-886FA73E6694}"/>
               </a:ext>
             </a:extLst>
           </p:cNvPr>
@@ -7840,7 +8368,7 @@
           <p:cNvPr id="7" name="evidence-observations">
             <a:extLst>
               <a:ext uri="{FF2B5EF4-FFF2-40B4-BE49-F238E27FC236}">
-                <a16:creationId xmlns:a16="http://schemas.microsoft.com/office/drawing/2014/main" id="{DD437210-869C-40EF-8006-45D2469C1883}"/>
+                <a16:creationId xmlns:a16="http://schemas.microsoft.com/office/drawing/2014/main" id="{E5F2585B-922A-4206-985D-9B6BE3B6D306}"/>
               </a:ext>
             </a:extLst>
           </p:cNvPr>
@@ -7979,7 +8507,7 @@
           <p:cNvPr id="8" name="boundary">
             <a:extLst>
               <a:ext uri="{FF2B5EF4-FFF2-40B4-BE49-F238E27FC236}">
-                <a16:creationId xmlns:a16="http://schemas.microsoft.com/office/drawing/2014/main" id="{36679B5B-EEBA-4A18-BB4A-ECB2F21C2A7D}"/>
+                <a16:creationId xmlns:a16="http://schemas.microsoft.com/office/drawing/2014/main" id="{FC2D50C1-7846-400B-9E6E-3C144F608DE8}"/>
               </a:ext>
             </a:extLst>
           </p:cNvPr>
@@ -8015,7 +8543,7 @@
                 <a:latin typeface="微软雅黑" panose="020B0503020204020204" pitchFamily="34" charset="-122"/>
                 <a:ea typeface="微软雅黑" panose="020B0503020204020204" pitchFamily="34" charset="-122"/>
               </a:rPr>
-              <a:t>课程模拟试演候选；真实项目验收延期；</a:t>
+              <a:t>模拟试演候选；</a:t>
             </a:r>
             <a:r>
               <a:rPr lang="en-US" altLang="zh-CN" sz="1100">
@@ -8035,7 +8563,27 @@
                 <a:latin typeface="微软雅黑" panose="020B0503020204020204" pitchFamily="34" charset="-122"/>
                 <a:ea typeface="微软雅黑" panose="020B0503020204020204" pitchFamily="34" charset="-122"/>
               </a:rPr>
-              <a:t>整体复核待完成</a:t>
+              <a:t>复核退回状态</a:t>
+            </a:r>
+            <a:r>
+              <a:rPr lang="en-US" altLang="zh-CN" sz="1100">
+                <a:solidFill>
+                  <a:srgbClr val="8C351E"/>
+                </a:solidFill>
+                <a:latin typeface="微软雅黑" panose="020B0503020204020204" pitchFamily="34" charset="-122"/>
+                <a:ea typeface="微软雅黑" panose="020B0503020204020204" pitchFamily="34" charset="-122"/>
+              </a:rPr>
+              <a:t>/</a:t>
+            </a:r>
+            <a:r>
+              <a:rPr lang="zh-CN" altLang="en-US" sz="1100">
+                <a:solidFill>
+                  <a:srgbClr val="8C351E"/>
+                </a:solidFill>
+                <a:latin typeface="微软雅黑" panose="020B0503020204020204" pitchFamily="34" charset="-122"/>
+                <a:ea typeface="微软雅黑" panose="020B0503020204020204" pitchFamily="34" charset="-122"/>
+              </a:rPr>
+              <a:t>来源，待定向复验；真实验收延期</a:t>
             </a:r>
           </a:p>
         </p:txBody>
@@ -8045,7 +8593,7 @@
           <p:cNvPr id="9" name="page-number">
             <a:extLst>
               <a:ext uri="{FF2B5EF4-FFF2-40B4-BE49-F238E27FC236}">
-                <a16:creationId xmlns:a16="http://schemas.microsoft.com/office/drawing/2014/main" id="{6ADF7F35-1C67-4B3E-85DE-2F320C90B541}"/>
+                <a16:creationId xmlns:a16="http://schemas.microsoft.com/office/drawing/2014/main" id="{B1DF8E47-2AAC-4A50-B471-7694172E9E50}"/>
               </a:ext>
             </a:extLst>
           </p:cNvPr>
@@ -8096,7 +8644,7 @@
     </p:spTree>
     <p:extLst>
       <p:ext uri="{BB962C8B-B14F-4D97-AF65-F5344CB8AC3E}">
-        <p14:creationId xmlns:p14="http://schemas.microsoft.com/office/powerpoint/2010/main" val="1525842645"/>
+        <p14:creationId xmlns:p14="http://schemas.microsoft.com/office/powerpoint/2010/main" val="2163374718"/>
       </p:ext>
     </p:extLst>
   </p:cSld>
@@ -8136,7 +8684,7 @@
           <p:cNvPr id="2" name="title">
             <a:extLst>
               <a:ext uri="{FF2B5EF4-FFF2-40B4-BE49-F238E27FC236}">
-                <a16:creationId xmlns:a16="http://schemas.microsoft.com/office/drawing/2014/main" id="{10F4E90A-22D2-4EF6-9612-6E76FEBD7B4B}"/>
+                <a16:creationId xmlns:a16="http://schemas.microsoft.com/office/drawing/2014/main" id="{6B211140-43EB-44B1-9778-89A60F5FBE48}"/>
               </a:ext>
             </a:extLst>
           </p:cNvPr>
@@ -8182,7 +8730,7 @@
           <p:cNvPr id="3" name="subtitle">
             <a:extLst>
               <a:ext uri="{FF2B5EF4-FFF2-40B4-BE49-F238E27FC236}">
-                <a16:creationId xmlns:a16="http://schemas.microsoft.com/office/drawing/2014/main" id="{6305D19A-5E0D-44D8-BEDA-C8734FBA9B0E}"/>
+                <a16:creationId xmlns:a16="http://schemas.microsoft.com/office/drawing/2014/main" id="{64889BDA-A7A1-4357-8CA5-4B6C1C97134B}"/>
               </a:ext>
             </a:extLst>
           </p:cNvPr>
@@ -8245,7 +8793,7 @@
           <p:cNvPr id="5" name="actual-run-screenshot">
             <a:extLst>
               <a:ext uri="{FF2B5EF4-FFF2-40B4-BE49-F238E27FC236}">
-                <a16:creationId xmlns:a16="http://schemas.microsoft.com/office/drawing/2014/main" id="{8E86A2BE-CFD0-4EBE-8306-86FB2658B183}"/>
+                <a16:creationId xmlns:a16="http://schemas.microsoft.com/office/drawing/2014/main" id="{601D856E-681D-40E6-B1FA-7EAF36CFFCCB}"/>
               </a:ext>
             </a:extLst>
           </p:cNvPr>
@@ -8281,7 +8829,7 @@
           <p:cNvPr id="6" name="image-source">
             <a:extLst>
               <a:ext uri="{FF2B5EF4-FFF2-40B4-BE49-F238E27FC236}">
-                <a16:creationId xmlns:a16="http://schemas.microsoft.com/office/drawing/2014/main" id="{62569FA4-990D-4CD6-A1DE-70C753262F4A}"/>
+                <a16:creationId xmlns:a16="http://schemas.microsoft.com/office/drawing/2014/main" id="{6525682E-61C1-415F-B339-D72045A35368}"/>
               </a:ext>
             </a:extLst>
           </p:cNvPr>
@@ -8344,7 +8892,7 @@
           <p:cNvPr id="7" name="evidence-observations">
             <a:extLst>
               <a:ext uri="{FF2B5EF4-FFF2-40B4-BE49-F238E27FC236}">
-                <a16:creationId xmlns:a16="http://schemas.microsoft.com/office/drawing/2014/main" id="{D25E4C49-E0B6-4205-87FE-A789C34699E8}"/>
+                <a16:creationId xmlns:a16="http://schemas.microsoft.com/office/drawing/2014/main" id="{E80DE35C-E0EA-44FE-9947-ECD40AC49BAE}"/>
               </a:ext>
             </a:extLst>
           </p:cNvPr>
@@ -8493,7 +9041,7 @@
                 <a:latin typeface="微软雅黑" panose="020B0503020204020204" pitchFamily="34" charset="-122"/>
                 <a:ea typeface="微软雅黑" panose="020B0503020204020204" pitchFamily="34" charset="-122"/>
               </a:rPr>
-              <a:t>整改后本地试演</a:t>
+              <a:t>本地试演</a:t>
             </a:r>
             <a:r>
               <a:rPr lang="en-US" altLang="zh-CN" sz="1900">
@@ -8513,7 +9061,47 @@
                 <a:latin typeface="微软雅黑" panose="020B0503020204020204" pitchFamily="34" charset="-122"/>
                 <a:ea typeface="微软雅黑" panose="020B0503020204020204" pitchFamily="34" charset="-122"/>
               </a:rPr>
-              <a:t>，整体复核待完成</a:t>
+              <a:t>；</a:t>
+            </a:r>
+            <a:r>
+              <a:rPr lang="en-US" altLang="zh-CN" sz="1900">
+                <a:solidFill>
+                  <a:srgbClr val="172E3A"/>
+                </a:solidFill>
+                <a:latin typeface="微软雅黑" panose="020B0503020204020204" pitchFamily="34" charset="-122"/>
+                <a:ea typeface="微软雅黑" panose="020B0503020204020204" pitchFamily="34" charset="-122"/>
+              </a:rPr>
+              <a:t>C</a:t>
+            </a:r>
+            <a:r>
+              <a:rPr lang="zh-CN" altLang="en-US" sz="1900">
+                <a:solidFill>
+                  <a:srgbClr val="172E3A"/>
+                </a:solidFill>
+                <a:latin typeface="微软雅黑" panose="020B0503020204020204" pitchFamily="34" charset="-122"/>
+                <a:ea typeface="微软雅黑" panose="020B0503020204020204" pitchFamily="34" charset="-122"/>
+              </a:rPr>
+              <a:t>要求状态</a:t>
+            </a:r>
+            <a:r>
+              <a:rPr lang="en-US" altLang="zh-CN" sz="1900">
+                <a:solidFill>
+                  <a:srgbClr val="172E3A"/>
+                </a:solidFill>
+                <a:latin typeface="微软雅黑" panose="020B0503020204020204" pitchFamily="34" charset="-122"/>
+                <a:ea typeface="微软雅黑" panose="020B0503020204020204" pitchFamily="34" charset="-122"/>
+              </a:rPr>
+              <a:t>/</a:t>
+            </a:r>
+            <a:r>
+              <a:rPr lang="zh-CN" altLang="en-US" sz="1900">
+                <a:solidFill>
+                  <a:srgbClr val="172E3A"/>
+                </a:solidFill>
+                <a:latin typeface="微软雅黑" panose="020B0503020204020204" pitchFamily="34" charset="-122"/>
+                <a:ea typeface="微软雅黑" panose="020B0503020204020204" pitchFamily="34" charset="-122"/>
+              </a:rPr>
+              <a:t>来源整改</a:t>
             </a:r>
           </a:p>
         </p:txBody>
@@ -8523,7 +9111,7 @@
           <p:cNvPr id="8" name="boundary">
             <a:extLst>
               <a:ext uri="{FF2B5EF4-FFF2-40B4-BE49-F238E27FC236}">
-                <a16:creationId xmlns:a16="http://schemas.microsoft.com/office/drawing/2014/main" id="{172D85FC-BDE5-4970-BEC0-6FDD9A861442}"/>
+                <a16:creationId xmlns:a16="http://schemas.microsoft.com/office/drawing/2014/main" id="{7F4490B8-69E1-4218-80F5-10D6CF6602B9}"/>
               </a:ext>
             </a:extLst>
           </p:cNvPr>
@@ -8559,7 +9147,7 @@
                 <a:latin typeface="微软雅黑" panose="020B0503020204020204" pitchFamily="34" charset="-122"/>
                 <a:ea typeface="微软雅黑" panose="020B0503020204020204" pitchFamily="34" charset="-122"/>
               </a:rPr>
-              <a:t>课程模拟试演候选；真实项目验收延期；</a:t>
+              <a:t>模拟试演候选；</a:t>
             </a:r>
             <a:r>
               <a:rPr lang="en-US" altLang="zh-CN" sz="1100">
@@ -8579,7 +9167,27 @@
                 <a:latin typeface="微软雅黑" panose="020B0503020204020204" pitchFamily="34" charset="-122"/>
                 <a:ea typeface="微软雅黑" panose="020B0503020204020204" pitchFamily="34" charset="-122"/>
               </a:rPr>
-              <a:t>整体复核待完成</a:t>
+              <a:t>复核退回状态</a:t>
+            </a:r>
+            <a:r>
+              <a:rPr lang="en-US" altLang="zh-CN" sz="1100">
+                <a:solidFill>
+                  <a:srgbClr val="8C351E"/>
+                </a:solidFill>
+                <a:latin typeface="微软雅黑" panose="020B0503020204020204" pitchFamily="34" charset="-122"/>
+                <a:ea typeface="微软雅黑" panose="020B0503020204020204" pitchFamily="34" charset="-122"/>
+              </a:rPr>
+              <a:t>/</a:t>
+            </a:r>
+            <a:r>
+              <a:rPr lang="zh-CN" altLang="en-US" sz="1100">
+                <a:solidFill>
+                  <a:srgbClr val="8C351E"/>
+                </a:solidFill>
+                <a:latin typeface="微软雅黑" panose="020B0503020204020204" pitchFamily="34" charset="-122"/>
+                <a:ea typeface="微软雅黑" panose="020B0503020204020204" pitchFamily="34" charset="-122"/>
+              </a:rPr>
+              <a:t>来源，待定向复验；真实验收延期</a:t>
             </a:r>
           </a:p>
         </p:txBody>
@@ -8589,7 +9197,7 @@
           <p:cNvPr id="9" name="page-number">
             <a:extLst>
               <a:ext uri="{FF2B5EF4-FFF2-40B4-BE49-F238E27FC236}">
-                <a16:creationId xmlns:a16="http://schemas.microsoft.com/office/drawing/2014/main" id="{6614AFE6-1E2A-4340-9DEF-E5A98E0288FB}"/>
+                <a16:creationId xmlns:a16="http://schemas.microsoft.com/office/drawing/2014/main" id="{D8D2D54A-701E-45F4-B940-1504F22A4B6E}"/>
               </a:ext>
             </a:extLst>
           </p:cNvPr>
@@ -8640,7 +9248,7 @@
     </p:spTree>
     <p:extLst>
       <p:ext uri="{BB962C8B-B14F-4D97-AF65-F5344CB8AC3E}">
-        <p14:creationId xmlns:p14="http://schemas.microsoft.com/office/powerpoint/2010/main" val="1012344602"/>
+        <p14:creationId xmlns:p14="http://schemas.microsoft.com/office/powerpoint/2010/main" val="1341781957"/>
       </p:ext>
     </p:extLst>
   </p:cSld>
@@ -8680,7 +9288,7 @@
           <p:cNvPr id="2" name="title">
             <a:extLst>
               <a:ext uri="{FF2B5EF4-FFF2-40B4-BE49-F238E27FC236}">
-                <a16:creationId xmlns:a16="http://schemas.microsoft.com/office/drawing/2014/main" id="{A29DCA09-6E26-46EF-BA8C-B6B7E125D6F1}"/>
+                <a16:creationId xmlns:a16="http://schemas.microsoft.com/office/drawing/2014/main" id="{9129015F-CFF1-4928-9442-EC4E5BC72071}"/>
               </a:ext>
             </a:extLst>
           </p:cNvPr>
@@ -8726,7 +9334,7 @@
           <p:cNvPr id="3" name="subtitle">
             <a:extLst>
               <a:ext uri="{FF2B5EF4-FFF2-40B4-BE49-F238E27FC236}">
-                <a16:creationId xmlns:a16="http://schemas.microsoft.com/office/drawing/2014/main" id="{7A3763C0-0ADE-4FF3-A70C-541873B037D5}"/>
+                <a16:creationId xmlns:a16="http://schemas.microsoft.com/office/drawing/2014/main" id="{D8F88CB6-F432-444F-9907-BC13E61694B7}"/>
               </a:ext>
             </a:extLst>
           </p:cNvPr>
@@ -8772,7 +9380,7 @@
           <p:cNvPr id="4" name="evidence-table">
             <a:extLst>
               <a:ext uri="{FF2B5EF4-FFF2-40B4-BE49-F238E27FC236}">
-                <a16:creationId xmlns:a16="http://schemas.microsoft.com/office/drawing/2014/main" id="{6FF02FC5-F7CF-4F73-A9C6-B8648ABC3C7A}"/>
+                <a16:creationId xmlns:a16="http://schemas.microsoft.com/office/drawing/2014/main" id="{4F6DFEF7-E852-4FFF-BA25-84AD845CA41C}"/>
               </a:ext>
             </a:extLst>
           </p:cNvPr>
@@ -8782,7 +9390,7 @@
           <p:nvPr>
             <p:extLst>
               <p:ext uri="{D42A27DB-BD31-4B8C-83A1-F6EECF244321}">
-                <p14:modId xmlns:p14="http://schemas.microsoft.com/office/powerpoint/2010/main" val="3607788939"/>
+                <p14:modId xmlns:p14="http://schemas.microsoft.com/office/powerpoint/2010/main" val="1779462891"/>
               </p:ext>
             </p:extLst>
           </p:nvPr>
@@ -8801,21 +9409,21 @@
                 <a:gridCol w="2413000">
                   <a:extLst>
                     <a:ext uri="{9D8B030D-6E8A-4147-A177-3AD203B41FA5}">
-                      <a16:colId xmlns:a16="http://schemas.microsoft.com/office/drawing/2014/main" val="3341957564"/>
+                      <a16:colId xmlns:a16="http://schemas.microsoft.com/office/drawing/2014/main" val="950668994"/>
                     </a:ext>
                   </a:extLst>
                 </a:gridCol>
                 <a:gridCol w="3810000">
                   <a:extLst>
                     <a:ext uri="{9D8B030D-6E8A-4147-A177-3AD203B41FA5}">
-                      <a16:colId xmlns:a16="http://schemas.microsoft.com/office/drawing/2014/main" val="3248567413"/>
+                      <a16:colId xmlns:a16="http://schemas.microsoft.com/office/drawing/2014/main" val="4218877856"/>
                     </a:ext>
                   </a:extLst>
                 </a:gridCol>
                 <a:gridCol w="4749800">
                   <a:extLst>
                     <a:ext uri="{9D8B030D-6E8A-4147-A177-3AD203B41FA5}">
-                      <a16:colId xmlns:a16="http://schemas.microsoft.com/office/drawing/2014/main" val="3799161931"/>
+                      <a16:colId xmlns:a16="http://schemas.microsoft.com/office/drawing/2014/main" val="2186238696"/>
                     </a:ext>
                   </a:extLst>
                 </a:gridCol>
@@ -8892,7 +9500,7 @@
                 </a:tc>
                 <a:extLst>
                   <a:ext uri="{0D108BD9-81ED-4DB2-BD59-A6C34878D82A}">
-                    <a16:rowId xmlns:a16="http://schemas.microsoft.com/office/drawing/2014/main" val="1302263250"/>
+                    <a16:rowId xmlns:a16="http://schemas.microsoft.com/office/drawing/2014/main" val="970806803"/>
                   </a:ext>
                 </a:extLst>
               </a:tr>
@@ -8936,29 +9544,6 @@
                     <a:lstStyle/>
                     <a:p>
                       <a:r>
-                        <a:rPr lang="zh-CN" altLang="en-US" sz="1800" b="0">
-                          <a:solidFill>
-                            <a:srgbClr val="172E3A"/>
-                          </a:solidFill>
-                          <a:latin typeface="微软雅黑" panose="020B0503020204020204" pitchFamily="34" charset="-122"/>
-                          <a:ea typeface="微软雅黑" panose="020B0503020204020204" pitchFamily="34" charset="-122"/>
-                        </a:rPr>
-                        <a:t>已整改复验，待指定确认</a:t>
-                      </a:r>
-                    </a:p>
-                  </a:txBody>
-                  <a:tcPr marL="152400" marR="152400" marT="114300" marB="76200">
-                    <a:solidFill>
-                      <a:srgbClr val="FFFFFF"/>
-                    </a:solidFill>
-                  </a:tcPr>
-                </a:tc>
-                <a:tc>
-                  <a:txBody>
-                    <a:bodyPr/>
-                    <a:lstStyle/>
-                    <a:p>
-                      <a:r>
                         <a:rPr lang="en-US" altLang="zh-CN" sz="1800" b="0">
                           <a:solidFill>
                             <a:srgbClr val="172E3A"/>
@@ -8966,7 +9551,7 @@
                           <a:latin typeface="微软雅黑" panose="020B0503020204020204" pitchFamily="34" charset="-122"/>
                           <a:ea typeface="微软雅黑" panose="020B0503020204020204" pitchFamily="34" charset="-122"/>
                         </a:rPr>
-                        <a:t>B</a:t>
+                        <a:t>CLOSED / B</a:t>
                       </a:r>
                       <a:r>
                         <a:rPr lang="zh-CN" altLang="en-US" sz="1800" b="0">
@@ -8976,7 +9561,7 @@
                           <a:latin typeface="微软雅黑" panose="020B0503020204020204" pitchFamily="34" charset="-122"/>
                           <a:ea typeface="微软雅黑" panose="020B0503020204020204" pitchFamily="34" charset="-122"/>
                         </a:rPr>
-                        <a:t>技术确认、</a:t>
+                        <a:t>及</a:t>
                       </a:r>
                       <a:r>
                         <a:rPr lang="en-US" altLang="zh-CN" sz="1800" b="0">
@@ -8996,7 +9581,50 @@
                           <a:latin typeface="微软雅黑" panose="020B0503020204020204" pitchFamily="34" charset="-122"/>
                           <a:ea typeface="微软雅黑" panose="020B0503020204020204" pitchFamily="34" charset="-122"/>
                         </a:rPr>
-                        <a:t>整体复核</a:t>
+                        <a:t>验证</a:t>
+                      </a:r>
+                    </a:p>
+                  </a:txBody>
+                  <a:tcPr marL="152400" marR="152400" marT="114300" marB="76200">
+                    <a:solidFill>
+                      <a:srgbClr val="FFFFFF"/>
+                    </a:solidFill>
+                  </a:tcPr>
+                </a:tc>
+                <a:tc>
+                  <a:txBody>
+                    <a:bodyPr/>
+                    <a:lstStyle/>
+                    <a:p>
+                      <a:r>
+                        <a:rPr lang="zh-CN" altLang="en-US" sz="1800" b="0">
+                          <a:solidFill>
+                            <a:srgbClr val="172E3A"/>
+                          </a:solidFill>
+                          <a:latin typeface="微软雅黑" panose="020B0503020204020204" pitchFamily="34" charset="-122"/>
+                          <a:ea typeface="微软雅黑" panose="020B0503020204020204" pitchFamily="34" charset="-122"/>
+                        </a:rPr>
+                        <a:t>保留原失败及</a:t>
+                      </a:r>
+                      <a:r>
+                        <a:rPr lang="en-US" altLang="zh-CN" sz="1800" b="0">
+                          <a:solidFill>
+                            <a:srgbClr val="172E3A"/>
+                          </a:solidFill>
+                          <a:latin typeface="微软雅黑" panose="020B0503020204020204" pitchFamily="34" charset="-122"/>
+                          <a:ea typeface="微软雅黑" panose="020B0503020204020204" pitchFamily="34" charset="-122"/>
+                        </a:rPr>
+                        <a:t>B/C</a:t>
+                      </a:r>
+                      <a:r>
+                        <a:rPr lang="zh-CN" altLang="en-US" sz="1800" b="0">
+                          <a:solidFill>
+                            <a:srgbClr val="172E3A"/>
+                          </a:solidFill>
+                          <a:latin typeface="微软雅黑" panose="020B0503020204020204" pitchFamily="34" charset="-122"/>
+                          <a:ea typeface="微软雅黑" panose="020B0503020204020204" pitchFamily="34" charset="-122"/>
+                        </a:rPr>
+                        <a:t>确认记录</a:t>
                       </a:r>
                     </a:p>
                   </a:txBody>
@@ -9008,7 +9636,7 @@
                 </a:tc>
                 <a:extLst>
                   <a:ext uri="{0D108BD9-81ED-4DB2-BD59-A6C34878D82A}">
-                    <a16:rowId xmlns:a16="http://schemas.microsoft.com/office/drawing/2014/main" val="3905096357"/>
+                    <a16:rowId xmlns:a16="http://schemas.microsoft.com/office/drawing/2014/main" val="2120459518"/>
                   </a:ext>
                 </a:extLst>
               </a:tr>
@@ -9134,7 +9762,7 @@
                 </a:tc>
                 <a:extLst>
                   <a:ext uri="{0D108BD9-81ED-4DB2-BD59-A6C34878D82A}">
-                    <a16:rowId xmlns:a16="http://schemas.microsoft.com/office/drawing/2014/main" val="1847461720"/>
+                    <a16:rowId xmlns:a16="http://schemas.microsoft.com/office/drawing/2014/main" val="683228067"/>
                   </a:ext>
                 </a:extLst>
               </a:tr>
@@ -9260,7 +9888,7 @@
                 </a:tc>
                 <a:extLst>
                   <a:ext uri="{0D108BD9-81ED-4DB2-BD59-A6C34878D82A}">
-                    <a16:rowId xmlns:a16="http://schemas.microsoft.com/office/drawing/2014/main" val="4132797583"/>
+                    <a16:rowId xmlns:a16="http://schemas.microsoft.com/office/drawing/2014/main" val="3786138491"/>
                   </a:ext>
                 </a:extLst>
               </a:tr>
@@ -9356,7 +9984,7 @@
                 </a:tc>
                 <a:extLst>
                   <a:ext uri="{0D108BD9-81ED-4DB2-BD59-A6C34878D82A}">
-                    <a16:rowId xmlns:a16="http://schemas.microsoft.com/office/drawing/2014/main" val="3385857793"/>
+                    <a16:rowId xmlns:a16="http://schemas.microsoft.com/office/drawing/2014/main" val="134021965"/>
                   </a:ext>
                 </a:extLst>
               </a:tr>
@@ -9369,7 +9997,7 @@
           <p:cNvPr id="5" name="boundary">
             <a:extLst>
               <a:ext uri="{FF2B5EF4-FFF2-40B4-BE49-F238E27FC236}">
-                <a16:creationId xmlns:a16="http://schemas.microsoft.com/office/drawing/2014/main" id="{CB0B5F39-903B-451D-B0B1-61E5BB59AED6}"/>
+                <a16:creationId xmlns:a16="http://schemas.microsoft.com/office/drawing/2014/main" id="{291BD87B-E212-4FAA-BF7C-9002EFC31558}"/>
               </a:ext>
             </a:extLst>
           </p:cNvPr>
@@ -9405,7 +10033,7 @@
                 <a:latin typeface="微软雅黑" panose="020B0503020204020204" pitchFamily="34" charset="-122"/>
                 <a:ea typeface="微软雅黑" panose="020B0503020204020204" pitchFamily="34" charset="-122"/>
               </a:rPr>
-              <a:t>课程模拟试演候选；真实项目验收延期；</a:t>
+              <a:t>模拟试演候选；</a:t>
             </a:r>
             <a:r>
               <a:rPr lang="en-US" altLang="zh-CN" sz="1100">
@@ -9425,7 +10053,27 @@
                 <a:latin typeface="微软雅黑" panose="020B0503020204020204" pitchFamily="34" charset="-122"/>
                 <a:ea typeface="微软雅黑" panose="020B0503020204020204" pitchFamily="34" charset="-122"/>
               </a:rPr>
-              <a:t>整体复核待完成</a:t>
+              <a:t>复核退回状态</a:t>
+            </a:r>
+            <a:r>
+              <a:rPr lang="en-US" altLang="zh-CN" sz="1100">
+                <a:solidFill>
+                  <a:srgbClr val="8C351E"/>
+                </a:solidFill>
+                <a:latin typeface="微软雅黑" panose="020B0503020204020204" pitchFamily="34" charset="-122"/>
+                <a:ea typeface="微软雅黑" panose="020B0503020204020204" pitchFamily="34" charset="-122"/>
+              </a:rPr>
+              <a:t>/</a:t>
+            </a:r>
+            <a:r>
+              <a:rPr lang="zh-CN" altLang="en-US" sz="1100">
+                <a:solidFill>
+                  <a:srgbClr val="8C351E"/>
+                </a:solidFill>
+                <a:latin typeface="微软雅黑" panose="020B0503020204020204" pitchFamily="34" charset="-122"/>
+                <a:ea typeface="微软雅黑" panose="020B0503020204020204" pitchFamily="34" charset="-122"/>
+              </a:rPr>
+              <a:t>来源，待定向复验；真实验收延期</a:t>
             </a:r>
           </a:p>
         </p:txBody>
@@ -9435,7 +10083,7 @@
           <p:cNvPr id="6" name="page-number">
             <a:extLst>
               <a:ext uri="{FF2B5EF4-FFF2-40B4-BE49-F238E27FC236}">
-                <a16:creationId xmlns:a16="http://schemas.microsoft.com/office/drawing/2014/main" id="{FFF06EA9-A45A-4F6A-84A8-C5385249E572}"/>
+                <a16:creationId xmlns:a16="http://schemas.microsoft.com/office/drawing/2014/main" id="{C1810B35-F4F6-4A0E-87D8-97A7B16B3290}"/>
               </a:ext>
             </a:extLst>
           </p:cNvPr>
@@ -9486,7 +10134,7 @@
     </p:spTree>
     <p:extLst>
       <p:ext uri="{BB962C8B-B14F-4D97-AF65-F5344CB8AC3E}">
-        <p14:creationId xmlns:p14="http://schemas.microsoft.com/office/powerpoint/2010/main" val="948744853"/>
+        <p14:creationId xmlns:p14="http://schemas.microsoft.com/office/powerpoint/2010/main" val="1663002684"/>
       </p:ext>
     </p:extLst>
   </p:cSld>
@@ -9526,7 +10174,7 @@
           <p:cNvPr id="2" name="title">
             <a:extLst>
               <a:ext uri="{FF2B5EF4-FFF2-40B4-BE49-F238E27FC236}">
-                <a16:creationId xmlns:a16="http://schemas.microsoft.com/office/drawing/2014/main" id="{E972CDE8-C787-452D-876E-AD8A9298465D}"/>
+                <a16:creationId xmlns:a16="http://schemas.microsoft.com/office/drawing/2014/main" id="{CB994673-6080-4AD1-B812-7CD2509A220E}"/>
               </a:ext>
             </a:extLst>
           </p:cNvPr>
@@ -9572,7 +10220,7 @@
           <p:cNvPr id="3" name="subtitle">
             <a:extLst>
               <a:ext uri="{FF2B5EF4-FFF2-40B4-BE49-F238E27FC236}">
-                <a16:creationId xmlns:a16="http://schemas.microsoft.com/office/drawing/2014/main" id="{12F57333-2D55-4FDF-965F-C3A738EE191B}"/>
+                <a16:creationId xmlns:a16="http://schemas.microsoft.com/office/drawing/2014/main" id="{FC18CF07-0AA5-499A-858F-929CA32F8157}"/>
               </a:ext>
             </a:extLst>
           </p:cNvPr>
@@ -9618,7 +10266,7 @@
           <p:cNvPr id="4" name="body">
             <a:extLst>
               <a:ext uri="{FF2B5EF4-FFF2-40B4-BE49-F238E27FC236}">
-                <a16:creationId xmlns:a16="http://schemas.microsoft.com/office/drawing/2014/main" id="{C59A6901-0D2C-4E8B-9D2B-945A9CE5D189}"/>
+                <a16:creationId xmlns:a16="http://schemas.microsoft.com/office/drawing/2014/main" id="{DA299669-6230-4427-BB94-32BB7E0A8071}"/>
               </a:ext>
             </a:extLst>
           </p:cNvPr>
@@ -9827,7 +10475,7 @@
           <p:cNvPr id="5" name="boundary">
             <a:extLst>
               <a:ext uri="{FF2B5EF4-FFF2-40B4-BE49-F238E27FC236}">
-                <a16:creationId xmlns:a16="http://schemas.microsoft.com/office/drawing/2014/main" id="{069D4F36-C3D8-4D93-BC89-F022FC76B8B3}"/>
+                <a16:creationId xmlns:a16="http://schemas.microsoft.com/office/drawing/2014/main" id="{0E2E1591-2707-45EA-A9B9-C91713B9AAD0}"/>
               </a:ext>
             </a:extLst>
           </p:cNvPr>
@@ -9863,7 +10511,7 @@
                 <a:latin typeface="微软雅黑" panose="020B0503020204020204" pitchFamily="34" charset="-122"/>
                 <a:ea typeface="微软雅黑" panose="020B0503020204020204" pitchFamily="34" charset="-122"/>
               </a:rPr>
-              <a:t>课程模拟试演候选；真实项目验收延期；</a:t>
+              <a:t>模拟试演候选；</a:t>
             </a:r>
             <a:r>
               <a:rPr lang="en-US" altLang="zh-CN" sz="1100">
@@ -9883,7 +10531,27 @@
                 <a:latin typeface="微软雅黑" panose="020B0503020204020204" pitchFamily="34" charset="-122"/>
                 <a:ea typeface="微软雅黑" panose="020B0503020204020204" pitchFamily="34" charset="-122"/>
               </a:rPr>
-              <a:t>整体复核待完成</a:t>
+              <a:t>复核退回状态</a:t>
+            </a:r>
+            <a:r>
+              <a:rPr lang="en-US" altLang="zh-CN" sz="1100">
+                <a:solidFill>
+                  <a:srgbClr val="8C351E"/>
+                </a:solidFill>
+                <a:latin typeface="微软雅黑" panose="020B0503020204020204" pitchFamily="34" charset="-122"/>
+                <a:ea typeface="微软雅黑" panose="020B0503020204020204" pitchFamily="34" charset="-122"/>
+              </a:rPr>
+              <a:t>/</a:t>
+            </a:r>
+            <a:r>
+              <a:rPr lang="zh-CN" altLang="en-US" sz="1100">
+                <a:solidFill>
+                  <a:srgbClr val="8C351E"/>
+                </a:solidFill>
+                <a:latin typeface="微软雅黑" panose="020B0503020204020204" pitchFamily="34" charset="-122"/>
+                <a:ea typeface="微软雅黑" panose="020B0503020204020204" pitchFamily="34" charset="-122"/>
+              </a:rPr>
+              <a:t>来源，待定向复验；真实验收延期</a:t>
             </a:r>
           </a:p>
         </p:txBody>
@@ -9893,7 +10561,7 @@
           <p:cNvPr id="6" name="page-number">
             <a:extLst>
               <a:ext uri="{FF2B5EF4-FFF2-40B4-BE49-F238E27FC236}">
-                <a16:creationId xmlns:a16="http://schemas.microsoft.com/office/drawing/2014/main" id="{0B530CAA-B23F-49D3-BA22-F9170E80356C}"/>
+                <a16:creationId xmlns:a16="http://schemas.microsoft.com/office/drawing/2014/main" id="{1D26FB71-2E2F-44AA-9DB3-3F3AB6810B30}"/>
               </a:ext>
             </a:extLst>
           </p:cNvPr>
@@ -9944,7 +10612,7 @@
     </p:spTree>
     <p:extLst>
       <p:ext uri="{BB962C8B-B14F-4D97-AF65-F5344CB8AC3E}">
-        <p14:creationId xmlns:p14="http://schemas.microsoft.com/office/powerpoint/2010/main" val="1895365398"/>
+        <p14:creationId xmlns:p14="http://schemas.microsoft.com/office/powerpoint/2010/main" val="787663433"/>
       </p:ext>
     </p:extLst>
   </p:cSld>
@@ -9984,7 +10652,7 @@
           <p:cNvPr id="2" name="title">
             <a:extLst>
               <a:ext uri="{FF2B5EF4-FFF2-40B4-BE49-F238E27FC236}">
-                <a16:creationId xmlns:a16="http://schemas.microsoft.com/office/drawing/2014/main" id="{A2C87442-3C8E-4C4C-857B-7A195C9B2F93}"/>
+                <a16:creationId xmlns:a16="http://schemas.microsoft.com/office/drawing/2014/main" id="{3ED9711F-DE1C-4BF7-9661-94EC0F18B606}"/>
               </a:ext>
             </a:extLst>
           </p:cNvPr>
@@ -10030,7 +10698,7 @@
           <p:cNvPr id="3" name="subtitle">
             <a:extLst>
               <a:ext uri="{FF2B5EF4-FFF2-40B4-BE49-F238E27FC236}">
-                <a16:creationId xmlns:a16="http://schemas.microsoft.com/office/drawing/2014/main" id="{186BC913-CBA3-4BC3-A605-AB9A76E14C2A}"/>
+                <a16:creationId xmlns:a16="http://schemas.microsoft.com/office/drawing/2014/main" id="{3F70669A-1939-4E22-BCAC-EEB69B0505A2}"/>
               </a:ext>
             </a:extLst>
           </p:cNvPr>
@@ -10086,7 +10754,7 @@
           <p:cNvPr id="4" name="evidence-table">
             <a:extLst>
               <a:ext uri="{FF2B5EF4-FFF2-40B4-BE49-F238E27FC236}">
-                <a16:creationId xmlns:a16="http://schemas.microsoft.com/office/drawing/2014/main" id="{729C545B-F44B-4942-B762-715147EF2B79}"/>
+                <a16:creationId xmlns:a16="http://schemas.microsoft.com/office/drawing/2014/main" id="{76048265-BA87-486A-94FD-5702E2A1295F}"/>
               </a:ext>
             </a:extLst>
           </p:cNvPr>
@@ -10096,7 +10764,7 @@
           <p:nvPr>
             <p:extLst>
               <p:ext uri="{D42A27DB-BD31-4B8C-83A1-F6EECF244321}">
-                <p14:modId xmlns:p14="http://schemas.microsoft.com/office/powerpoint/2010/main" val="2982762972"/>
+                <p14:modId xmlns:p14="http://schemas.microsoft.com/office/powerpoint/2010/main" val="1827017745"/>
               </p:ext>
             </p:extLst>
           </p:nvPr>
@@ -10115,21 +10783,21 @@
                 <a:gridCol w="2413000">
                   <a:extLst>
                     <a:ext uri="{9D8B030D-6E8A-4147-A177-3AD203B41FA5}">
-                      <a16:colId xmlns:a16="http://schemas.microsoft.com/office/drawing/2014/main" val="3879489947"/>
+                      <a16:colId xmlns:a16="http://schemas.microsoft.com/office/drawing/2014/main" val="544668453"/>
                     </a:ext>
                   </a:extLst>
                 </a:gridCol>
                 <a:gridCol w="3810000">
                   <a:extLst>
                     <a:ext uri="{9D8B030D-6E8A-4147-A177-3AD203B41FA5}">
-                      <a16:colId xmlns:a16="http://schemas.microsoft.com/office/drawing/2014/main" val="3048476895"/>
+                      <a16:colId xmlns:a16="http://schemas.microsoft.com/office/drawing/2014/main" val="594791555"/>
                     </a:ext>
                   </a:extLst>
                 </a:gridCol>
                 <a:gridCol w="4749800">
                   <a:extLst>
                     <a:ext uri="{9D8B030D-6E8A-4147-A177-3AD203B41FA5}">
-                      <a16:colId xmlns:a16="http://schemas.microsoft.com/office/drawing/2014/main" val="4237047597"/>
+                      <a16:colId xmlns:a16="http://schemas.microsoft.com/office/drawing/2014/main" val="1294753104"/>
                     </a:ext>
                   </a:extLst>
                 </a:gridCol>
@@ -10206,7 +10874,7 @@
                 </a:tc>
                 <a:extLst>
                   <a:ext uri="{0D108BD9-81ED-4DB2-BD59-A6C34878D82A}">
-                    <a16:rowId xmlns:a16="http://schemas.microsoft.com/office/drawing/2014/main" val="2660736418"/>
+                    <a16:rowId xmlns:a16="http://schemas.microsoft.com/office/drawing/2014/main" val="1831537687"/>
                   </a:ext>
                 </a:extLst>
               </a:tr>
@@ -10289,7 +10957,7 @@
                 </a:tc>
                 <a:extLst>
                   <a:ext uri="{0D108BD9-81ED-4DB2-BD59-A6C34878D82A}">
-                    <a16:rowId xmlns:a16="http://schemas.microsoft.com/office/drawing/2014/main" val="3194382110"/>
+                    <a16:rowId xmlns:a16="http://schemas.microsoft.com/office/drawing/2014/main" val="827625773"/>
                   </a:ext>
                 </a:extLst>
               </a:tr>
@@ -10389,7 +11057,7 @@
                 </a:tc>
                 <a:extLst>
                   <a:ext uri="{0D108BD9-81ED-4DB2-BD59-A6C34878D82A}">
-                    <a16:rowId xmlns:a16="http://schemas.microsoft.com/office/drawing/2014/main" val="3839259524"/>
+                    <a16:rowId xmlns:a16="http://schemas.microsoft.com/office/drawing/2014/main" val="166980787"/>
                   </a:ext>
                 </a:extLst>
               </a:tr>
@@ -10482,7 +11150,7 @@
                 </a:tc>
                 <a:extLst>
                   <a:ext uri="{0D108BD9-81ED-4DB2-BD59-A6C34878D82A}">
-                    <a16:rowId xmlns:a16="http://schemas.microsoft.com/office/drawing/2014/main" val="708550926"/>
+                    <a16:rowId xmlns:a16="http://schemas.microsoft.com/office/drawing/2014/main" val="1966530271"/>
                   </a:ext>
                 </a:extLst>
               </a:tr>
@@ -10546,6 +11214,16 @@
                     <a:lstStyle/>
                     <a:p>
                       <a:r>
+                        <a:rPr lang="en-US" altLang="zh-CN" sz="1800" b="0">
+                          <a:solidFill>
+                            <a:srgbClr val="172E3A"/>
+                          </a:solidFill>
+                          <a:latin typeface="微软雅黑" panose="020B0503020204020204" pitchFamily="34" charset="-122"/>
+                          <a:ea typeface="微软雅黑" panose="020B0503020204020204" pitchFamily="34" charset="-122"/>
+                        </a:rPr>
+                        <a:t>G6-01/02 DONE</a:t>
+                      </a:r>
+                      <a:r>
                         <a:rPr lang="zh-CN" altLang="en-US" sz="1800" b="0">
                           <a:solidFill>
                             <a:srgbClr val="172E3A"/>
@@ -10553,7 +11231,47 @@
                           <a:latin typeface="微软雅黑" panose="020B0503020204020204" pitchFamily="34" charset="-122"/>
                           <a:ea typeface="微软雅黑" panose="020B0503020204020204" pitchFamily="34" charset="-122"/>
                         </a:rPr>
-                        <a:t>整体复核与最终审计待完成</a:t>
+                        <a:t>；</a:t>
+                      </a:r>
+                      <a:r>
+                        <a:rPr lang="en-US" altLang="zh-CN" sz="1800" b="0">
+                          <a:solidFill>
+                            <a:srgbClr val="172E3A"/>
+                          </a:solidFill>
+                          <a:latin typeface="微软雅黑" panose="020B0503020204020204" pitchFamily="34" charset="-122"/>
+                          <a:ea typeface="微软雅黑" panose="020B0503020204020204" pitchFamily="34" charset="-122"/>
+                        </a:rPr>
+                        <a:t>G6-03</a:t>
+                      </a:r>
+                      <a:r>
+                        <a:rPr lang="zh-CN" altLang="en-US" sz="1800" b="0">
+                          <a:solidFill>
+                            <a:srgbClr val="172E3A"/>
+                          </a:solidFill>
+                          <a:latin typeface="微软雅黑" panose="020B0503020204020204" pitchFamily="34" charset="-122"/>
+                          <a:ea typeface="微软雅黑" panose="020B0503020204020204" pitchFamily="34" charset="-122"/>
+                        </a:rPr>
+                        <a:t>待</a:t>
+                      </a:r>
+                      <a:r>
+                        <a:rPr lang="en-US" altLang="zh-CN" sz="1800" b="0">
+                          <a:solidFill>
+                            <a:srgbClr val="172E3A"/>
+                          </a:solidFill>
+                          <a:latin typeface="微软雅黑" panose="020B0503020204020204" pitchFamily="34" charset="-122"/>
+                          <a:ea typeface="微软雅黑" panose="020B0503020204020204" pitchFamily="34" charset="-122"/>
+                        </a:rPr>
+                        <a:t>C</a:t>
+                      </a:r>
+                      <a:r>
+                        <a:rPr lang="zh-CN" altLang="en-US" sz="1800" b="0">
+                          <a:solidFill>
+                            <a:srgbClr val="172E3A"/>
+                          </a:solidFill>
+                          <a:latin typeface="微软雅黑" panose="020B0503020204020204" pitchFamily="34" charset="-122"/>
+                          <a:ea typeface="微软雅黑" panose="020B0503020204020204" pitchFamily="34" charset="-122"/>
+                        </a:rPr>
+                        <a:t>复验</a:t>
                       </a:r>
                     </a:p>
                   </a:txBody>
@@ -10565,7 +11283,7 @@
                 </a:tc>
                 <a:extLst>
                   <a:ext uri="{0D108BD9-81ED-4DB2-BD59-A6C34878D82A}">
-                    <a16:rowId xmlns:a16="http://schemas.microsoft.com/office/drawing/2014/main" val="824764203"/>
+                    <a16:rowId xmlns:a16="http://schemas.microsoft.com/office/drawing/2014/main" val="2538700686"/>
                   </a:ext>
                 </a:extLst>
               </a:tr>
@@ -10578,7 +11296,7 @@
           <p:cNvPr id="5" name="boundary">
             <a:extLst>
               <a:ext uri="{FF2B5EF4-FFF2-40B4-BE49-F238E27FC236}">
-                <a16:creationId xmlns:a16="http://schemas.microsoft.com/office/drawing/2014/main" id="{4A6C619D-5FA3-424C-BA7E-A8BFB8F645CA}"/>
+                <a16:creationId xmlns:a16="http://schemas.microsoft.com/office/drawing/2014/main" id="{B2E834FE-CCF7-4743-A97F-12E9B1384FF2}"/>
               </a:ext>
             </a:extLst>
           </p:cNvPr>
@@ -10614,7 +11332,7 @@
                 <a:latin typeface="微软雅黑" panose="020B0503020204020204" pitchFamily="34" charset="-122"/>
                 <a:ea typeface="微软雅黑" panose="020B0503020204020204" pitchFamily="34" charset="-122"/>
               </a:rPr>
-              <a:t>课程模拟试演候选；真实项目验收延期；</a:t>
+              <a:t>模拟试演候选；</a:t>
             </a:r>
             <a:r>
               <a:rPr lang="en-US" altLang="zh-CN" sz="1100">
@@ -10634,7 +11352,27 @@
                 <a:latin typeface="微软雅黑" panose="020B0503020204020204" pitchFamily="34" charset="-122"/>
                 <a:ea typeface="微软雅黑" panose="020B0503020204020204" pitchFamily="34" charset="-122"/>
               </a:rPr>
-              <a:t>整体复核待完成</a:t>
+              <a:t>复核退回状态</a:t>
+            </a:r>
+            <a:r>
+              <a:rPr lang="en-US" altLang="zh-CN" sz="1100">
+                <a:solidFill>
+                  <a:srgbClr val="8C351E"/>
+                </a:solidFill>
+                <a:latin typeface="微软雅黑" panose="020B0503020204020204" pitchFamily="34" charset="-122"/>
+                <a:ea typeface="微软雅黑" panose="020B0503020204020204" pitchFamily="34" charset="-122"/>
+              </a:rPr>
+              <a:t>/</a:t>
+            </a:r>
+            <a:r>
+              <a:rPr lang="zh-CN" altLang="en-US" sz="1100">
+                <a:solidFill>
+                  <a:srgbClr val="8C351E"/>
+                </a:solidFill>
+                <a:latin typeface="微软雅黑" panose="020B0503020204020204" pitchFamily="34" charset="-122"/>
+                <a:ea typeface="微软雅黑" panose="020B0503020204020204" pitchFamily="34" charset="-122"/>
+              </a:rPr>
+              <a:t>来源，待定向复验；真实验收延期</a:t>
             </a:r>
           </a:p>
         </p:txBody>
@@ -10644,7 +11382,7 @@
           <p:cNvPr id="6" name="page-number">
             <a:extLst>
               <a:ext uri="{FF2B5EF4-FFF2-40B4-BE49-F238E27FC236}">
-                <a16:creationId xmlns:a16="http://schemas.microsoft.com/office/drawing/2014/main" id="{F3C7D6F0-3F00-4652-AC1B-2A63C3E9F6F8}"/>
+                <a16:creationId xmlns:a16="http://schemas.microsoft.com/office/drawing/2014/main" id="{53741D79-EFA1-4F6A-98ED-81A492BE3A10}"/>
               </a:ext>
             </a:extLst>
           </p:cNvPr>
@@ -10695,7 +11433,7 @@
     </p:spTree>
     <p:extLst>
       <p:ext uri="{BB962C8B-B14F-4D97-AF65-F5344CB8AC3E}">
-        <p14:creationId xmlns:p14="http://schemas.microsoft.com/office/powerpoint/2010/main" val="1929864586"/>
+        <p14:creationId xmlns:p14="http://schemas.microsoft.com/office/powerpoint/2010/main" val="555503101"/>
       </p:ext>
     </p:extLst>
   </p:cSld>
@@ -10735,7 +11473,7 @@
           <p:cNvPr id="2" name="title">
             <a:extLst>
               <a:ext uri="{FF2B5EF4-FFF2-40B4-BE49-F238E27FC236}">
-                <a16:creationId xmlns:a16="http://schemas.microsoft.com/office/drawing/2014/main" id="{493A3746-B2E6-4577-82B9-66A1BF63F567}"/>
+                <a16:creationId xmlns:a16="http://schemas.microsoft.com/office/drawing/2014/main" id="{1FD077DF-5345-406E-B841-1D8B9F3007AF}"/>
               </a:ext>
             </a:extLst>
           </p:cNvPr>
@@ -10781,7 +11519,7 @@
           <p:cNvPr id="3" name="subtitle">
             <a:extLst>
               <a:ext uri="{FF2B5EF4-FFF2-40B4-BE49-F238E27FC236}">
-                <a16:creationId xmlns:a16="http://schemas.microsoft.com/office/drawing/2014/main" id="{8AC5E3DB-B5C9-4B0C-A33B-37A65D54B93D}"/>
+                <a16:creationId xmlns:a16="http://schemas.microsoft.com/office/drawing/2014/main" id="{4B66876C-CEBD-457C-9312-0F7360F55277}"/>
               </a:ext>
             </a:extLst>
           </p:cNvPr>
@@ -10894,7 +11632,7 @@
           <p:cNvPr id="4" name="body">
             <a:extLst>
               <a:ext uri="{FF2B5EF4-FFF2-40B4-BE49-F238E27FC236}">
-                <a16:creationId xmlns:a16="http://schemas.microsoft.com/office/drawing/2014/main" id="{5C6D89B8-724F-4B59-AE3D-38B6361D3133}"/>
+                <a16:creationId xmlns:a16="http://schemas.microsoft.com/office/drawing/2014/main" id="{6DB631F8-084B-499C-AE04-0733C8A35575}"/>
               </a:ext>
             </a:extLst>
           </p:cNvPr>
@@ -11073,7 +11811,7 @@
           <p:cNvPr id="5" name="boundary">
             <a:extLst>
               <a:ext uri="{FF2B5EF4-FFF2-40B4-BE49-F238E27FC236}">
-                <a16:creationId xmlns:a16="http://schemas.microsoft.com/office/drawing/2014/main" id="{6B079847-15E3-4913-BBFE-4EBCE0D5544A}"/>
+                <a16:creationId xmlns:a16="http://schemas.microsoft.com/office/drawing/2014/main" id="{B8F6082E-7C98-4711-BE61-18A8DE96A1D1}"/>
               </a:ext>
             </a:extLst>
           </p:cNvPr>
@@ -11109,7 +11847,7 @@
                 <a:latin typeface="微软雅黑" panose="020B0503020204020204" pitchFamily="34" charset="-122"/>
                 <a:ea typeface="微软雅黑" panose="020B0503020204020204" pitchFamily="34" charset="-122"/>
               </a:rPr>
-              <a:t>课程模拟试演候选；真实项目验收延期；</a:t>
+              <a:t>模拟试演候选；</a:t>
             </a:r>
             <a:r>
               <a:rPr lang="en-US" altLang="zh-CN" sz="1100">
@@ -11129,7 +11867,27 @@
                 <a:latin typeface="微软雅黑" panose="020B0503020204020204" pitchFamily="34" charset="-122"/>
                 <a:ea typeface="微软雅黑" panose="020B0503020204020204" pitchFamily="34" charset="-122"/>
               </a:rPr>
-              <a:t>整体复核待完成</a:t>
+              <a:t>复核退回状态</a:t>
+            </a:r>
+            <a:r>
+              <a:rPr lang="en-US" altLang="zh-CN" sz="1100">
+                <a:solidFill>
+                  <a:srgbClr val="8C351E"/>
+                </a:solidFill>
+                <a:latin typeface="微软雅黑" panose="020B0503020204020204" pitchFamily="34" charset="-122"/>
+                <a:ea typeface="微软雅黑" panose="020B0503020204020204" pitchFamily="34" charset="-122"/>
+              </a:rPr>
+              <a:t>/</a:t>
+            </a:r>
+            <a:r>
+              <a:rPr lang="zh-CN" altLang="en-US" sz="1100">
+                <a:solidFill>
+                  <a:srgbClr val="8C351E"/>
+                </a:solidFill>
+                <a:latin typeface="微软雅黑" panose="020B0503020204020204" pitchFamily="34" charset="-122"/>
+                <a:ea typeface="微软雅黑" panose="020B0503020204020204" pitchFamily="34" charset="-122"/>
+              </a:rPr>
+              <a:t>来源，待定向复验；真实验收延期</a:t>
             </a:r>
           </a:p>
         </p:txBody>
@@ -11139,7 +11897,7 @@
           <p:cNvPr id="6" name="page-number">
             <a:extLst>
               <a:ext uri="{FF2B5EF4-FFF2-40B4-BE49-F238E27FC236}">
-                <a16:creationId xmlns:a16="http://schemas.microsoft.com/office/drawing/2014/main" id="{2BFBA428-3D55-47F0-8F29-D0D677B0A81C}"/>
+                <a16:creationId xmlns:a16="http://schemas.microsoft.com/office/drawing/2014/main" id="{B2A47BF2-E926-4E01-B3F4-B72DB9BFF682}"/>
               </a:ext>
             </a:extLst>
           </p:cNvPr>
@@ -11190,7 +11948,7 @@
     </p:spTree>
     <p:extLst>
       <p:ext uri="{BB962C8B-B14F-4D97-AF65-F5344CB8AC3E}">
-        <p14:creationId xmlns:p14="http://schemas.microsoft.com/office/powerpoint/2010/main" val="2058412931"/>
+        <p14:creationId xmlns:p14="http://schemas.microsoft.com/office/powerpoint/2010/main" val="2303669461"/>
       </p:ext>
     </p:extLst>
   </p:cSld>
@@ -11230,7 +11988,7 @@
           <p:cNvPr id="2" name="title">
             <a:extLst>
               <a:ext uri="{FF2B5EF4-FFF2-40B4-BE49-F238E27FC236}">
-                <a16:creationId xmlns:a16="http://schemas.microsoft.com/office/drawing/2014/main" id="{2847A50E-2B8E-4D3D-B57E-FEDCB19524EE}"/>
+                <a16:creationId xmlns:a16="http://schemas.microsoft.com/office/drawing/2014/main" id="{99C9D356-CC35-48EF-8EF4-C5C920E2E2A7}"/>
               </a:ext>
             </a:extLst>
           </p:cNvPr>
@@ -11276,7 +12034,7 @@
           <p:cNvPr id="3" name="subtitle">
             <a:extLst>
               <a:ext uri="{FF2B5EF4-FFF2-40B4-BE49-F238E27FC236}">
-                <a16:creationId xmlns:a16="http://schemas.microsoft.com/office/drawing/2014/main" id="{6C9175D7-5D68-4444-AA0F-1E4BFEC531A3}"/>
+                <a16:creationId xmlns:a16="http://schemas.microsoft.com/office/drawing/2014/main" id="{845B6558-5A35-4044-B37C-647F8D32C19E}"/>
               </a:ext>
             </a:extLst>
           </p:cNvPr>
@@ -11322,7 +12080,7 @@
           <p:cNvPr id="4" name="evidence-table">
             <a:extLst>
               <a:ext uri="{FF2B5EF4-FFF2-40B4-BE49-F238E27FC236}">
-                <a16:creationId xmlns:a16="http://schemas.microsoft.com/office/drawing/2014/main" id="{3052CA51-2714-40F7-8EDD-2DC2425C56D2}"/>
+                <a16:creationId xmlns:a16="http://schemas.microsoft.com/office/drawing/2014/main" id="{D46FC7E4-4A23-46A0-98F9-13FC3EF0346E}"/>
               </a:ext>
             </a:extLst>
           </p:cNvPr>
@@ -11332,7 +12090,7 @@
           <p:nvPr>
             <p:extLst>
               <p:ext uri="{D42A27DB-BD31-4B8C-83A1-F6EECF244321}">
-                <p14:modId xmlns:p14="http://schemas.microsoft.com/office/powerpoint/2010/main" val="2311191746"/>
+                <p14:modId xmlns:p14="http://schemas.microsoft.com/office/powerpoint/2010/main" val="78674254"/>
               </p:ext>
             </p:extLst>
           </p:nvPr>
@@ -11351,21 +12109,21 @@
                 <a:gridCol w="2413000">
                   <a:extLst>
                     <a:ext uri="{9D8B030D-6E8A-4147-A177-3AD203B41FA5}">
-                      <a16:colId xmlns:a16="http://schemas.microsoft.com/office/drawing/2014/main" val="1926800861"/>
+                      <a16:colId xmlns:a16="http://schemas.microsoft.com/office/drawing/2014/main" val="1180489016"/>
                     </a:ext>
                   </a:extLst>
                 </a:gridCol>
                 <a:gridCol w="3810000">
                   <a:extLst>
                     <a:ext uri="{9D8B030D-6E8A-4147-A177-3AD203B41FA5}">
-                      <a16:colId xmlns:a16="http://schemas.microsoft.com/office/drawing/2014/main" val="2405607056"/>
+                      <a16:colId xmlns:a16="http://schemas.microsoft.com/office/drawing/2014/main" val="1905548848"/>
                     </a:ext>
                   </a:extLst>
                 </a:gridCol>
                 <a:gridCol w="4749800">
                   <a:extLst>
                     <a:ext uri="{9D8B030D-6E8A-4147-A177-3AD203B41FA5}">
-                      <a16:colId xmlns:a16="http://schemas.microsoft.com/office/drawing/2014/main" val="1569229041"/>
+                      <a16:colId xmlns:a16="http://schemas.microsoft.com/office/drawing/2014/main" val="2956721408"/>
                     </a:ext>
                   </a:extLst>
                 </a:gridCol>
@@ -11442,7 +12200,7 @@
                 </a:tc>
                 <a:extLst>
                   <a:ext uri="{0D108BD9-81ED-4DB2-BD59-A6C34878D82A}">
-                    <a16:rowId xmlns:a16="http://schemas.microsoft.com/office/drawing/2014/main" val="3237520488"/>
+                    <a16:rowId xmlns:a16="http://schemas.microsoft.com/office/drawing/2014/main" val="610069464"/>
                   </a:ext>
                 </a:extLst>
               </a:tr>
@@ -11595,7 +12353,7 @@
                 </a:tc>
                 <a:extLst>
                   <a:ext uri="{0D108BD9-81ED-4DB2-BD59-A6C34878D82A}">
-                    <a16:rowId xmlns:a16="http://schemas.microsoft.com/office/drawing/2014/main" val="2147025006"/>
+                    <a16:rowId xmlns:a16="http://schemas.microsoft.com/office/drawing/2014/main" val="2182364361"/>
                   </a:ext>
                 </a:extLst>
               </a:tr>
@@ -11701,7 +12459,7 @@
                 </a:tc>
                 <a:extLst>
                   <a:ext uri="{0D108BD9-81ED-4DB2-BD59-A6C34878D82A}">
-                    <a16:rowId xmlns:a16="http://schemas.microsoft.com/office/drawing/2014/main" val="2879392047"/>
+                    <a16:rowId xmlns:a16="http://schemas.microsoft.com/office/drawing/2014/main" val="3682968199"/>
                   </a:ext>
                 </a:extLst>
               </a:tr>
@@ -11794,7 +12552,7 @@
                 </a:tc>
                 <a:extLst>
                   <a:ext uri="{0D108BD9-81ED-4DB2-BD59-A6C34878D82A}">
-                    <a16:rowId xmlns:a16="http://schemas.microsoft.com/office/drawing/2014/main" val="2858910464"/>
+                    <a16:rowId xmlns:a16="http://schemas.microsoft.com/office/drawing/2014/main" val="3827776956"/>
                   </a:ext>
                 </a:extLst>
               </a:tr>
@@ -11870,7 +12628,7 @@
                 </a:tc>
                 <a:extLst>
                   <a:ext uri="{0D108BD9-81ED-4DB2-BD59-A6C34878D82A}">
-                    <a16:rowId xmlns:a16="http://schemas.microsoft.com/office/drawing/2014/main" val="875014262"/>
+                    <a16:rowId xmlns:a16="http://schemas.microsoft.com/office/drawing/2014/main" val="1091232520"/>
                   </a:ext>
                 </a:extLst>
               </a:tr>
@@ -11883,7 +12641,7 @@
           <p:cNvPr id="5" name="boundary">
             <a:extLst>
               <a:ext uri="{FF2B5EF4-FFF2-40B4-BE49-F238E27FC236}">
-                <a16:creationId xmlns:a16="http://schemas.microsoft.com/office/drawing/2014/main" id="{9A28A736-F044-46D9-8523-E77BBC8C7887}"/>
+                <a16:creationId xmlns:a16="http://schemas.microsoft.com/office/drawing/2014/main" id="{63EE4E09-E0A0-4EDA-B57E-33FB3E401389}"/>
               </a:ext>
             </a:extLst>
           </p:cNvPr>
@@ -11919,7 +12677,7 @@
                 <a:latin typeface="微软雅黑" panose="020B0503020204020204" pitchFamily="34" charset="-122"/>
                 <a:ea typeface="微软雅黑" panose="020B0503020204020204" pitchFamily="34" charset="-122"/>
               </a:rPr>
-              <a:t>课程模拟试演候选；真实项目验收延期；</a:t>
+              <a:t>模拟试演候选；</a:t>
             </a:r>
             <a:r>
               <a:rPr lang="en-US" altLang="zh-CN" sz="1100">
@@ -11939,7 +12697,27 @@
                 <a:latin typeface="微软雅黑" panose="020B0503020204020204" pitchFamily="34" charset="-122"/>
                 <a:ea typeface="微软雅黑" panose="020B0503020204020204" pitchFamily="34" charset="-122"/>
               </a:rPr>
-              <a:t>整体复核待完成</a:t>
+              <a:t>复核退回状态</a:t>
+            </a:r>
+            <a:r>
+              <a:rPr lang="en-US" altLang="zh-CN" sz="1100">
+                <a:solidFill>
+                  <a:srgbClr val="8C351E"/>
+                </a:solidFill>
+                <a:latin typeface="微软雅黑" panose="020B0503020204020204" pitchFamily="34" charset="-122"/>
+                <a:ea typeface="微软雅黑" panose="020B0503020204020204" pitchFamily="34" charset="-122"/>
+              </a:rPr>
+              <a:t>/</a:t>
+            </a:r>
+            <a:r>
+              <a:rPr lang="zh-CN" altLang="en-US" sz="1100">
+                <a:solidFill>
+                  <a:srgbClr val="8C351E"/>
+                </a:solidFill>
+                <a:latin typeface="微软雅黑" panose="020B0503020204020204" pitchFamily="34" charset="-122"/>
+                <a:ea typeface="微软雅黑" panose="020B0503020204020204" pitchFamily="34" charset="-122"/>
+              </a:rPr>
+              <a:t>来源，待定向复验；真实验收延期</a:t>
             </a:r>
           </a:p>
         </p:txBody>
@@ -11949,7 +12727,7 @@
           <p:cNvPr id="6" name="page-number">
             <a:extLst>
               <a:ext uri="{FF2B5EF4-FFF2-40B4-BE49-F238E27FC236}">
-                <a16:creationId xmlns:a16="http://schemas.microsoft.com/office/drawing/2014/main" id="{8F9B6D5E-B800-474F-9F8D-C2C35614E34F}"/>
+                <a16:creationId xmlns:a16="http://schemas.microsoft.com/office/drawing/2014/main" id="{019A9370-E730-4DAD-9C7B-17693ECB11B8}"/>
               </a:ext>
             </a:extLst>
           </p:cNvPr>
@@ -12000,7 +12778,7 @@
     </p:spTree>
     <p:extLst>
       <p:ext uri="{BB962C8B-B14F-4D97-AF65-F5344CB8AC3E}">
-        <p14:creationId xmlns:p14="http://schemas.microsoft.com/office/powerpoint/2010/main" val="2491351821"/>
+        <p14:creationId xmlns:p14="http://schemas.microsoft.com/office/powerpoint/2010/main" val="1955174877"/>
       </p:ext>
     </p:extLst>
   </p:cSld>
@@ -12040,7 +12818,7 @@
           <p:cNvPr id="2" name="title">
             <a:extLst>
               <a:ext uri="{FF2B5EF4-FFF2-40B4-BE49-F238E27FC236}">
-                <a16:creationId xmlns:a16="http://schemas.microsoft.com/office/drawing/2014/main" id="{B33858C2-E1FA-403D-B239-3B67EB6A923F}"/>
+                <a16:creationId xmlns:a16="http://schemas.microsoft.com/office/drawing/2014/main" id="{E8D443F7-2F80-4F26-B123-BF1320D41CC2}"/>
               </a:ext>
             </a:extLst>
           </p:cNvPr>
@@ -12096,7 +12874,7 @@
           <p:cNvPr id="3" name="subtitle">
             <a:extLst>
               <a:ext uri="{FF2B5EF4-FFF2-40B4-BE49-F238E27FC236}">
-                <a16:creationId xmlns:a16="http://schemas.microsoft.com/office/drawing/2014/main" id="{EA38880E-8407-4AE5-8646-53477E9F3AA9}"/>
+                <a16:creationId xmlns:a16="http://schemas.microsoft.com/office/drawing/2014/main" id="{62AAB7F6-DC99-44AF-B0C9-C3BE3AD49241}"/>
               </a:ext>
             </a:extLst>
           </p:cNvPr>
@@ -12162,7 +12940,7 @@
           <p:cNvPr id="4" name="evidence-table">
             <a:extLst>
               <a:ext uri="{FF2B5EF4-FFF2-40B4-BE49-F238E27FC236}">
-                <a16:creationId xmlns:a16="http://schemas.microsoft.com/office/drawing/2014/main" id="{4EE7D7DD-9D7B-45FF-9509-FF2FD3BB04E2}"/>
+                <a16:creationId xmlns:a16="http://schemas.microsoft.com/office/drawing/2014/main" id="{779AC7A2-3123-4B9D-B6F5-3E5C03B397F3}"/>
               </a:ext>
             </a:extLst>
           </p:cNvPr>
@@ -12172,7 +12950,7 @@
           <p:nvPr>
             <p:extLst>
               <p:ext uri="{D42A27DB-BD31-4B8C-83A1-F6EECF244321}">
-                <p14:modId xmlns:p14="http://schemas.microsoft.com/office/powerpoint/2010/main" val="278058521"/>
+                <p14:modId xmlns:p14="http://schemas.microsoft.com/office/powerpoint/2010/main" val="1249001209"/>
               </p:ext>
             </p:extLst>
           </p:nvPr>
@@ -12191,21 +12969,21 @@
                 <a:gridCol w="2413000">
                   <a:extLst>
                     <a:ext uri="{9D8B030D-6E8A-4147-A177-3AD203B41FA5}">
-                      <a16:colId xmlns:a16="http://schemas.microsoft.com/office/drawing/2014/main" val="3354640139"/>
+                      <a16:colId xmlns:a16="http://schemas.microsoft.com/office/drawing/2014/main" val="211151156"/>
                     </a:ext>
                   </a:extLst>
                 </a:gridCol>
                 <a:gridCol w="3810000">
                   <a:extLst>
                     <a:ext uri="{9D8B030D-6E8A-4147-A177-3AD203B41FA5}">
-                      <a16:colId xmlns:a16="http://schemas.microsoft.com/office/drawing/2014/main" val="167601744"/>
+                      <a16:colId xmlns:a16="http://schemas.microsoft.com/office/drawing/2014/main" val="3559242139"/>
                     </a:ext>
                   </a:extLst>
                 </a:gridCol>
                 <a:gridCol w="4749800">
                   <a:extLst>
                     <a:ext uri="{9D8B030D-6E8A-4147-A177-3AD203B41FA5}">
-                      <a16:colId xmlns:a16="http://schemas.microsoft.com/office/drawing/2014/main" val="4274135138"/>
+                      <a16:colId xmlns:a16="http://schemas.microsoft.com/office/drawing/2014/main" val="1454628572"/>
                     </a:ext>
                   </a:extLst>
                 </a:gridCol>
@@ -12282,7 +13060,7 @@
                 </a:tc>
                 <a:extLst>
                   <a:ext uri="{0D108BD9-81ED-4DB2-BD59-A6C34878D82A}">
-                    <a16:rowId xmlns:a16="http://schemas.microsoft.com/office/drawing/2014/main" val="2319753223"/>
+                    <a16:rowId xmlns:a16="http://schemas.microsoft.com/office/drawing/2014/main" val="1064790705"/>
                   </a:ext>
                 </a:extLst>
               </a:tr>
@@ -12392,7 +13170,7 @@
                 </a:tc>
                 <a:extLst>
                   <a:ext uri="{0D108BD9-81ED-4DB2-BD59-A6C34878D82A}">
-                    <a16:rowId xmlns:a16="http://schemas.microsoft.com/office/drawing/2014/main" val="4280047048"/>
+                    <a16:rowId xmlns:a16="http://schemas.microsoft.com/office/drawing/2014/main" val="3210772665"/>
                   </a:ext>
                 </a:extLst>
               </a:tr>
@@ -12482,7 +13260,7 @@
                 </a:tc>
                 <a:extLst>
                   <a:ext uri="{0D108BD9-81ED-4DB2-BD59-A6C34878D82A}">
-                    <a16:rowId xmlns:a16="http://schemas.microsoft.com/office/drawing/2014/main" val="4279983566"/>
+                    <a16:rowId xmlns:a16="http://schemas.microsoft.com/office/drawing/2014/main" val="644320370"/>
                   </a:ext>
                 </a:extLst>
               </a:tr>
@@ -12572,7 +13350,7 @@
                 </a:tc>
                 <a:extLst>
                   <a:ext uri="{0D108BD9-81ED-4DB2-BD59-A6C34878D82A}">
-                    <a16:rowId xmlns:a16="http://schemas.microsoft.com/office/drawing/2014/main" val="2483136342"/>
+                    <a16:rowId xmlns:a16="http://schemas.microsoft.com/office/drawing/2014/main" val="2836025332"/>
                   </a:ext>
                 </a:extLst>
               </a:tr>
@@ -12682,7 +13460,7 @@
                 </a:tc>
                 <a:extLst>
                   <a:ext uri="{0D108BD9-81ED-4DB2-BD59-A6C34878D82A}">
-                    <a16:rowId xmlns:a16="http://schemas.microsoft.com/office/drawing/2014/main" val="2176163257"/>
+                    <a16:rowId xmlns:a16="http://schemas.microsoft.com/office/drawing/2014/main" val="3655543377"/>
                   </a:ext>
                 </a:extLst>
               </a:tr>
@@ -12695,7 +13473,7 @@
           <p:cNvPr id="5" name="boundary">
             <a:extLst>
               <a:ext uri="{FF2B5EF4-FFF2-40B4-BE49-F238E27FC236}">
-                <a16:creationId xmlns:a16="http://schemas.microsoft.com/office/drawing/2014/main" id="{6FC9DF4A-4163-4AF1-A562-07E7E218A3D1}"/>
+                <a16:creationId xmlns:a16="http://schemas.microsoft.com/office/drawing/2014/main" id="{534C5688-4B55-4C62-BA5F-27D5953234C3}"/>
               </a:ext>
             </a:extLst>
           </p:cNvPr>
@@ -12731,7 +13509,7 @@
                 <a:latin typeface="微软雅黑" panose="020B0503020204020204" pitchFamily="34" charset="-122"/>
                 <a:ea typeface="微软雅黑" panose="020B0503020204020204" pitchFamily="34" charset="-122"/>
               </a:rPr>
-              <a:t>课程模拟试演候选；真实项目验收延期；</a:t>
+              <a:t>模拟试演候选；</a:t>
             </a:r>
             <a:r>
               <a:rPr lang="en-US" altLang="zh-CN" sz="1100">
@@ -12751,7 +13529,27 @@
                 <a:latin typeface="微软雅黑" panose="020B0503020204020204" pitchFamily="34" charset="-122"/>
                 <a:ea typeface="微软雅黑" panose="020B0503020204020204" pitchFamily="34" charset="-122"/>
               </a:rPr>
-              <a:t>整体复核待完成</a:t>
+              <a:t>复核退回状态</a:t>
+            </a:r>
+            <a:r>
+              <a:rPr lang="en-US" altLang="zh-CN" sz="1100">
+                <a:solidFill>
+                  <a:srgbClr val="8C351E"/>
+                </a:solidFill>
+                <a:latin typeface="微软雅黑" panose="020B0503020204020204" pitchFamily="34" charset="-122"/>
+                <a:ea typeface="微软雅黑" panose="020B0503020204020204" pitchFamily="34" charset="-122"/>
+              </a:rPr>
+              <a:t>/</a:t>
+            </a:r>
+            <a:r>
+              <a:rPr lang="zh-CN" altLang="en-US" sz="1100">
+                <a:solidFill>
+                  <a:srgbClr val="8C351E"/>
+                </a:solidFill>
+                <a:latin typeface="微软雅黑" panose="020B0503020204020204" pitchFamily="34" charset="-122"/>
+                <a:ea typeface="微软雅黑" panose="020B0503020204020204" pitchFamily="34" charset="-122"/>
+              </a:rPr>
+              <a:t>来源，待定向复验；真实验收延期</a:t>
             </a:r>
           </a:p>
         </p:txBody>
@@ -12761,7 +13559,7 @@
           <p:cNvPr id="6" name="page-number">
             <a:extLst>
               <a:ext uri="{FF2B5EF4-FFF2-40B4-BE49-F238E27FC236}">
-                <a16:creationId xmlns:a16="http://schemas.microsoft.com/office/drawing/2014/main" id="{561EC147-8141-447F-A1B2-31D9B09822BE}"/>
+                <a16:creationId xmlns:a16="http://schemas.microsoft.com/office/drawing/2014/main" id="{F3CA54F4-149E-489F-8919-ACA8E0F68CE3}"/>
               </a:ext>
             </a:extLst>
           </p:cNvPr>
@@ -12812,7 +13610,7 @@
     </p:spTree>
     <p:extLst>
       <p:ext uri="{BB962C8B-B14F-4D97-AF65-F5344CB8AC3E}">
-        <p14:creationId xmlns:p14="http://schemas.microsoft.com/office/powerpoint/2010/main" val="1987025023"/>
+        <p14:creationId xmlns:p14="http://schemas.microsoft.com/office/powerpoint/2010/main" val="769804229"/>
       </p:ext>
     </p:extLst>
   </p:cSld>
@@ -12852,7 +13650,7 @@
           <p:cNvPr id="2" name="title">
             <a:extLst>
               <a:ext uri="{FF2B5EF4-FFF2-40B4-BE49-F238E27FC236}">
-                <a16:creationId xmlns:a16="http://schemas.microsoft.com/office/drawing/2014/main" id="{4521A61B-4501-4E06-9935-23A0C9E43F79}"/>
+                <a16:creationId xmlns:a16="http://schemas.microsoft.com/office/drawing/2014/main" id="{282236EC-9412-4C50-B99F-BC95B67A9CDD}"/>
               </a:ext>
             </a:extLst>
           </p:cNvPr>
@@ -12898,7 +13696,7 @@
           <p:cNvPr id="3" name="subtitle">
             <a:extLst>
               <a:ext uri="{FF2B5EF4-FFF2-40B4-BE49-F238E27FC236}">
-                <a16:creationId xmlns:a16="http://schemas.microsoft.com/office/drawing/2014/main" id="{9BEF0F05-F5EF-4E1D-802E-1DCC16C4C533}"/>
+                <a16:creationId xmlns:a16="http://schemas.microsoft.com/office/drawing/2014/main" id="{ADBA508E-D6AF-4145-9B8B-67651C2CF257}"/>
               </a:ext>
             </a:extLst>
           </p:cNvPr>
@@ -12944,7 +13742,7 @@
           <p:cNvPr id="4" name="body">
             <a:extLst>
               <a:ext uri="{FF2B5EF4-FFF2-40B4-BE49-F238E27FC236}">
-                <a16:creationId xmlns:a16="http://schemas.microsoft.com/office/drawing/2014/main" id="{71BF4676-376E-49D5-B2AE-AE3737E12465}"/>
+                <a16:creationId xmlns:a16="http://schemas.microsoft.com/office/drawing/2014/main" id="{8DEF19DA-8295-411D-8A3A-32FA7DD638C9}"/>
               </a:ext>
             </a:extLst>
           </p:cNvPr>
@@ -13031,7 +13829,7 @@
                 <a:latin typeface="微软雅黑" panose="020B0503020204020204" pitchFamily="34" charset="-122"/>
                 <a:ea typeface="微软雅黑" panose="020B0503020204020204" pitchFamily="34" charset="-122"/>
               </a:rPr>
-              <a:t>：首版索引、</a:t>
+              <a:t>：最终审计包，</a:t>
             </a:r>
             <a:r>
               <a:rPr lang="en-US" altLang="zh-CN" sz="2300">
@@ -13041,7 +13839,7 @@
                 <a:latin typeface="微软雅黑" panose="020B0503020204020204" pitchFamily="34" charset="-122"/>
                 <a:ea typeface="微软雅黑" panose="020B0503020204020204" pitchFamily="34" charset="-122"/>
               </a:rPr>
-              <a:t>RTM</a:t>
+              <a:t>B/A</a:t>
             </a:r>
             <a:r>
               <a:rPr lang="zh-CN" altLang="en-US" sz="2300">
@@ -13051,27 +13849,7 @@
                 <a:latin typeface="微软雅黑" panose="020B0503020204020204" pitchFamily="34" charset="-122"/>
                 <a:ea typeface="微软雅黑" panose="020B0503020204020204" pitchFamily="34" charset="-122"/>
               </a:rPr>
-              <a:t>增量及</a:t>
-            </a:r>
-            <a:r>
-              <a:rPr lang="en-US" altLang="zh-CN" sz="2300">
-                <a:solidFill>
-                  <a:srgbClr val="172E3A"/>
-                </a:solidFill>
-                <a:latin typeface="微软雅黑" panose="020B0503020204020204" pitchFamily="34" charset="-122"/>
-                <a:ea typeface="微软雅黑" panose="020B0503020204020204" pitchFamily="34" charset="-122"/>
-              </a:rPr>
-              <a:t>B</a:t>
-            </a:r>
-            <a:r>
-              <a:rPr lang="zh-CN" altLang="en-US" sz="2300">
-                <a:solidFill>
-                  <a:srgbClr val="172E3A"/>
-                </a:solidFill>
-                <a:latin typeface="微软雅黑" panose="020B0503020204020204" pitchFamily="34" charset="-122"/>
-                <a:ea typeface="微软雅黑" panose="020B0503020204020204" pitchFamily="34" charset="-122"/>
-              </a:rPr>
-              <a:t>复核</a:t>
+              <a:t>复核接受</a:t>
             </a:r>
           </a:p>
           <a:p>
@@ -13153,7 +13931,7 @@
           <p:cNvPr id="5" name="boundary">
             <a:extLst>
               <a:ext uri="{FF2B5EF4-FFF2-40B4-BE49-F238E27FC236}">
-                <a16:creationId xmlns:a16="http://schemas.microsoft.com/office/drawing/2014/main" id="{2DEE44C3-6BB9-4DDE-852C-064A5162A51C}"/>
+                <a16:creationId xmlns:a16="http://schemas.microsoft.com/office/drawing/2014/main" id="{BF67B190-E617-4DA7-A1D8-D1A8718AB6FF}"/>
               </a:ext>
             </a:extLst>
           </p:cNvPr>
@@ -13189,7 +13967,7 @@
                 <a:latin typeface="微软雅黑" panose="020B0503020204020204" pitchFamily="34" charset="-122"/>
                 <a:ea typeface="微软雅黑" panose="020B0503020204020204" pitchFamily="34" charset="-122"/>
               </a:rPr>
-              <a:t>课程模拟试演候选；真实项目验收延期；</a:t>
+              <a:t>模拟试演候选；</a:t>
             </a:r>
             <a:r>
               <a:rPr lang="en-US" altLang="zh-CN" sz="1100">
@@ -13209,7 +13987,27 @@
                 <a:latin typeface="微软雅黑" panose="020B0503020204020204" pitchFamily="34" charset="-122"/>
                 <a:ea typeface="微软雅黑" panose="020B0503020204020204" pitchFamily="34" charset="-122"/>
               </a:rPr>
-              <a:t>整体复核待完成</a:t>
+              <a:t>复核退回状态</a:t>
+            </a:r>
+            <a:r>
+              <a:rPr lang="en-US" altLang="zh-CN" sz="1100">
+                <a:solidFill>
+                  <a:srgbClr val="8C351E"/>
+                </a:solidFill>
+                <a:latin typeface="微软雅黑" panose="020B0503020204020204" pitchFamily="34" charset="-122"/>
+                <a:ea typeface="微软雅黑" panose="020B0503020204020204" pitchFamily="34" charset="-122"/>
+              </a:rPr>
+              <a:t>/</a:t>
+            </a:r>
+            <a:r>
+              <a:rPr lang="zh-CN" altLang="en-US" sz="1100">
+                <a:solidFill>
+                  <a:srgbClr val="8C351E"/>
+                </a:solidFill>
+                <a:latin typeface="微软雅黑" panose="020B0503020204020204" pitchFamily="34" charset="-122"/>
+                <a:ea typeface="微软雅黑" panose="020B0503020204020204" pitchFamily="34" charset="-122"/>
+              </a:rPr>
+              <a:t>来源，待定向复验；真实验收延期</a:t>
             </a:r>
           </a:p>
         </p:txBody>
@@ -13219,7 +14017,7 @@
           <p:cNvPr id="6" name="page-number">
             <a:extLst>
               <a:ext uri="{FF2B5EF4-FFF2-40B4-BE49-F238E27FC236}">
-                <a16:creationId xmlns:a16="http://schemas.microsoft.com/office/drawing/2014/main" id="{3A98A5E2-B28F-46B3-8F83-98C379DADBC3}"/>
+                <a16:creationId xmlns:a16="http://schemas.microsoft.com/office/drawing/2014/main" id="{F76108FB-0803-4E24-B983-5951C90EE258}"/>
               </a:ext>
             </a:extLst>
           </p:cNvPr>
@@ -13270,7 +14068,7 @@
     </p:spTree>
     <p:extLst>
       <p:ext uri="{BB962C8B-B14F-4D97-AF65-F5344CB8AC3E}">
-        <p14:creationId xmlns:p14="http://schemas.microsoft.com/office/powerpoint/2010/main" val="105052501"/>
+        <p14:creationId xmlns:p14="http://schemas.microsoft.com/office/powerpoint/2010/main" val="1976126897"/>
       </p:ext>
     </p:extLst>
   </p:cSld>
@@ -13310,7 +14108,7 @@
           <p:cNvPr id="2" name="title">
             <a:extLst>
               <a:ext uri="{FF2B5EF4-FFF2-40B4-BE49-F238E27FC236}">
-                <a16:creationId xmlns:a16="http://schemas.microsoft.com/office/drawing/2014/main" id="{F2A2D57B-D00B-4224-BE44-134FB7EDF257}"/>
+                <a16:creationId xmlns:a16="http://schemas.microsoft.com/office/drawing/2014/main" id="{CDBF4D59-3F98-40E8-A8D4-98B52ED58E9E}"/>
               </a:ext>
             </a:extLst>
           </p:cNvPr>
@@ -13356,7 +14154,7 @@
           <p:cNvPr id="3" name="subtitle">
             <a:extLst>
               <a:ext uri="{FF2B5EF4-FFF2-40B4-BE49-F238E27FC236}">
-                <a16:creationId xmlns:a16="http://schemas.microsoft.com/office/drawing/2014/main" id="{A82E5B34-D124-4E4A-A09A-83ECC7E8622B}"/>
+                <a16:creationId xmlns:a16="http://schemas.microsoft.com/office/drawing/2014/main" id="{7380A2B9-4F5A-4E67-8CB6-7A9E28F2380F}"/>
               </a:ext>
             </a:extLst>
           </p:cNvPr>
@@ -13402,7 +14200,7 @@
           <p:cNvPr id="4" name="body">
             <a:extLst>
               <a:ext uri="{FF2B5EF4-FFF2-40B4-BE49-F238E27FC236}">
-                <a16:creationId xmlns:a16="http://schemas.microsoft.com/office/drawing/2014/main" id="{A6727EC3-D7D6-496D-B1F7-8213B5F81F4C}"/>
+                <a16:creationId xmlns:a16="http://schemas.microsoft.com/office/drawing/2014/main" id="{B8B31E68-0F44-43E3-BB7D-3C88B17EFDB6}"/>
               </a:ext>
             </a:extLst>
           </p:cNvPr>
@@ -13541,7 +14339,7 @@
           <p:cNvPr id="5" name="boundary">
             <a:extLst>
               <a:ext uri="{FF2B5EF4-FFF2-40B4-BE49-F238E27FC236}">
-                <a16:creationId xmlns:a16="http://schemas.microsoft.com/office/drawing/2014/main" id="{F04D6318-225D-4C4B-9787-70762FA4E058}"/>
+                <a16:creationId xmlns:a16="http://schemas.microsoft.com/office/drawing/2014/main" id="{6D328301-E79F-43F9-B796-C52427C7C45C}"/>
               </a:ext>
             </a:extLst>
           </p:cNvPr>
@@ -13577,7 +14375,7 @@
                 <a:latin typeface="微软雅黑" panose="020B0503020204020204" pitchFamily="34" charset="-122"/>
                 <a:ea typeface="微软雅黑" panose="020B0503020204020204" pitchFamily="34" charset="-122"/>
               </a:rPr>
-              <a:t>课程模拟试演候选；真实项目验收延期；</a:t>
+              <a:t>模拟试演候选；</a:t>
             </a:r>
             <a:r>
               <a:rPr lang="en-US" altLang="zh-CN" sz="1100">
@@ -13597,7 +14395,27 @@
                 <a:latin typeface="微软雅黑" panose="020B0503020204020204" pitchFamily="34" charset="-122"/>
                 <a:ea typeface="微软雅黑" panose="020B0503020204020204" pitchFamily="34" charset="-122"/>
               </a:rPr>
-              <a:t>整体复核待完成</a:t>
+              <a:t>复核退回状态</a:t>
+            </a:r>
+            <a:r>
+              <a:rPr lang="en-US" altLang="zh-CN" sz="1100">
+                <a:solidFill>
+                  <a:srgbClr val="8C351E"/>
+                </a:solidFill>
+                <a:latin typeface="微软雅黑" panose="020B0503020204020204" pitchFamily="34" charset="-122"/>
+                <a:ea typeface="微软雅黑" panose="020B0503020204020204" pitchFamily="34" charset="-122"/>
+              </a:rPr>
+              <a:t>/</a:t>
+            </a:r>
+            <a:r>
+              <a:rPr lang="zh-CN" altLang="en-US" sz="1100">
+                <a:solidFill>
+                  <a:srgbClr val="8C351E"/>
+                </a:solidFill>
+                <a:latin typeface="微软雅黑" panose="020B0503020204020204" pitchFamily="34" charset="-122"/>
+                <a:ea typeface="微软雅黑" panose="020B0503020204020204" pitchFamily="34" charset="-122"/>
+              </a:rPr>
+              <a:t>来源，待定向复验；真实验收延期</a:t>
             </a:r>
           </a:p>
         </p:txBody>
@@ -13607,7 +14425,7 @@
           <p:cNvPr id="6" name="page-number">
             <a:extLst>
               <a:ext uri="{FF2B5EF4-FFF2-40B4-BE49-F238E27FC236}">
-                <a16:creationId xmlns:a16="http://schemas.microsoft.com/office/drawing/2014/main" id="{1FAD23FC-F0B2-4CB3-97E7-FE71504C4726}"/>
+                <a16:creationId xmlns:a16="http://schemas.microsoft.com/office/drawing/2014/main" id="{71C8B8AF-FF6B-473D-B740-5DB87B0F3009}"/>
               </a:ext>
             </a:extLst>
           </p:cNvPr>
@@ -13658,7 +14476,7 @@
     </p:spTree>
     <p:extLst>
       <p:ext uri="{BB962C8B-B14F-4D97-AF65-F5344CB8AC3E}">
-        <p14:creationId xmlns:p14="http://schemas.microsoft.com/office/powerpoint/2010/main" val="1898497405"/>
+        <p14:creationId xmlns:p14="http://schemas.microsoft.com/office/powerpoint/2010/main" val="2165060761"/>
       </p:ext>
     </p:extLst>
   </p:cSld>
@@ -13698,7 +14516,7 @@
           <p:cNvPr id="2" name="title">
             <a:extLst>
               <a:ext uri="{FF2B5EF4-FFF2-40B4-BE49-F238E27FC236}">
-                <a16:creationId xmlns:a16="http://schemas.microsoft.com/office/drawing/2014/main" id="{0400D9DB-C91C-49BB-9964-4984BCB06F57}"/>
+                <a16:creationId xmlns:a16="http://schemas.microsoft.com/office/drawing/2014/main" id="{09E7EBB8-2FAE-4BC4-B5CA-14CBEB2926A0}"/>
               </a:ext>
             </a:extLst>
           </p:cNvPr>
@@ -13744,7 +14562,7 @@
           <p:cNvPr id="3" name="subtitle">
             <a:extLst>
               <a:ext uri="{FF2B5EF4-FFF2-40B4-BE49-F238E27FC236}">
-                <a16:creationId xmlns:a16="http://schemas.microsoft.com/office/drawing/2014/main" id="{E5AF8F46-593B-4978-8682-7819E93E117D}"/>
+                <a16:creationId xmlns:a16="http://schemas.microsoft.com/office/drawing/2014/main" id="{0FDC7465-3496-4B0A-8D40-082F91FD4924}"/>
               </a:ext>
             </a:extLst>
           </p:cNvPr>
@@ -13817,7 +14635,7 @@
           <p:cNvPr id="5" name="actual-run-screenshot">
             <a:extLst>
               <a:ext uri="{FF2B5EF4-FFF2-40B4-BE49-F238E27FC236}">
-                <a16:creationId xmlns:a16="http://schemas.microsoft.com/office/drawing/2014/main" id="{D75E7CAC-5C0E-45C2-8FDB-8C4CF59D7B1D}"/>
+                <a16:creationId xmlns:a16="http://schemas.microsoft.com/office/drawing/2014/main" id="{9EE0C6F7-2670-4179-9B89-B9117F4A7970}"/>
               </a:ext>
             </a:extLst>
           </p:cNvPr>
@@ -13853,7 +14671,7 @@
           <p:cNvPr id="6" name="image-source">
             <a:extLst>
               <a:ext uri="{FF2B5EF4-FFF2-40B4-BE49-F238E27FC236}">
-                <a16:creationId xmlns:a16="http://schemas.microsoft.com/office/drawing/2014/main" id="{5D9DBC3B-6685-4535-A848-52C6F105B6C5}"/>
+                <a16:creationId xmlns:a16="http://schemas.microsoft.com/office/drawing/2014/main" id="{EF767A4B-D007-4802-9487-E701FC5B129C}"/>
               </a:ext>
             </a:extLst>
           </p:cNvPr>
@@ -13916,7 +14734,7 @@
           <p:cNvPr id="7" name="evidence-observations">
             <a:extLst>
               <a:ext uri="{FF2B5EF4-FFF2-40B4-BE49-F238E27FC236}">
-                <a16:creationId xmlns:a16="http://schemas.microsoft.com/office/drawing/2014/main" id="{20106C6D-731F-4654-93A2-F3029BDCEAF2}"/>
+                <a16:creationId xmlns:a16="http://schemas.microsoft.com/office/drawing/2014/main" id="{1365F948-7068-4567-80A3-E94FF5DD2FF4}"/>
               </a:ext>
             </a:extLst>
           </p:cNvPr>
@@ -14075,7 +14893,7 @@
           <p:cNvPr id="8" name="boundary">
             <a:extLst>
               <a:ext uri="{FF2B5EF4-FFF2-40B4-BE49-F238E27FC236}">
-                <a16:creationId xmlns:a16="http://schemas.microsoft.com/office/drawing/2014/main" id="{F35EEF54-EC63-4D15-B862-018DCFB2DECB}"/>
+                <a16:creationId xmlns:a16="http://schemas.microsoft.com/office/drawing/2014/main" id="{47BBC265-0388-40FE-BBEE-C3D0B0E4C3D8}"/>
               </a:ext>
             </a:extLst>
           </p:cNvPr>
@@ -14111,7 +14929,7 @@
                 <a:latin typeface="微软雅黑" panose="020B0503020204020204" pitchFamily="34" charset="-122"/>
                 <a:ea typeface="微软雅黑" panose="020B0503020204020204" pitchFamily="34" charset="-122"/>
               </a:rPr>
-              <a:t>课程模拟试演候选；真实项目验收延期；</a:t>
+              <a:t>模拟试演候选；</a:t>
             </a:r>
             <a:r>
               <a:rPr lang="en-US" altLang="zh-CN" sz="1100">
@@ -14131,7 +14949,27 @@
                 <a:latin typeface="微软雅黑" panose="020B0503020204020204" pitchFamily="34" charset="-122"/>
                 <a:ea typeface="微软雅黑" panose="020B0503020204020204" pitchFamily="34" charset="-122"/>
               </a:rPr>
-              <a:t>整体复核待完成</a:t>
+              <a:t>复核退回状态</a:t>
+            </a:r>
+            <a:r>
+              <a:rPr lang="en-US" altLang="zh-CN" sz="1100">
+                <a:solidFill>
+                  <a:srgbClr val="8C351E"/>
+                </a:solidFill>
+                <a:latin typeface="微软雅黑" panose="020B0503020204020204" pitchFamily="34" charset="-122"/>
+                <a:ea typeface="微软雅黑" panose="020B0503020204020204" pitchFamily="34" charset="-122"/>
+              </a:rPr>
+              <a:t>/</a:t>
+            </a:r>
+            <a:r>
+              <a:rPr lang="zh-CN" altLang="en-US" sz="1100">
+                <a:solidFill>
+                  <a:srgbClr val="8C351E"/>
+                </a:solidFill>
+                <a:latin typeface="微软雅黑" panose="020B0503020204020204" pitchFamily="34" charset="-122"/>
+                <a:ea typeface="微软雅黑" panose="020B0503020204020204" pitchFamily="34" charset="-122"/>
+              </a:rPr>
+              <a:t>来源，待定向复验；真实验收延期</a:t>
             </a:r>
           </a:p>
         </p:txBody>
@@ -14141,7 +14979,7 @@
           <p:cNvPr id="9" name="page-number">
             <a:extLst>
               <a:ext uri="{FF2B5EF4-FFF2-40B4-BE49-F238E27FC236}">
-                <a16:creationId xmlns:a16="http://schemas.microsoft.com/office/drawing/2014/main" id="{2FF33429-9135-4A9C-951B-8166551B0B42}"/>
+                <a16:creationId xmlns:a16="http://schemas.microsoft.com/office/drawing/2014/main" id="{B9DB16C3-3563-4C78-AC56-29BC53843528}"/>
               </a:ext>
             </a:extLst>
           </p:cNvPr>
@@ -14192,7 +15030,7 @@
     </p:spTree>
     <p:extLst>
       <p:ext uri="{BB962C8B-B14F-4D97-AF65-F5344CB8AC3E}">
-        <p14:creationId xmlns:p14="http://schemas.microsoft.com/office/powerpoint/2010/main" val="2603946856"/>
+        <p14:creationId xmlns:p14="http://schemas.microsoft.com/office/powerpoint/2010/main" val="323250359"/>
       </p:ext>
     </p:extLst>
   </p:cSld>
@@ -14232,7 +15070,7 @@
           <p:cNvPr id="2" name="title">
             <a:extLst>
               <a:ext uri="{FF2B5EF4-FFF2-40B4-BE49-F238E27FC236}">
-                <a16:creationId xmlns:a16="http://schemas.microsoft.com/office/drawing/2014/main" id="{28658D8F-F7C5-4C5E-8AE5-2F884329552F}"/>
+                <a16:creationId xmlns:a16="http://schemas.microsoft.com/office/drawing/2014/main" id="{897AC938-8E2B-439B-A6B6-3E738B2EABDB}"/>
               </a:ext>
             </a:extLst>
           </p:cNvPr>
@@ -14288,7 +15126,7 @@
           <p:cNvPr id="3" name="subtitle">
             <a:extLst>
               <a:ext uri="{FF2B5EF4-FFF2-40B4-BE49-F238E27FC236}">
-                <a16:creationId xmlns:a16="http://schemas.microsoft.com/office/drawing/2014/main" id="{8EB19D83-6D72-445E-B5A6-0C279135D7E9}"/>
+                <a16:creationId xmlns:a16="http://schemas.microsoft.com/office/drawing/2014/main" id="{3691F201-0B6B-4667-9655-11F53882A56A}"/>
               </a:ext>
             </a:extLst>
           </p:cNvPr>
@@ -14351,7 +15189,7 @@
           <p:cNvPr id="5" name="actual-run-screenshot">
             <a:extLst>
               <a:ext uri="{FF2B5EF4-FFF2-40B4-BE49-F238E27FC236}">
-                <a16:creationId xmlns:a16="http://schemas.microsoft.com/office/drawing/2014/main" id="{A4BFE272-B57A-463B-AADB-62E8DBEEC7EC}"/>
+                <a16:creationId xmlns:a16="http://schemas.microsoft.com/office/drawing/2014/main" id="{BD3FCEC9-D254-4826-BCF4-000BAC3C3A1A}"/>
               </a:ext>
             </a:extLst>
           </p:cNvPr>
@@ -14387,7 +15225,7 @@
           <p:cNvPr id="6" name="image-source">
             <a:extLst>
               <a:ext uri="{FF2B5EF4-FFF2-40B4-BE49-F238E27FC236}">
-                <a16:creationId xmlns:a16="http://schemas.microsoft.com/office/drawing/2014/main" id="{1C4F4752-C30C-4E68-B747-DB8ED08A4658}"/>
+                <a16:creationId xmlns:a16="http://schemas.microsoft.com/office/drawing/2014/main" id="{7CA6C258-169D-4364-B827-0832488D7DD0}"/>
               </a:ext>
             </a:extLst>
           </p:cNvPr>
@@ -14450,7 +15288,7 @@
           <p:cNvPr id="7" name="evidence-observations">
             <a:extLst>
               <a:ext uri="{FF2B5EF4-FFF2-40B4-BE49-F238E27FC236}">
-                <a16:creationId xmlns:a16="http://schemas.microsoft.com/office/drawing/2014/main" id="{E67AA32C-56C9-441B-9B6D-D9C6C40AC9CD}"/>
+                <a16:creationId xmlns:a16="http://schemas.microsoft.com/office/drawing/2014/main" id="{AD1986DA-0AB6-4B2D-9D9F-17A8C58E9C54}"/>
               </a:ext>
             </a:extLst>
           </p:cNvPr>
@@ -14659,7 +15497,7 @@
                 <a:latin typeface="微软雅黑" panose="020B0503020204020204" pitchFamily="34" charset="-122"/>
                 <a:ea typeface="微软雅黑" panose="020B0503020204020204" pitchFamily="34" charset="-122"/>
               </a:rPr>
-              <a:t>，待</a:t>
+              <a:t>已由</a:t>
             </a:r>
             <a:r>
               <a:rPr lang="en-US" altLang="zh-CN" sz="1900">
@@ -14689,7 +15527,7 @@
           <p:cNvPr id="8" name="boundary">
             <a:extLst>
               <a:ext uri="{FF2B5EF4-FFF2-40B4-BE49-F238E27FC236}">
-                <a16:creationId xmlns:a16="http://schemas.microsoft.com/office/drawing/2014/main" id="{B24465F1-BB7D-4FB8-8EC6-DECE0F775EC0}"/>
+                <a16:creationId xmlns:a16="http://schemas.microsoft.com/office/drawing/2014/main" id="{B618F218-1F34-40D8-9779-F5860B1EDDAE}"/>
               </a:ext>
             </a:extLst>
           </p:cNvPr>
@@ -14725,7 +15563,7 @@
                 <a:latin typeface="微软雅黑" panose="020B0503020204020204" pitchFamily="34" charset="-122"/>
                 <a:ea typeface="微软雅黑" panose="020B0503020204020204" pitchFamily="34" charset="-122"/>
               </a:rPr>
-              <a:t>课程模拟试演候选；真实项目验收延期；</a:t>
+              <a:t>模拟试演候选；</a:t>
             </a:r>
             <a:r>
               <a:rPr lang="en-US" altLang="zh-CN" sz="1100">
@@ -14745,7 +15583,27 @@
                 <a:latin typeface="微软雅黑" panose="020B0503020204020204" pitchFamily="34" charset="-122"/>
                 <a:ea typeface="微软雅黑" panose="020B0503020204020204" pitchFamily="34" charset="-122"/>
               </a:rPr>
-              <a:t>整体复核待完成</a:t>
+              <a:t>复核退回状态</a:t>
+            </a:r>
+            <a:r>
+              <a:rPr lang="en-US" altLang="zh-CN" sz="1100">
+                <a:solidFill>
+                  <a:srgbClr val="8C351E"/>
+                </a:solidFill>
+                <a:latin typeface="微软雅黑" panose="020B0503020204020204" pitchFamily="34" charset="-122"/>
+                <a:ea typeface="微软雅黑" panose="020B0503020204020204" pitchFamily="34" charset="-122"/>
+              </a:rPr>
+              <a:t>/</a:t>
+            </a:r>
+            <a:r>
+              <a:rPr lang="zh-CN" altLang="en-US" sz="1100">
+                <a:solidFill>
+                  <a:srgbClr val="8C351E"/>
+                </a:solidFill>
+                <a:latin typeface="微软雅黑" panose="020B0503020204020204" pitchFamily="34" charset="-122"/>
+                <a:ea typeface="微软雅黑" panose="020B0503020204020204" pitchFamily="34" charset="-122"/>
+              </a:rPr>
+              <a:t>来源，待定向复验；真实验收延期</a:t>
             </a:r>
           </a:p>
         </p:txBody>
@@ -14755,7 +15613,7 @@
           <p:cNvPr id="9" name="page-number">
             <a:extLst>
               <a:ext uri="{FF2B5EF4-FFF2-40B4-BE49-F238E27FC236}">
-                <a16:creationId xmlns:a16="http://schemas.microsoft.com/office/drawing/2014/main" id="{B77DB371-08C2-4B97-BD02-813720A0F6A4}"/>
+                <a16:creationId xmlns:a16="http://schemas.microsoft.com/office/drawing/2014/main" id="{4C21798E-60F4-4D47-A0B9-D7E6AA56A44B}"/>
               </a:ext>
             </a:extLst>
           </p:cNvPr>
@@ -14806,7 +15664,7 @@
     </p:spTree>
     <p:extLst>
       <p:ext uri="{BB962C8B-B14F-4D97-AF65-F5344CB8AC3E}">
-        <p14:creationId xmlns:p14="http://schemas.microsoft.com/office/powerpoint/2010/main" val="36157004"/>
+        <p14:creationId xmlns:p14="http://schemas.microsoft.com/office/powerpoint/2010/main" val="3907160978"/>
       </p:ext>
     </p:extLst>
   </p:cSld>

</xml_diff>